<commit_message>
BFTP deck: tighten slide 6 subtitle overflow risks
Heuristic overflow analysis (width × height × characters-per-line × line-
count) flagged two of the six platform-shape subtitle boxes on slide 6
as likely to wrap awkwardly:

  Yggdrasil ERP subtitle  62 chars in a ~41-char budget box
  Norn subtitle           54 chars in the same budget

The other four subtitles (Ratatosk / Ragnarok / Bifrost / Jormungandr)
land within budget. Tightened the two outliers to match:

  Yggdrasil: "Manufacturing ERP with OPE governance — 323 tables,
              10 modules" → "ERP — 323 tables, 10 modules, OPE governance"
  Norn:      "Contract document intelligence — OPE plugin on roadmap"
              → "Contract document pilot — OPE plugin roadmap"

OPE-inside-Yggdrasil framing preserved. All six subtitles now read at
similar visual weight.

Co-Authored-By: Claude Opus 4.7 (1M context) <noreply@anthropic.com>
</commit_message>
<xml_diff>
--- a/business/btfp/mimir_labs_investor_deck_rewrite_clean.pptx
+++ b/business/btfp/mimir_labs_investor_deck_rewrite_clean.pptx
@@ -15392,7 +15392,7 @@
                 <a:ea typeface="Aptos" pitchFamily="34" charset="-122"/>
                 <a:cs typeface="Aptos" pitchFamily="34" charset="-120"/>
               </a:rPr>
-              <a:t>Manufacturing ERP with OPE governance — 323 tables, 10 modules</a:t>
+              <a:t>ERP — 323 tables, 10 modules, OPE governance</a:t>
             </a:r>
             <a:endParaRPr lang="en-US" sz="880" dirty="0"/>
           </a:p>
@@ -15664,7 +15664,7 @@
                 <a:ea typeface="Aptos" pitchFamily="34" charset="-122"/>
                 <a:cs typeface="Aptos" pitchFamily="34" charset="-120"/>
               </a:rPr>
-              <a:t>Contract document intelligence — OPE plugin on roadmap</a:t>
+              <a:t>Contract document pilot — OPE plugin roadmap</a:t>
             </a:r>
             <a:endParaRPr lang="en-US" sz="880" dirty="0"/>
           </a:p>

</xml_diff>

<commit_message>
BFTP deck: 18pt body floor + strip decorative arcs/lines + fix slide 14 hierarchy
Peachscore typography pass:
- 272 body text runs lifted to 18pt minimum across all 14 slides
- Chrome (page numbers, footer chips, product chips on slide 4) preserved
- Slide 14 (Closing): "WE'VE ALREADY BUILT IT." moved into the 35pt headline slot;
  tagline demoted to small chrome (was inverted previously)
- 28 decorative top-right arcs removed (2 per slide)
- 14 decorative top-right diagonal lines removed (1 per slide, stroke 12700)
- Functional lines preserved: slide 4 platform-shape leader lines, slide 9
  differentiation-table dividers

Validation: 14 slides, sldIdLst + app.xml in sync, zip integrity OK.

Co-Authored-By: Claude Opus 4.7 (1M context) <noreply@anthropic.com>
</commit_message>
<xml_diff>
--- a/business/btfp/mimir_labs_investor_deck_rewrite_clean.pptx
+++ b/business/btfp/mimir_labs_investor_deck_rewrite_clean.pptx
@@ -1648,89 +1648,6 @@
       </p:sp>
       <p:sp>
         <p:nvSpPr>
-          <p:cNvPr id="4" name="Shape 2"/>
-          <p:cNvSpPr/>
-          <p:nvPr/>
-        </p:nvSpPr>
-        <p:spPr>
-          <a:xfrm>
-            <a:off x="8275320" y="137160"/>
-            <a:ext cx="3611880" cy="3611880"/>
-          </a:xfrm>
-          <a:prstGeom prst="arc">
-            <a:avLst/>
-          </a:prstGeom>
-          <a:solidFill>
-            <a:srgbClr val="08131F">
-              <a:alpha val="0"/>
-            </a:srgbClr>
-          </a:solidFill>
-          <a:ln w="13970">
-            <a:solidFill>
-              <a:srgbClr val="123D5A">
-                <a:alpha val="65000"/>
-              </a:srgbClr>
-            </a:solidFill>
-            <a:prstDash val="solid"/>
-          </a:ln>
-        </p:spPr>
-      </p:sp>
-      <p:sp>
-        <p:nvSpPr>
-          <p:cNvPr id="5" name="Shape 3"/>
-          <p:cNvSpPr/>
-          <p:nvPr/>
-        </p:nvSpPr>
-        <p:spPr>
-          <a:xfrm>
-            <a:off x="8641080" y="475488"/>
-            <a:ext cx="2834640" cy="2834640"/>
-          </a:xfrm>
-          <a:prstGeom prst="arc">
-            <a:avLst/>
-          </a:prstGeom>
-          <a:solidFill>
-            <a:srgbClr val="08131F">
-              <a:alpha val="0"/>
-            </a:srgbClr>
-          </a:solidFill>
-          <a:ln w="10160">
-            <a:solidFill>
-              <a:srgbClr val="2DE2D1">
-                <a:alpha val="28000"/>
-              </a:srgbClr>
-            </a:solidFill>
-            <a:prstDash val="solid"/>
-          </a:ln>
-        </p:spPr>
-      </p:sp>
-      <p:sp>
-        <p:nvSpPr>
-          <p:cNvPr id="6" name="Shape 4"/>
-          <p:cNvSpPr/>
-          <p:nvPr/>
-        </p:nvSpPr>
-        <p:spPr>
-          <a:xfrm>
-            <a:off x="8138160" y="731520"/>
-            <a:ext cx="3291840" cy="0"/>
-          </a:xfrm>
-          <a:prstGeom prst="line">
-            <a:avLst/>
-          </a:prstGeom>
-          <a:noFill/>
-          <a:ln w="12700">
-            <a:solidFill>
-              <a:srgbClr val="123D5A">
-                <a:alpha val="55000"/>
-              </a:srgbClr>
-            </a:solidFill>
-            <a:prstDash val="solid"/>
-          </a:ln>
-        </p:spPr>
-      </p:sp>
-      <p:sp>
-        <p:nvSpPr>
           <p:cNvPr id="7" name="Shape 5"/>
           <p:cNvSpPr/>
           <p:nvPr/>
@@ -1910,7 +1827,7 @@
               <a:buNone/>
             </a:pPr>
             <a:r>
-              <a:rPr lang="en-US" sz="1600" dirty="0">
+              <a:rPr lang="en-US" sz="1800" dirty="0">
                 <a:solidFill>
                   <a:srgbClr val="A9BED0"/>
                 </a:solidFill>
@@ -1920,7 +1837,7 @@
               </a:rPr>
               <a:t>Ratatosk discovers where enterprise meaning breaks. Yggdrasil ERP turns governed meaning into enforceable operational state.</a:t>
             </a:r>
-            <a:endParaRPr lang="en-US" sz="1600" dirty="0"/>
+            <a:endParaRPr lang="en-US" sz="1800" dirty="0"/>
           </a:p>
         </p:txBody>
       </p:sp>
@@ -2019,7 +1936,7 @@
               <a:buNone/>
             </a:pPr>
             <a:r>
-              <a:rPr lang="en-US" sz="1150" dirty="0">
+              <a:rPr lang="en-US" sz="1800" dirty="0">
                 <a:solidFill>
                   <a:srgbClr val="A9BED0"/>
                 </a:solidFill>
@@ -2029,7 +1946,7 @@
               </a:rPr>
               <a:t>Pre-seed investor materials — Mimir Labs LLC, South Central Pennsylvania.</a:t>
             </a:r>
-            <a:endParaRPr lang="en-US" sz="1150" dirty="0"/>
+            <a:endParaRPr lang="en-US" sz="1800" dirty="0"/>
           </a:p>
         </p:txBody>
       </p:sp>
@@ -2203,89 +2120,6 @@
       </p:sp>
       <p:sp>
         <p:nvSpPr>
-          <p:cNvPr id="4" name="Shape 2"/>
-          <p:cNvSpPr/>
-          <p:nvPr/>
-        </p:nvSpPr>
-        <p:spPr>
-          <a:xfrm>
-            <a:off x="8275320" y="137160"/>
-            <a:ext cx="3611880" cy="3611880"/>
-          </a:xfrm>
-          <a:prstGeom prst="arc">
-            <a:avLst/>
-          </a:prstGeom>
-          <a:solidFill>
-            <a:srgbClr val="08131F">
-              <a:alpha val="0"/>
-            </a:srgbClr>
-          </a:solidFill>
-          <a:ln w="13970">
-            <a:solidFill>
-              <a:srgbClr val="123D5A">
-                <a:alpha val="65000"/>
-              </a:srgbClr>
-            </a:solidFill>
-            <a:prstDash val="solid"/>
-          </a:ln>
-        </p:spPr>
-      </p:sp>
-      <p:sp>
-        <p:nvSpPr>
-          <p:cNvPr id="5" name="Shape 3"/>
-          <p:cNvSpPr/>
-          <p:nvPr/>
-        </p:nvSpPr>
-        <p:spPr>
-          <a:xfrm>
-            <a:off x="8641080" y="475488"/>
-            <a:ext cx="2834640" cy="2834640"/>
-          </a:xfrm>
-          <a:prstGeom prst="arc">
-            <a:avLst/>
-          </a:prstGeom>
-          <a:solidFill>
-            <a:srgbClr val="08131F">
-              <a:alpha val="0"/>
-            </a:srgbClr>
-          </a:solidFill>
-          <a:ln w="10160">
-            <a:solidFill>
-              <a:srgbClr val="2DE2D1">
-                <a:alpha val="28000"/>
-              </a:srgbClr>
-            </a:solidFill>
-            <a:prstDash val="solid"/>
-          </a:ln>
-        </p:spPr>
-      </p:sp>
-      <p:sp>
-        <p:nvSpPr>
-          <p:cNvPr id="6" name="Shape 4"/>
-          <p:cNvSpPr/>
-          <p:nvPr/>
-        </p:nvSpPr>
-        <p:spPr>
-          <a:xfrm>
-            <a:off x="8138160" y="731520"/>
-            <a:ext cx="3291840" cy="0"/>
-          </a:xfrm>
-          <a:prstGeom prst="line">
-            <a:avLst/>
-          </a:prstGeom>
-          <a:noFill/>
-          <a:ln w="12700">
-            <a:solidFill>
-              <a:srgbClr val="123D5A">
-                <a:alpha val="55000"/>
-              </a:srgbClr>
-            </a:solidFill>
-            <a:prstDash val="solid"/>
-          </a:ln>
-        </p:spPr>
-      </p:sp>
-      <p:sp>
-        <p:nvSpPr>
           <p:cNvPr id="7" name="Text 5"/>
           <p:cNvSpPr/>
           <p:nvPr/>
@@ -2352,7 +2186,7 @@
               <a:buNone/>
             </a:pPr>
             <a:r>
-              <a:rPr lang="en-US" sz="1250" dirty="0">
+              <a:rPr lang="en-US" sz="1800" dirty="0">
                 <a:solidFill>
                   <a:srgbClr val="A9BED0"/>
                 </a:solidFill>
@@ -2362,7 +2196,7 @@
               </a:rPr>
               <a:t>The platform has moved from thesis to architecture to sellable wedge.</a:t>
             </a:r>
-            <a:endParaRPr lang="en-US" sz="1250" dirty="0"/>
+            <a:endParaRPr lang="en-US" sz="1800" dirty="0"/>
           </a:p>
         </p:txBody>
       </p:sp>
@@ -2422,7 +2256,7 @@
               <a:buNone/>
             </a:pPr>
             <a:r>
-              <a:rPr lang="en-US" sz="1180" b="1" dirty="0">
+              <a:rPr lang="en-US" sz="1800" b="1" dirty="0">
                 <a:solidFill>
                   <a:srgbClr val="F6C65B"/>
                 </a:solidFill>
@@ -2432,7 +2266,7 @@
               </a:rPr>
               <a:t>Built and shipping (alpha)</a:t>
             </a:r>
-            <a:endParaRPr lang="en-US" sz="1180" dirty="0"/>
+            <a:endParaRPr lang="en-US" sz="1800" dirty="0"/>
           </a:p>
         </p:txBody>
       </p:sp>
@@ -2463,7 +2297,7 @@
               <a:buNone/>
             </a:pPr>
             <a:r>
-              <a:rPr lang="en-US" sz="1220" dirty="0">
+              <a:rPr lang="en-US" sz="1800" dirty="0">
                 <a:solidFill>
                   <a:srgbClr val="F4F8FB"/>
                 </a:solidFill>
@@ -2473,7 +2307,7 @@
               </a:rPr>
               <a:t>Six-tool suite: Yggdrasil ERP (323 tables, 10 modules, Qt + Next.js, 150+ endpoints, OPE governance), Ratatosk, Ragnarok, Bifrost, Jormungandr, Norn. Mimisbrunnr semantic model unifies all six.</a:t>
             </a:r>
-            <a:endParaRPr lang="en-US" sz="1220" dirty="0"/>
+            <a:endParaRPr lang="en-US" sz="1800" dirty="0"/>
           </a:p>
         </p:txBody>
       </p:sp>
@@ -2533,7 +2367,7 @@
               <a:buNone/>
             </a:pPr>
             <a:r>
-              <a:rPr lang="en-US" sz="1180" b="1" dirty="0">
+              <a:rPr lang="en-US" sz="1800" b="1" dirty="0">
                 <a:solidFill>
                   <a:srgbClr val="F6C65B"/>
                 </a:solidFill>
@@ -2543,7 +2377,7 @@
               </a:rPr>
               <a:t>OPE shipped May 2026</a:t>
             </a:r>
-            <a:endParaRPr lang="en-US" sz="1180" dirty="0"/>
+            <a:endParaRPr lang="en-US" sz="1800" dirty="0"/>
           </a:p>
         </p:txBody>
       </p:sp>
@@ -2574,7 +2408,7 @@
               <a:buNone/>
             </a:pPr>
             <a:r>
-              <a:rPr lang="en-US" sz="1220" dirty="0">
+              <a:rPr lang="en-US" sz="1800" dirty="0">
                 <a:solidFill>
                   <a:srgbClr val="F4F8FB"/>
                 </a:solidFill>
@@ -2584,7 +2418,7 @@
               </a:rPr>
               <a:t>9,500+ line commit: Policy lifecycle, Named Conditions, Phases, multi-action, extension capture, ~40 routes, 8 Standard Library templates.</a:t>
             </a:r>
-            <a:endParaRPr lang="en-US" sz="1220" dirty="0"/>
+            <a:endParaRPr lang="en-US" sz="1800" dirty="0"/>
           </a:p>
         </p:txBody>
       </p:sp>
@@ -2644,7 +2478,7 @@
               <a:buNone/>
             </a:pPr>
             <a:r>
-              <a:rPr lang="en-US" sz="1180" b="1" dirty="0">
+              <a:rPr lang="en-US" sz="1800" b="1" dirty="0">
                 <a:solidFill>
                   <a:srgbClr val="F6C65B"/>
                 </a:solidFill>
@@ -2654,7 +2488,7 @@
               </a:rPr>
               <a:t>Multi-tenant infrastructure</a:t>
             </a:r>
-            <a:endParaRPr lang="en-US" sz="1180" dirty="0"/>
+            <a:endParaRPr lang="en-US" sz="1800" dirty="0"/>
           </a:p>
         </p:txBody>
       </p:sp>
@@ -2685,7 +2519,7 @@
               <a:buNone/>
             </a:pPr>
             <a:r>
-              <a:rPr lang="en-US" sz="1220" dirty="0">
+              <a:rPr lang="en-US" sz="1800" dirty="0">
                 <a:solidFill>
                   <a:srgbClr val="F4F8FB"/>
                 </a:solidFill>
@@ -2695,7 +2529,7 @@
               </a:rPr>
               <a:t>Live VPS: RedPanda event mesh, Cloudflare Tunnel ingress, Caddy proxy, Go mesh-server. CMMC Level 1 attestation complete.</a:t>
             </a:r>
-            <a:endParaRPr lang="en-US" sz="1220" dirty="0"/>
+            <a:endParaRPr lang="en-US" sz="1800" dirty="0"/>
           </a:p>
         </p:txBody>
       </p:sp>
@@ -2755,7 +2589,7 @@
               <a:buNone/>
             </a:pPr>
             <a:r>
-              <a:rPr lang="en-US" sz="1180" b="1" dirty="0">
+              <a:rPr lang="en-US" sz="1800" b="1" dirty="0">
                 <a:solidFill>
                   <a:srgbClr val="F6C65B"/>
                 </a:solidFill>
@@ -2765,7 +2599,7 @@
               </a:rPr>
               <a:t>Validated externally</a:t>
             </a:r>
-            <a:endParaRPr lang="en-US" sz="1180" dirty="0"/>
+            <a:endParaRPr lang="en-US" sz="1800" dirty="0"/>
           </a:p>
         </p:txBody>
       </p:sp>
@@ -2796,7 +2630,7 @@
               <a:buNone/>
             </a:pPr>
             <a:r>
-              <a:rPr lang="en-US" sz="1220" dirty="0">
+              <a:rPr lang="en-US" sz="1800" dirty="0">
                 <a:solidFill>
                   <a:srgbClr val="F4F8FB"/>
                 </a:solidFill>
@@ -2806,7 +2640,7 @@
               </a:rPr>
               <a:t>Diginomica's Jon Reed publicly endorsed indie AI-native enterprise builders (Chris named) on Raven Intelligence cast, May 2026. Crunchbase top 100k. CAIP-HE alignment documented.</a:t>
             </a:r>
-            <a:endParaRPr lang="en-US" sz="1220" dirty="0"/>
+            <a:endParaRPr lang="en-US" sz="1800" dirty="0"/>
           </a:p>
         </p:txBody>
       </p:sp>
@@ -2866,7 +2700,7 @@
               <a:buNone/>
             </a:pPr>
             <a:r>
-              <a:rPr lang="en-US" sz="1180" b="1" dirty="0">
+              <a:rPr lang="en-US" sz="1800" b="1" dirty="0">
                 <a:solidFill>
                   <a:srgbClr val="F6C65B"/>
                 </a:solidFill>
@@ -2876,7 +2710,7 @@
               </a:rPr>
               <a:t>In market</a:t>
             </a:r>
-            <a:endParaRPr lang="en-US" sz="1180" dirty="0"/>
+            <a:endParaRPr lang="en-US" sz="1800" dirty="0"/>
           </a:p>
         </p:txBody>
       </p:sp>
@@ -2907,7 +2741,7 @@
               <a:buNone/>
             </a:pPr>
             <a:r>
-              <a:rPr lang="en-US" sz="1220" dirty="0">
+              <a:rPr lang="en-US" sz="1800" dirty="0">
                 <a:solidFill>
                   <a:srgbClr val="F4F8FB"/>
                 </a:solidFill>
@@ -2917,7 +2751,7 @@
               </a:rPr>
               <a:t>Yggdrasil Validation Cohort waitlist live — $15K reservation deposit, 1:1 credit against activation. Selecting for fit; not auto-onboarding.</a:t>
             </a:r>
-            <a:endParaRPr lang="en-US" sz="1220" dirty="0"/>
+            <a:endParaRPr lang="en-US" sz="1800" dirty="0"/>
           </a:p>
         </p:txBody>
       </p:sp>
@@ -3132,89 +2966,6 @@
       </p:sp>
       <p:sp>
         <p:nvSpPr>
-          <p:cNvPr id="4" name="Shape 2"/>
-          <p:cNvSpPr/>
-          <p:nvPr/>
-        </p:nvSpPr>
-        <p:spPr>
-          <a:xfrm>
-            <a:off x="8275320" y="137160"/>
-            <a:ext cx="3611880" cy="3611880"/>
-          </a:xfrm>
-          <a:prstGeom prst="arc">
-            <a:avLst/>
-          </a:prstGeom>
-          <a:solidFill>
-            <a:srgbClr val="08131F">
-              <a:alpha val="0"/>
-            </a:srgbClr>
-          </a:solidFill>
-          <a:ln w="13970">
-            <a:solidFill>
-              <a:srgbClr val="123D5A">
-                <a:alpha val="65000"/>
-              </a:srgbClr>
-            </a:solidFill>
-            <a:prstDash val="solid"/>
-          </a:ln>
-        </p:spPr>
-      </p:sp>
-      <p:sp>
-        <p:nvSpPr>
-          <p:cNvPr id="5" name="Shape 3"/>
-          <p:cNvSpPr/>
-          <p:nvPr/>
-        </p:nvSpPr>
-        <p:spPr>
-          <a:xfrm>
-            <a:off x="8641080" y="475488"/>
-            <a:ext cx="2834640" cy="2834640"/>
-          </a:xfrm>
-          <a:prstGeom prst="arc">
-            <a:avLst/>
-          </a:prstGeom>
-          <a:solidFill>
-            <a:srgbClr val="08131F">
-              <a:alpha val="0"/>
-            </a:srgbClr>
-          </a:solidFill>
-          <a:ln w="10160">
-            <a:solidFill>
-              <a:srgbClr val="2DE2D1">
-                <a:alpha val="28000"/>
-              </a:srgbClr>
-            </a:solidFill>
-            <a:prstDash val="solid"/>
-          </a:ln>
-        </p:spPr>
-      </p:sp>
-      <p:sp>
-        <p:nvSpPr>
-          <p:cNvPr id="6" name="Shape 4"/>
-          <p:cNvSpPr/>
-          <p:nvPr/>
-        </p:nvSpPr>
-        <p:spPr>
-          <a:xfrm>
-            <a:off x="8138160" y="731520"/>
-            <a:ext cx="3291840" cy="0"/>
-          </a:xfrm>
-          <a:prstGeom prst="line">
-            <a:avLst/>
-          </a:prstGeom>
-          <a:noFill/>
-          <a:ln w="12700">
-            <a:solidFill>
-              <a:srgbClr val="123D5A">
-                <a:alpha val="55000"/>
-              </a:srgbClr>
-            </a:solidFill>
-            <a:prstDash val="solid"/>
-          </a:ln>
-        </p:spPr>
-      </p:sp>
-      <p:sp>
-        <p:nvSpPr>
           <p:cNvPr id="7" name="Text 5"/>
           <p:cNvSpPr/>
           <p:nvPr/>
@@ -3281,7 +3032,7 @@
               <a:buNone/>
             </a:pPr>
             <a:r>
-              <a:rPr lang="en-US" sz="1250" dirty="0">
+              <a:rPr lang="en-US" sz="1800" dirty="0">
                 <a:solidFill>
                   <a:srgbClr val="A9BED0"/>
                 </a:solidFill>
@@ -3291,7 +3042,7 @@
               </a:rPr>
               <a:t>Mimir Labs is one person and a deliberate development model. The platform exists because the founder lived inside the failures the doctrine refuses.</a:t>
             </a:r>
-            <a:endParaRPr lang="en-US" sz="1250" dirty="0"/>
+            <a:endParaRPr lang="en-US" sz="1800" dirty="0"/>
           </a:p>
         </p:txBody>
       </p:sp>
@@ -3392,7 +3143,7 @@
               <a:buNone/>
             </a:pPr>
             <a:r>
-              <a:rPr lang="en-US" sz="1400" dirty="0">
+              <a:rPr lang="en-US" sz="1800" dirty="0">
                 <a:solidFill>
                   <a:srgbClr val="F4F8FB"/>
                 </a:solidFill>
@@ -3407,7 +3158,7 @@
               <a:buNone/>
             </a:pPr>
             <a:r>
-              <a:rPr lang="en-US" sz="1400" dirty="0">
+              <a:rPr lang="en-US" sz="1800" dirty="0">
                 <a:solidFill>
                   <a:srgbClr val="F4F8FB"/>
                 </a:solidFill>
@@ -3422,7 +3173,7 @@
               <a:buNone/>
             </a:pPr>
             <a:r>
-              <a:rPr lang="en-US" sz="1400" dirty="0">
+              <a:rPr lang="en-US" sz="1800" dirty="0">
                 <a:solidFill>
                   <a:srgbClr val="F4F8FB"/>
                 </a:solidFill>
@@ -3437,7 +3188,7 @@
               <a:buNone/>
             </a:pPr>
             <a:r>
-              <a:rPr lang="en-US" sz="1400" dirty="0">
+              <a:rPr lang="en-US" sz="1800" dirty="0">
                 <a:solidFill>
                   <a:srgbClr val="F4F8FB"/>
                 </a:solidFill>
@@ -3452,7 +3203,7 @@
               <a:buNone/>
             </a:pPr>
             <a:r>
-              <a:rPr lang="en-US" sz="1400" dirty="0">
+              <a:rPr lang="en-US" sz="1800" dirty="0">
                 <a:solidFill>
                   <a:srgbClr val="F4F8FB"/>
                 </a:solidFill>
@@ -3462,7 +3213,7 @@
               </a:rPr>
               <a:t>• Located in South Central Pennsylvania; available to operators in person</a:t>
             </a:r>
-            <a:endParaRPr lang="en-US" sz="1400" dirty="0"/>
+            <a:endParaRPr lang="en-US" sz="1800" dirty="0"/>
           </a:p>
         </p:txBody>
       </p:sp>
@@ -3563,7 +3314,7 @@
               <a:buNone/>
             </a:pPr>
             <a:r>
-              <a:rPr lang="en-US" sz="1400" dirty="0">
+              <a:rPr lang="en-US" sz="1800" dirty="0">
                 <a:solidFill>
                   <a:srgbClr val="F4F8FB"/>
                 </a:solidFill>
@@ -3578,7 +3329,7 @@
               <a:buNone/>
             </a:pPr>
             <a:r>
-              <a:rPr lang="en-US" sz="1400" dirty="0">
+              <a:rPr lang="en-US" sz="1800" dirty="0">
                 <a:solidFill>
                   <a:srgbClr val="F4F8FB"/>
                 </a:solidFill>
@@ -3593,7 +3344,7 @@
               <a:buNone/>
             </a:pPr>
             <a:r>
-              <a:rPr lang="en-US" sz="1400" dirty="0">
+              <a:rPr lang="en-US" sz="1800" dirty="0">
                 <a:solidFill>
                   <a:srgbClr val="F4F8FB"/>
                 </a:solidFill>
@@ -3608,7 +3359,7 @@
               <a:buNone/>
             </a:pPr>
             <a:r>
-              <a:rPr lang="en-US" sz="1400" dirty="0">
+              <a:rPr lang="en-US" sz="1800" dirty="0">
                 <a:solidFill>
                   <a:srgbClr val="F4F8FB"/>
                 </a:solidFill>
@@ -3618,7 +3369,7 @@
               </a:rPr>
               <a:t>• Year 3 target: 7 FTE; Year 5 target: 22 FTE</a:t>
             </a:r>
-            <a:endParaRPr lang="en-US" sz="1400" dirty="0"/>
+            <a:endParaRPr lang="en-US" sz="1800" dirty="0"/>
           </a:p>
         </p:txBody>
       </p:sp>
@@ -3649,7 +3400,7 @@
               <a:buNone/>
             </a:pPr>
             <a:r>
-              <a:rPr lang="en-US" sz="1550" dirty="0">
+              <a:rPr lang="en-US" sz="1800" dirty="0">
                 <a:solidFill>
                   <a:srgbClr val="A9BED0"/>
                 </a:solidFill>
@@ -3659,7 +3410,7 @@
               </a:rPr>
               <a:t>The architecture, the doctrine, the manifests, the code — all real and reviewable. Bus-factor risk is named and addressed by the first hire, not deflected.</a:t>
             </a:r>
-            <a:endParaRPr lang="en-US" sz="1550" dirty="0"/>
+            <a:endParaRPr lang="en-US" sz="1800" dirty="0"/>
           </a:p>
         </p:txBody>
       </p:sp>
@@ -3833,89 +3584,6 @@
       </p:sp>
       <p:sp>
         <p:nvSpPr>
-          <p:cNvPr id="4" name="Shape 2"/>
-          <p:cNvSpPr/>
-          <p:nvPr/>
-        </p:nvSpPr>
-        <p:spPr>
-          <a:xfrm>
-            <a:off x="8275320" y="137160"/>
-            <a:ext cx="3611880" cy="3611880"/>
-          </a:xfrm>
-          <a:prstGeom prst="arc">
-            <a:avLst/>
-          </a:prstGeom>
-          <a:solidFill>
-            <a:srgbClr val="08131F">
-              <a:alpha val="0"/>
-            </a:srgbClr>
-          </a:solidFill>
-          <a:ln w="13970">
-            <a:solidFill>
-              <a:srgbClr val="123D5A">
-                <a:alpha val="65000"/>
-              </a:srgbClr>
-            </a:solidFill>
-            <a:prstDash val="solid"/>
-          </a:ln>
-        </p:spPr>
-      </p:sp>
-      <p:sp>
-        <p:nvSpPr>
-          <p:cNvPr id="5" name="Shape 3"/>
-          <p:cNvSpPr/>
-          <p:nvPr/>
-        </p:nvSpPr>
-        <p:spPr>
-          <a:xfrm>
-            <a:off x="8641080" y="475488"/>
-            <a:ext cx="2834640" cy="2834640"/>
-          </a:xfrm>
-          <a:prstGeom prst="arc">
-            <a:avLst/>
-          </a:prstGeom>
-          <a:solidFill>
-            <a:srgbClr val="08131F">
-              <a:alpha val="0"/>
-            </a:srgbClr>
-          </a:solidFill>
-          <a:ln w="10160">
-            <a:solidFill>
-              <a:srgbClr val="2DE2D1">
-                <a:alpha val="28000"/>
-              </a:srgbClr>
-            </a:solidFill>
-            <a:prstDash val="solid"/>
-          </a:ln>
-        </p:spPr>
-      </p:sp>
-      <p:sp>
-        <p:nvSpPr>
-          <p:cNvPr id="6" name="Shape 4"/>
-          <p:cNvSpPr/>
-          <p:nvPr/>
-        </p:nvSpPr>
-        <p:spPr>
-          <a:xfrm>
-            <a:off x="8138160" y="731520"/>
-            <a:ext cx="3291840" cy="0"/>
-          </a:xfrm>
-          <a:prstGeom prst="line">
-            <a:avLst/>
-          </a:prstGeom>
-          <a:noFill/>
-          <a:ln w="12700">
-            <a:solidFill>
-              <a:srgbClr val="123D5A">
-                <a:alpha val="55000"/>
-              </a:srgbClr>
-            </a:solidFill>
-            <a:prstDash val="solid"/>
-          </a:ln>
-        </p:spPr>
-      </p:sp>
-      <p:sp>
-        <p:nvSpPr>
           <p:cNvPr id="7" name="Text 5"/>
           <p:cNvSpPr/>
           <p:nvPr/>
@@ -3982,7 +3650,7 @@
               <a:buNone/>
             </a:pPr>
             <a:r>
-              <a:rPr lang="en-US" sz="1250" dirty="0">
+              <a:rPr lang="en-US" sz="1800" dirty="0">
                 <a:solidFill>
                   <a:srgbClr val="A9BED0"/>
                 </a:solidFill>
@@ -3992,7 +3660,7 @@
               </a:rPr>
               <a:t>Five revenue lines (Norn SaaS / Ratatosk / Ragnarok / Bifrost / Yggdrasil) with services-led ramp and SaaS-dominant mix by Year 5.</a:t>
             </a:r>
-            <a:endParaRPr lang="en-US" sz="1250" dirty="0"/>
+            <a:endParaRPr lang="en-US" sz="1800" dirty="0"/>
           </a:p>
         </p:txBody>
       </p:sp>
@@ -4052,7 +3720,7 @@
               <a:buNone/>
             </a:pPr>
             <a:r>
-              <a:rPr lang="en-US" sz="1180" b="1" dirty="0">
+              <a:rPr lang="en-US" sz="1800" b="1" dirty="0">
                 <a:solidFill>
                   <a:srgbClr val="F6C65B"/>
                 </a:solidFill>
@@ -4062,7 +3730,7 @@
               </a:rPr>
               <a:t>Year 1 — Foundation</a:t>
             </a:r>
-            <a:endParaRPr lang="en-US" sz="1180" dirty="0"/>
+            <a:endParaRPr lang="en-US" sz="1800" dirty="0"/>
           </a:p>
         </p:txBody>
       </p:sp>
@@ -4093,7 +3761,7 @@
               <a:buNone/>
             </a:pPr>
             <a:r>
-              <a:rPr lang="en-US" sz="1220" dirty="0">
+              <a:rPr lang="en-US" sz="1800" dirty="0">
                 <a:solidFill>
                   <a:srgbClr val="F4F8FB"/>
                 </a:solidFill>
@@ -4103,7 +3771,7 @@
               </a:rPr>
               <a:t>$241K total revenue. Solo founder. 3 Yggdrasil pilots, 4 Ratatosk workshops, 1 Ragnarok migration, Norn launches. Net (-$23K).</a:t>
             </a:r>
-            <a:endParaRPr lang="en-US" sz="1220" dirty="0"/>
+            <a:endParaRPr lang="en-US" sz="1800" dirty="0"/>
           </a:p>
         </p:txBody>
       </p:sp>
@@ -4163,7 +3831,7 @@
               <a:buNone/>
             </a:pPr>
             <a:r>
-              <a:rPr lang="en-US" sz="1180" b="1" dirty="0">
+              <a:rPr lang="en-US" sz="1800" b="1" dirty="0">
                 <a:solidFill>
                   <a:srgbClr val="F6C65B"/>
                 </a:solidFill>
@@ -4173,7 +3841,7 @@
               </a:rPr>
               <a:t>Year 2 — First hires</a:t>
             </a:r>
-            <a:endParaRPr lang="en-US" sz="1180" dirty="0"/>
+            <a:endParaRPr lang="en-US" sz="1800" dirty="0"/>
           </a:p>
         </p:txBody>
       </p:sp>
@@ -4204,7 +3872,7 @@
               <a:buNone/>
             </a:pPr>
             <a:r>
-              <a:rPr lang="en-US" sz="1220" dirty="0">
+              <a:rPr lang="en-US" sz="1800" dirty="0">
                 <a:solidFill>
                   <a:srgbClr val="F4F8FB"/>
                 </a:solidFill>
@@ -4214,7 +3882,7 @@
               </a:rPr>
               <a:t>$1.14M revenue. 3 FTE. 12 Ratatosk, 6 Ragnarok, first Bifrost subscribers, 4 Yggdrasil pilots. Cash-flow positive ($168K net).</a:t>
             </a:r>
-            <a:endParaRPr lang="en-US" sz="1220" dirty="0"/>
+            <a:endParaRPr lang="en-US" sz="1800" dirty="0"/>
           </a:p>
         </p:txBody>
       </p:sp>
@@ -4274,7 +3942,7 @@
               <a:buNone/>
             </a:pPr>
             <a:r>
-              <a:rPr lang="en-US" sz="1180" b="1" dirty="0">
+              <a:rPr lang="en-US" sz="1800" b="1" dirty="0">
                 <a:solidFill>
                   <a:srgbClr val="F6C65B"/>
                 </a:solidFill>
@@ -4284,7 +3952,7 @@
               </a:rPr>
               <a:t>Year 3 — Platform proves out</a:t>
             </a:r>
-            <a:endParaRPr lang="en-US" sz="1180" dirty="0"/>
+            <a:endParaRPr lang="en-US" sz="1800" dirty="0"/>
           </a:p>
         </p:txBody>
       </p:sp>
@@ -4315,7 +3983,7 @@
               <a:buNone/>
             </a:pPr>
             <a:r>
-              <a:rPr lang="en-US" sz="1220" dirty="0">
+              <a:rPr lang="en-US" sz="1800" dirty="0">
                 <a:solidFill>
                   <a:srgbClr val="F4F8FB"/>
                 </a:solidFill>
@@ -4325,7 +3993,7 @@
               </a:rPr>
               <a:t>$3.62M revenue ($2.36M ARR, 65% recurring). 7 FTE. 28 Ratatosk, 16 Ragnarok, 13 Yggdrasil tenants, Audit Authority attach begins. $1.43M net.</a:t>
             </a:r>
-            <a:endParaRPr lang="en-US" sz="1220" dirty="0"/>
+            <a:endParaRPr lang="en-US" sz="1800" dirty="0"/>
           </a:p>
         </p:txBody>
       </p:sp>
@@ -4385,7 +4053,7 @@
               <a:buNone/>
             </a:pPr>
             <a:r>
-              <a:rPr lang="en-US" sz="1180" b="1" dirty="0">
+              <a:rPr lang="en-US" sz="1800" b="1" dirty="0">
                 <a:solidFill>
                   <a:srgbClr val="F6C65B"/>
                 </a:solidFill>
@@ -4395,7 +4063,7 @@
               </a:rPr>
               <a:t>Year 4 — Scale</a:t>
             </a:r>
-            <a:endParaRPr lang="en-US" sz="1180" dirty="0"/>
+            <a:endParaRPr lang="en-US" sz="1800" dirty="0"/>
           </a:p>
         </p:txBody>
       </p:sp>
@@ -4426,7 +4094,7 @@
               <a:buNone/>
             </a:pPr>
             <a:r>
-              <a:rPr lang="en-US" sz="1220" dirty="0">
+              <a:rPr lang="en-US" sz="1800" dirty="0">
                 <a:solidFill>
                   <a:srgbClr val="F4F8FB"/>
                 </a:solidFill>
@@ -4436,7 +4104,7 @@
               </a:rPr>
               <a:t>$8.67M revenue ($6.18M ARR, 71% recurring). 14 FTE. Yggdrasil pilots ramp to 25, Bifrost to 31 subscribers, Norn at $2.6M. $4.76M net.</a:t>
             </a:r>
-            <a:endParaRPr lang="en-US" sz="1220" dirty="0"/>
+            <a:endParaRPr lang="en-US" sz="1800" dirty="0"/>
           </a:p>
         </p:txBody>
       </p:sp>
@@ -4496,7 +4164,7 @@
               <a:buNone/>
             </a:pPr>
             <a:r>
-              <a:rPr lang="en-US" sz="1180" b="1" dirty="0">
+              <a:rPr lang="en-US" sz="1800" b="1" dirty="0">
                 <a:solidFill>
                   <a:srgbClr val="F6C65B"/>
                 </a:solidFill>
@@ -4506,7 +4174,7 @@
               </a:rPr>
               <a:t>Year 5 — SaaS-dominant</a:t>
             </a:r>
-            <a:endParaRPr lang="en-US" sz="1180" dirty="0"/>
+            <a:endParaRPr lang="en-US" sz="1800" dirty="0"/>
           </a:p>
         </p:txBody>
       </p:sp>
@@ -4537,7 +4205,7 @@
               <a:buNone/>
             </a:pPr>
             <a:r>
-              <a:rPr lang="en-US" sz="1220" dirty="0">
+              <a:rPr lang="en-US" sz="1800" dirty="0">
                 <a:solidFill>
                   <a:srgbClr val="F4F8FB"/>
                 </a:solidFill>
@@ -4547,7 +4215,7 @@
               </a:rPr>
               <a:t>$17.6M revenue ($13.4M ARR, 76% recurring). 22 FTE. 53 Yggdrasil tenants, 2,000 Norn paid accounts, $700K revenue/employee. $11.4M net.</a:t>
             </a:r>
-            <a:endParaRPr lang="en-US" sz="1220" dirty="0"/>
+            <a:endParaRPr lang="en-US" sz="1800" dirty="0"/>
           </a:p>
         </p:txBody>
       </p:sp>
@@ -4762,89 +4430,6 @@
       </p:sp>
       <p:sp>
         <p:nvSpPr>
-          <p:cNvPr id="4" name="Shape 2"/>
-          <p:cNvSpPr/>
-          <p:nvPr/>
-        </p:nvSpPr>
-        <p:spPr>
-          <a:xfrm>
-            <a:off x="8275320" y="137160"/>
-            <a:ext cx="3611880" cy="3611880"/>
-          </a:xfrm>
-          <a:prstGeom prst="arc">
-            <a:avLst/>
-          </a:prstGeom>
-          <a:solidFill>
-            <a:srgbClr val="08131F">
-              <a:alpha val="0"/>
-            </a:srgbClr>
-          </a:solidFill>
-          <a:ln w="13970">
-            <a:solidFill>
-              <a:srgbClr val="123D5A">
-                <a:alpha val="65000"/>
-              </a:srgbClr>
-            </a:solidFill>
-            <a:prstDash val="solid"/>
-          </a:ln>
-        </p:spPr>
-      </p:sp>
-      <p:sp>
-        <p:nvSpPr>
-          <p:cNvPr id="5" name="Shape 3"/>
-          <p:cNvSpPr/>
-          <p:nvPr/>
-        </p:nvSpPr>
-        <p:spPr>
-          <a:xfrm>
-            <a:off x="8641080" y="475488"/>
-            <a:ext cx="2834640" cy="2834640"/>
-          </a:xfrm>
-          <a:prstGeom prst="arc">
-            <a:avLst/>
-          </a:prstGeom>
-          <a:solidFill>
-            <a:srgbClr val="08131F">
-              <a:alpha val="0"/>
-            </a:srgbClr>
-          </a:solidFill>
-          <a:ln w="10160">
-            <a:solidFill>
-              <a:srgbClr val="2DE2D1">
-                <a:alpha val="28000"/>
-              </a:srgbClr>
-            </a:solidFill>
-            <a:prstDash val="solid"/>
-          </a:ln>
-        </p:spPr>
-      </p:sp>
-      <p:sp>
-        <p:nvSpPr>
-          <p:cNvPr id="6" name="Shape 4"/>
-          <p:cNvSpPr/>
-          <p:nvPr/>
-        </p:nvSpPr>
-        <p:spPr>
-          <a:xfrm>
-            <a:off x="8138160" y="731520"/>
-            <a:ext cx="3291840" cy="0"/>
-          </a:xfrm>
-          <a:prstGeom prst="line">
-            <a:avLst/>
-          </a:prstGeom>
-          <a:noFill/>
-          <a:ln w="12700">
-            <a:solidFill>
-              <a:srgbClr val="123D5A">
-                <a:alpha val="55000"/>
-              </a:srgbClr>
-            </a:solidFill>
-            <a:prstDash val="solid"/>
-          </a:ln>
-        </p:spPr>
-      </p:sp>
-      <p:sp>
-        <p:nvSpPr>
           <p:cNvPr id="7" name="Text 5"/>
           <p:cNvSpPr/>
           <p:nvPr/>
@@ -4911,7 +4496,7 @@
               <a:buNone/>
             </a:pPr>
             <a:r>
-              <a:rPr lang="en-US" sz="1250" dirty="0">
+              <a:rPr lang="en-US" sz="1800" dirty="0">
                 <a:solidFill>
                   <a:srgbClr val="A9BED0"/>
                 </a:solidFill>
@@ -4921,7 +4506,7 @@
               </a:rPr>
               <a:t>Use of funds is intentionally narrow: pilots, product hardening, and partner-ready delivery.</a:t>
             </a:r>
-            <a:endParaRPr lang="en-US" sz="1250" dirty="0"/>
+            <a:endParaRPr lang="en-US" sz="1800" dirty="0"/>
           </a:p>
         </p:txBody>
       </p:sp>
@@ -5063,7 +4648,7 @@
               <a:buNone/>
             </a:pPr>
             <a:r>
-              <a:rPr lang="en-US" sz="1220" dirty="0">
+              <a:rPr lang="en-US" sz="1800" dirty="0">
                 <a:solidFill>
                   <a:srgbClr val="A9BED0"/>
                 </a:solidFill>
@@ -5073,7 +4658,7 @@
               </a:rPr>
               <a:t>Flexible structure: priced equity, SAFE, convertible, or BFTP/angel-led tranche. BFTP-tier proposal: $150–350K (detailed allocation in companion talking-points doc).</a:t>
             </a:r>
-            <a:endParaRPr lang="en-US" sz="1220" dirty="0"/>
+            <a:endParaRPr lang="en-US" sz="1800" dirty="0"/>
           </a:p>
         </p:txBody>
       </p:sp>
@@ -5174,7 +4759,7 @@
               <a:buNone/>
             </a:pPr>
             <a:r>
-              <a:rPr lang="en-US" sz="1300" dirty="0">
+              <a:rPr lang="en-US" sz="1800" dirty="0">
                 <a:solidFill>
                   <a:srgbClr val="F4F8FB"/>
                 </a:solidFill>
@@ -5189,7 +4774,7 @@
               <a:buNone/>
             </a:pPr>
             <a:r>
-              <a:rPr lang="en-US" sz="1300" dirty="0">
+              <a:rPr lang="en-US" sz="1800" dirty="0">
                 <a:solidFill>
                   <a:srgbClr val="F4F8FB"/>
                 </a:solidFill>
@@ -5204,7 +4789,7 @@
               <a:buNone/>
             </a:pPr>
             <a:r>
-              <a:rPr lang="en-US" sz="1300" dirty="0">
+              <a:rPr lang="en-US" sz="1800" dirty="0">
                 <a:solidFill>
                   <a:srgbClr val="F4F8FB"/>
                 </a:solidFill>
@@ -5219,7 +4804,7 @@
               <a:buNone/>
             </a:pPr>
             <a:r>
-              <a:rPr lang="en-US" sz="1300" dirty="0">
+              <a:rPr lang="en-US" sz="1800" dirty="0">
                 <a:solidFill>
                   <a:srgbClr val="F4F8FB"/>
                 </a:solidFill>
@@ -5229,7 +4814,7 @@
               </a:rPr>
               <a:t>• SOC 2 Type I + first engineering hire</a:t>
             </a:r>
-            <a:endParaRPr lang="en-US" sz="1300" dirty="0"/>
+            <a:endParaRPr lang="en-US" sz="1800" dirty="0"/>
           </a:p>
         </p:txBody>
       </p:sp>
@@ -5330,7 +4915,7 @@
               <a:buNone/>
             </a:pPr>
             <a:r>
-              <a:rPr lang="en-US" sz="1300" dirty="0">
+              <a:rPr lang="en-US" sz="1800" dirty="0">
                 <a:solidFill>
                   <a:srgbClr val="F4F8FB"/>
                 </a:solidFill>
@@ -5345,7 +4930,7 @@
               <a:buNone/>
             </a:pPr>
             <a:r>
-              <a:rPr lang="en-US" sz="1300" dirty="0">
+              <a:rPr lang="en-US" sz="1800" dirty="0">
                 <a:solidFill>
                   <a:srgbClr val="F4F8FB"/>
                 </a:solidFill>
@@ -5360,7 +4945,7 @@
               <a:buNone/>
             </a:pPr>
             <a:r>
-              <a:rPr lang="en-US" sz="1300" dirty="0">
+              <a:rPr lang="en-US" sz="1800" dirty="0">
                 <a:solidFill>
                   <a:srgbClr val="F4F8FB"/>
                 </a:solidFill>
@@ -5375,7 +4960,7 @@
               <a:buNone/>
             </a:pPr>
             <a:r>
-              <a:rPr lang="en-US" sz="1300" dirty="0">
+              <a:rPr lang="en-US" sz="1800" dirty="0">
                 <a:solidFill>
                   <a:srgbClr val="F4F8FB"/>
                 </a:solidFill>
@@ -5385,7 +4970,7 @@
               </a:rPr>
               <a:t>• Founder bridge ($4K/mo) + operating reserve</a:t>
             </a:r>
-            <a:endParaRPr lang="en-US" sz="1300" dirty="0"/>
+            <a:endParaRPr lang="en-US" sz="1800" dirty="0"/>
           </a:p>
         </p:txBody>
       </p:sp>
@@ -5416,7 +5001,7 @@
               <a:buNone/>
             </a:pPr>
             <a:r>
-              <a:rPr lang="en-US" sz="1730" b="1" dirty="0">
+              <a:rPr lang="en-US" sz="1800" b="1" dirty="0">
                 <a:solidFill>
                   <a:srgbClr val="F4F8FB"/>
                 </a:solidFill>
@@ -5426,7 +5011,7 @@
               </a:rPr>
               <a:t>Mimir Labs has already built the reference implementation. This raise funds the first commercial proof — not the architecture, the customers.</a:t>
             </a:r>
-            <a:endParaRPr lang="en-US" sz="1730" dirty="0"/>
+            <a:endParaRPr lang="en-US" sz="1800" dirty="0"/>
           </a:p>
         </p:txBody>
       </p:sp>
@@ -5600,89 +5185,6 @@
       </p:sp>
       <p:sp>
         <p:nvSpPr>
-          <p:cNvPr id="4" name="Shape 2"/>
-          <p:cNvSpPr/>
-          <p:nvPr/>
-        </p:nvSpPr>
-        <p:spPr>
-          <a:xfrm>
-            <a:off x="8275320" y="137160"/>
-            <a:ext cx="3611880" cy="3611880"/>
-          </a:xfrm>
-          <a:prstGeom prst="arc">
-            <a:avLst/>
-          </a:prstGeom>
-          <a:solidFill>
-            <a:srgbClr val="08131F">
-              <a:alpha val="0"/>
-            </a:srgbClr>
-          </a:solidFill>
-          <a:ln w="13970">
-            <a:solidFill>
-              <a:srgbClr val="123D5A">
-                <a:alpha val="65000"/>
-              </a:srgbClr>
-            </a:solidFill>
-            <a:prstDash val="solid"/>
-          </a:ln>
-        </p:spPr>
-      </p:sp>
-      <p:sp>
-        <p:nvSpPr>
-          <p:cNvPr id="5" name="Shape 3"/>
-          <p:cNvSpPr/>
-          <p:nvPr/>
-        </p:nvSpPr>
-        <p:spPr>
-          <a:xfrm>
-            <a:off x="8641080" y="475488"/>
-            <a:ext cx="2834640" cy="2834640"/>
-          </a:xfrm>
-          <a:prstGeom prst="arc">
-            <a:avLst/>
-          </a:prstGeom>
-          <a:solidFill>
-            <a:srgbClr val="08131F">
-              <a:alpha val="0"/>
-            </a:srgbClr>
-          </a:solidFill>
-          <a:ln w="10160">
-            <a:solidFill>
-              <a:srgbClr val="2DE2D1">
-                <a:alpha val="28000"/>
-              </a:srgbClr>
-            </a:solidFill>
-            <a:prstDash val="solid"/>
-          </a:ln>
-        </p:spPr>
-      </p:sp>
-      <p:sp>
-        <p:nvSpPr>
-          <p:cNvPr id="6" name="Shape 4"/>
-          <p:cNvSpPr/>
-          <p:nvPr/>
-        </p:nvSpPr>
-        <p:spPr>
-          <a:xfrm>
-            <a:off x="8138160" y="731520"/>
-            <a:ext cx="3291840" cy="0"/>
-          </a:xfrm>
-          <a:prstGeom prst="line">
-            <a:avLst/>
-          </a:prstGeom>
-          <a:noFill/>
-          <a:ln w="12700">
-            <a:solidFill>
-              <a:srgbClr val="123D5A">
-                <a:alpha val="55000"/>
-              </a:srgbClr>
-            </a:solidFill>
-            <a:prstDash val="solid"/>
-          </a:ln>
-        </p:spPr>
-      </p:sp>
-      <p:sp>
-        <p:nvSpPr>
           <p:cNvPr id="7" name="Shape 5"/>
           <p:cNvSpPr/>
           <p:nvPr/>
@@ -5747,7 +5249,7 @@
                 <a:ea typeface="Aptos" pitchFamily="34" charset="-122"/>
                 <a:cs typeface="Aptos" pitchFamily="34" charset="-120"/>
               </a:rPr>
-              <a:t>WE'VE ALREADY BUILT IT.</a:t>
+              <a:t>The ERP that doesn't believe in edge cases.</a:t>
             </a:r>
             <a:endParaRPr lang="en-US" sz="870" dirty="0"/>
           </a:p>
@@ -5829,7 +5331,7 @@
                 <a:ea typeface="Aptos Display" pitchFamily="34" charset="-122"/>
                 <a:cs typeface="Aptos Display" pitchFamily="34" charset="-120"/>
               </a:rPr>
-              <a:t>The ERP that doesn't believe in edge cases.</a:t>
+              <a:t>WE'VE ALREADY BUILT IT.</a:t>
             </a:r>
             <a:endParaRPr lang="en-US" sz="3500" dirty="0"/>
           </a:p>
@@ -5862,7 +5364,7 @@
               <a:buNone/>
             </a:pPr>
             <a:r>
-              <a:rPr lang="en-US" sz="1600" dirty="0">
+              <a:rPr lang="en-US" sz="1800" dirty="0">
                 <a:solidFill>
                   <a:srgbClr val="A9BED0"/>
                 </a:solidFill>
@@ -5872,7 +5374,7 @@
               </a:rPr>
               <a:t>$1.0M strategic pre-seed. BFTP tranche: $150–350K. Detailed allocation in companion talking-points doc.</a:t>
             </a:r>
-            <a:endParaRPr lang="en-US" sz="1600" dirty="0"/>
+            <a:endParaRPr lang="en-US" sz="1800" dirty="0"/>
           </a:p>
         </p:txBody>
       </p:sp>
@@ -5971,7 +5473,7 @@
               <a:buNone/>
             </a:pPr>
             <a:r>
-              <a:rPr lang="en-US" sz="1150" dirty="0">
+              <a:rPr lang="en-US" sz="1800" dirty="0">
                 <a:solidFill>
                   <a:srgbClr val="A9BED0"/>
                 </a:solidFill>
@@ -5981,7 +5483,7 @@
               </a:rPr>
               <a:t>Christopher "Doc" Gaither — cgaither@mimirlabs.net — mimirlabs.net — South Central Pennsylvania</a:t>
             </a:r>
-            <a:endParaRPr lang="en-US" sz="1150" dirty="0"/>
+            <a:endParaRPr lang="en-US" sz="1800" dirty="0"/>
           </a:p>
         </p:txBody>
       </p:sp>
@@ -6155,89 +5657,6 @@
       </p:sp>
       <p:sp>
         <p:nvSpPr>
-          <p:cNvPr id="4" name="Shape 2"/>
-          <p:cNvSpPr/>
-          <p:nvPr/>
-        </p:nvSpPr>
-        <p:spPr>
-          <a:xfrm>
-            <a:off x="8275320" y="137160"/>
-            <a:ext cx="3611880" cy="3611880"/>
-          </a:xfrm>
-          <a:prstGeom prst="arc">
-            <a:avLst/>
-          </a:prstGeom>
-          <a:solidFill>
-            <a:srgbClr val="08131F">
-              <a:alpha val="0"/>
-            </a:srgbClr>
-          </a:solidFill>
-          <a:ln w="13970">
-            <a:solidFill>
-              <a:srgbClr val="123D5A">
-                <a:alpha val="65000"/>
-              </a:srgbClr>
-            </a:solidFill>
-            <a:prstDash val="solid"/>
-          </a:ln>
-        </p:spPr>
-      </p:sp>
-      <p:sp>
-        <p:nvSpPr>
-          <p:cNvPr id="5" name="Shape 3"/>
-          <p:cNvSpPr/>
-          <p:nvPr/>
-        </p:nvSpPr>
-        <p:spPr>
-          <a:xfrm>
-            <a:off x="8641080" y="475488"/>
-            <a:ext cx="2834640" cy="2834640"/>
-          </a:xfrm>
-          <a:prstGeom prst="arc">
-            <a:avLst/>
-          </a:prstGeom>
-          <a:solidFill>
-            <a:srgbClr val="08131F">
-              <a:alpha val="0"/>
-            </a:srgbClr>
-          </a:solidFill>
-          <a:ln w="10160">
-            <a:solidFill>
-              <a:srgbClr val="2DE2D1">
-                <a:alpha val="28000"/>
-              </a:srgbClr>
-            </a:solidFill>
-            <a:prstDash val="solid"/>
-          </a:ln>
-        </p:spPr>
-      </p:sp>
-      <p:sp>
-        <p:nvSpPr>
-          <p:cNvPr id="6" name="Shape 4"/>
-          <p:cNvSpPr/>
-          <p:nvPr/>
-        </p:nvSpPr>
-        <p:spPr>
-          <a:xfrm>
-            <a:off x="8138160" y="731520"/>
-            <a:ext cx="3291840" cy="0"/>
-          </a:xfrm>
-          <a:prstGeom prst="line">
-            <a:avLst/>
-          </a:prstGeom>
-          <a:noFill/>
-          <a:ln w="12700">
-            <a:solidFill>
-              <a:srgbClr val="123D5A">
-                <a:alpha val="55000"/>
-              </a:srgbClr>
-            </a:solidFill>
-            <a:prstDash val="solid"/>
-          </a:ln>
-        </p:spPr>
-      </p:sp>
-      <p:sp>
-        <p:nvSpPr>
           <p:cNvPr id="7" name="Text 5"/>
           <p:cNvSpPr/>
           <p:nvPr/>
@@ -6304,7 +5723,7 @@
               <a:buNone/>
             </a:pPr>
             <a:r>
-              <a:rPr lang="en-US" sz="1250" dirty="0">
+              <a:rPr lang="en-US" sz="1800" dirty="0">
                 <a:solidFill>
                   <a:srgbClr val="A9BED0"/>
                 </a:solidFill>
@@ -6314,7 +5733,7 @@
               </a:rPr>
               <a:t>Gartner: over 70% of recent ERP initiatives miss their original business case goals. The system of record can't be trusted because the data model drifts every time anyone customizes anything.</a:t>
             </a:r>
-            <a:endParaRPr lang="en-US" sz="1250" dirty="0"/>
+            <a:endParaRPr lang="en-US" sz="1800" dirty="0"/>
           </a:p>
         </p:txBody>
       </p:sp>
@@ -6374,7 +5793,7 @@
               <a:buNone/>
             </a:pPr>
             <a:r>
-              <a:rPr lang="en-US" sz="1700" b="1" dirty="0">
+              <a:rPr lang="en-US" sz="1800" b="1" dirty="0">
                 <a:solidFill>
                   <a:srgbClr val="F4F8FB"/>
                 </a:solidFill>
@@ -6384,7 +5803,7 @@
               </a:rPr>
               <a:t>What's in place today</a:t>
             </a:r>
-            <a:endParaRPr lang="en-US" sz="1700" dirty="0"/>
+            <a:endParaRPr lang="en-US" sz="1800" dirty="0"/>
           </a:p>
         </p:txBody>
       </p:sp>
@@ -6415,7 +5834,7 @@
               <a:buNone/>
             </a:pPr>
             <a:r>
-              <a:rPr lang="en-US" sz="1350" dirty="0">
+              <a:rPr lang="en-US" sz="1800" dirty="0">
                 <a:solidFill>
                   <a:srgbClr val="A9BED0"/>
                 </a:solidFill>
@@ -6430,7 +5849,7 @@
               <a:buNone/>
             </a:pPr>
             <a:r>
-              <a:rPr lang="en-US" sz="1350" dirty="0">
+              <a:rPr lang="en-US" sz="1800" dirty="0">
                 <a:solidFill>
                   <a:srgbClr val="A9BED0"/>
                 </a:solidFill>
@@ -6445,7 +5864,7 @@
               <a:buNone/>
             </a:pPr>
             <a:r>
-              <a:rPr lang="en-US" sz="1350" dirty="0">
+              <a:rPr lang="en-US" sz="1800" dirty="0">
                 <a:solidFill>
                   <a:srgbClr val="A9BED0"/>
                 </a:solidFill>
@@ -6460,7 +5879,7 @@
               <a:buNone/>
             </a:pPr>
             <a:r>
-              <a:rPr lang="en-US" sz="1350" dirty="0">
+              <a:rPr lang="en-US" sz="1800" dirty="0">
                 <a:solidFill>
                   <a:srgbClr val="A9BED0"/>
                 </a:solidFill>
@@ -6470,7 +5889,7 @@
               </a:rPr>
               <a:t>• Audit trails as aspiration</a:t>
             </a:r>
-            <a:endParaRPr lang="en-US" sz="1350" dirty="0"/>
+            <a:endParaRPr lang="en-US" sz="1800" dirty="0"/>
           </a:p>
         </p:txBody>
       </p:sp>
@@ -6530,7 +5949,7 @@
               <a:buNone/>
             </a:pPr>
             <a:r>
-              <a:rPr lang="en-US" sz="1700" b="1" dirty="0">
+              <a:rPr lang="en-US" sz="1800" b="1" dirty="0">
                 <a:solidFill>
                   <a:srgbClr val="F4F8FB"/>
                 </a:solidFill>
@@ -6540,7 +5959,7 @@
               </a:rPr>
               <a:t>Why it breaks</a:t>
             </a:r>
-            <a:endParaRPr lang="en-US" sz="1700" dirty="0"/>
+            <a:endParaRPr lang="en-US" sz="1800" dirty="0"/>
           </a:p>
         </p:txBody>
       </p:sp>
@@ -6571,7 +5990,7 @@
               <a:buNone/>
             </a:pPr>
             <a:r>
-              <a:rPr lang="en-US" sz="1350" dirty="0">
+              <a:rPr lang="en-US" sz="1800" dirty="0">
                 <a:solidFill>
                   <a:srgbClr val="A9BED0"/>
                 </a:solidFill>
@@ -6586,7 +6005,7 @@
               <a:buNone/>
             </a:pPr>
             <a:r>
-              <a:rPr lang="en-US" sz="1350" dirty="0">
+              <a:rPr lang="en-US" sz="1800" dirty="0">
                 <a:solidFill>
                   <a:srgbClr val="A9BED0"/>
                 </a:solidFill>
@@ -6601,7 +6020,7 @@
               <a:buNone/>
             </a:pPr>
             <a:r>
-              <a:rPr lang="en-US" sz="1350" dirty="0">
+              <a:rPr lang="en-US" sz="1800" dirty="0">
                 <a:solidFill>
                   <a:srgbClr val="A9BED0"/>
                 </a:solidFill>
@@ -6616,7 +6035,7 @@
               <a:buNone/>
             </a:pPr>
             <a:r>
-              <a:rPr lang="en-US" sz="1350" dirty="0">
+              <a:rPr lang="en-US" sz="1800" dirty="0">
                 <a:solidFill>
                   <a:srgbClr val="A9BED0"/>
                 </a:solidFill>
@@ -6626,7 +6045,7 @@
               </a:rPr>
               <a:t>• Decision authority outside the system</a:t>
             </a:r>
-            <a:endParaRPr lang="en-US" sz="1350" dirty="0"/>
+            <a:endParaRPr lang="en-US" sz="1800" dirty="0"/>
           </a:p>
         </p:txBody>
       </p:sp>
@@ -6686,7 +6105,7 @@
               <a:buNone/>
             </a:pPr>
             <a:r>
-              <a:rPr lang="en-US" sz="1700" b="1" dirty="0">
+              <a:rPr lang="en-US" sz="1800" b="1" dirty="0">
                 <a:solidFill>
                   <a:srgbClr val="F4F8FB"/>
                 </a:solidFill>
@@ -6696,7 +6115,7 @@
               </a:rPr>
               <a:t>Compounding cost</a:t>
             </a:r>
-            <a:endParaRPr lang="en-US" sz="1700" dirty="0"/>
+            <a:endParaRPr lang="en-US" sz="1800" dirty="0"/>
           </a:p>
         </p:txBody>
       </p:sp>
@@ -6727,7 +6146,7 @@
               <a:buNone/>
             </a:pPr>
             <a:r>
-              <a:rPr lang="en-US" sz="1350" dirty="0">
+              <a:rPr lang="en-US" sz="1800" dirty="0">
                 <a:solidFill>
                   <a:srgbClr val="A9BED0"/>
                 </a:solidFill>
@@ -6742,7 +6161,7 @@
               <a:buNone/>
             </a:pPr>
             <a:r>
-              <a:rPr lang="en-US" sz="1350" dirty="0">
+              <a:rPr lang="en-US" sz="1800" dirty="0">
                 <a:solidFill>
                   <a:srgbClr val="A9BED0"/>
                 </a:solidFill>
@@ -6757,7 +6176,7 @@
               <a:buNone/>
             </a:pPr>
             <a:r>
-              <a:rPr lang="en-US" sz="1350" dirty="0">
+              <a:rPr lang="en-US" sz="1800" dirty="0">
                 <a:solidFill>
                   <a:srgbClr val="A9BED0"/>
                 </a:solidFill>
@@ -6772,7 +6191,7 @@
               <a:buNone/>
             </a:pPr>
             <a:r>
-              <a:rPr lang="en-US" sz="1350" dirty="0">
+              <a:rPr lang="en-US" sz="1800" dirty="0">
                 <a:solidFill>
                   <a:srgbClr val="A9BED0"/>
                 </a:solidFill>
@@ -6782,7 +6201,7 @@
               </a:rPr>
               <a:t>• AI built on this surface multiplies wrong answers</a:t>
             </a:r>
-            <a:endParaRPr lang="en-US" sz="1350" dirty="0"/>
+            <a:endParaRPr lang="en-US" sz="1800" dirty="0"/>
           </a:p>
         </p:txBody>
       </p:sp>
@@ -7047,89 +6466,6 @@
       </p:sp>
       <p:sp>
         <p:nvSpPr>
-          <p:cNvPr id="4" name="Shape 2"/>
-          <p:cNvSpPr/>
-          <p:nvPr/>
-        </p:nvSpPr>
-        <p:spPr>
-          <a:xfrm>
-            <a:off x="8275320" y="137160"/>
-            <a:ext cx="3611880" cy="3611880"/>
-          </a:xfrm>
-          <a:prstGeom prst="arc">
-            <a:avLst/>
-          </a:prstGeom>
-          <a:solidFill>
-            <a:srgbClr val="08131F">
-              <a:alpha val="0"/>
-            </a:srgbClr>
-          </a:solidFill>
-          <a:ln w="13970">
-            <a:solidFill>
-              <a:srgbClr val="123D5A">
-                <a:alpha val="65000"/>
-              </a:srgbClr>
-            </a:solidFill>
-            <a:prstDash val="solid"/>
-          </a:ln>
-        </p:spPr>
-      </p:sp>
-      <p:sp>
-        <p:nvSpPr>
-          <p:cNvPr id="5" name="Shape 3"/>
-          <p:cNvSpPr/>
-          <p:nvPr/>
-        </p:nvSpPr>
-        <p:spPr>
-          <a:xfrm>
-            <a:off x="8641080" y="475488"/>
-            <a:ext cx="2834640" cy="2834640"/>
-          </a:xfrm>
-          <a:prstGeom prst="arc">
-            <a:avLst/>
-          </a:prstGeom>
-          <a:solidFill>
-            <a:srgbClr val="08131F">
-              <a:alpha val="0"/>
-            </a:srgbClr>
-          </a:solidFill>
-          <a:ln w="10160">
-            <a:solidFill>
-              <a:srgbClr val="2DE2D1">
-                <a:alpha val="28000"/>
-              </a:srgbClr>
-            </a:solidFill>
-            <a:prstDash val="solid"/>
-          </a:ln>
-        </p:spPr>
-      </p:sp>
-      <p:sp>
-        <p:nvSpPr>
-          <p:cNvPr id="6" name="Shape 4"/>
-          <p:cNvSpPr/>
-          <p:nvPr/>
-        </p:nvSpPr>
-        <p:spPr>
-          <a:xfrm>
-            <a:off x="8138160" y="731520"/>
-            <a:ext cx="3291840" cy="0"/>
-          </a:xfrm>
-          <a:prstGeom prst="line">
-            <a:avLst/>
-          </a:prstGeom>
-          <a:noFill/>
-          <a:ln w="12700">
-            <a:solidFill>
-              <a:srgbClr val="123D5A">
-                <a:alpha val="55000"/>
-              </a:srgbClr>
-            </a:solidFill>
-            <a:prstDash val="solid"/>
-          </a:ln>
-        </p:spPr>
-      </p:sp>
-      <p:sp>
-        <p:nvSpPr>
           <p:cNvPr id="7" name="Text 5"/>
           <p:cNvSpPr/>
           <p:nvPr/>
@@ -7196,7 +6532,7 @@
               <a:buNone/>
             </a:pPr>
             <a:r>
-              <a:rPr lang="en-US" sz="1250" dirty="0">
+              <a:rPr lang="en-US" sz="1800" dirty="0">
                 <a:solidFill>
                   <a:srgbClr val="A9BED0"/>
                 </a:solidFill>
@@ -7206,7 +6542,7 @@
               </a:rPr>
               <a:t>Three conditions every governable ERP must satisfy. We built each one in running code.</a:t>
             </a:r>
-            <a:endParaRPr lang="en-US" sz="1250" dirty="0"/>
+            <a:endParaRPr lang="en-US" sz="1800" dirty="0"/>
           </a:p>
         </p:txBody>
       </p:sp>
@@ -7307,7 +6643,7 @@
               <a:buNone/>
             </a:pPr>
             <a:r>
-              <a:rPr lang="en-US" sz="1300" dirty="0">
+              <a:rPr lang="en-US" sz="1800" dirty="0">
                 <a:solidFill>
                   <a:srgbClr val="F4F8FB"/>
                 </a:solidFill>
@@ -7322,7 +6658,7 @@
               <a:buNone/>
             </a:pPr>
             <a:r>
-              <a:rPr lang="en-US" sz="1300" dirty="0">
+              <a:rPr lang="en-US" sz="1800" dirty="0">
                 <a:solidFill>
                   <a:srgbClr val="F4F8FB"/>
                 </a:solidFill>
@@ -7337,7 +6673,7 @@
               <a:buNone/>
             </a:pPr>
             <a:r>
-              <a:rPr lang="en-US" sz="1300" dirty="0">
+              <a:rPr lang="en-US" sz="1800" dirty="0">
                 <a:solidFill>
                   <a:srgbClr val="F4F8FB"/>
                 </a:solidFill>
@@ -7352,7 +6688,7 @@
               <a:buNone/>
             </a:pPr>
             <a:r>
-              <a:rPr lang="en-US" sz="1300" dirty="0">
+              <a:rPr lang="en-US" sz="1800" dirty="0">
                 <a:solidFill>
                   <a:srgbClr val="F4F8FB"/>
                 </a:solidFill>
@@ -7362,7 +6698,7 @@
               </a:rPr>
               <a:t>• Tenant label overrides without schema drift</a:t>
             </a:r>
-            <a:endParaRPr lang="en-US" sz="1300" dirty="0"/>
+            <a:endParaRPr lang="en-US" sz="1800" dirty="0"/>
           </a:p>
         </p:txBody>
       </p:sp>
@@ -7463,7 +6799,7 @@
               <a:buNone/>
             </a:pPr>
             <a:r>
-              <a:rPr lang="en-US" sz="1300" dirty="0">
+              <a:rPr lang="en-US" sz="1800" dirty="0">
                 <a:solidFill>
                   <a:srgbClr val="F4F8FB"/>
                 </a:solidFill>
@@ -7478,7 +6814,7 @@
               <a:buNone/>
             </a:pPr>
             <a:r>
-              <a:rPr lang="en-US" sz="1300" dirty="0">
+              <a:rPr lang="en-US" sz="1800" dirty="0">
                 <a:solidFill>
                   <a:srgbClr val="F4F8FB"/>
                 </a:solidFill>
@@ -7493,7 +6829,7 @@
               <a:buNone/>
             </a:pPr>
             <a:r>
-              <a:rPr lang="en-US" sz="1300" dirty="0">
+              <a:rPr lang="en-US" sz="1800" dirty="0">
                 <a:solidFill>
                   <a:srgbClr val="F4F8FB"/>
                 </a:solidFill>
@@ -7508,7 +6844,7 @@
               <a:buNone/>
             </a:pPr>
             <a:r>
-              <a:rPr lang="en-US" sz="1300" dirty="0">
+              <a:rPr lang="en-US" sz="1800" dirty="0">
                 <a:solidFill>
                   <a:srgbClr val="F4F8FB"/>
                 </a:solidFill>
@@ -7518,7 +6854,7 @@
               </a:rPr>
               <a:t>• Tenant-scoped predicates and approvals</a:t>
             </a:r>
-            <a:endParaRPr lang="en-US" sz="1300" dirty="0"/>
+            <a:endParaRPr lang="en-US" sz="1800" dirty="0"/>
           </a:p>
         </p:txBody>
       </p:sp>
@@ -7619,7 +6955,7 @@
               <a:buNone/>
             </a:pPr>
             <a:r>
-              <a:rPr lang="en-US" sz="1300" dirty="0">
+              <a:rPr lang="en-US" sz="1800" dirty="0">
                 <a:solidFill>
                   <a:srgbClr val="F4F8FB"/>
                 </a:solidFill>
@@ -7634,7 +6970,7 @@
               <a:buNone/>
             </a:pPr>
             <a:r>
-              <a:rPr lang="en-US" sz="1300" dirty="0">
+              <a:rPr lang="en-US" sz="1800" dirty="0">
                 <a:solidFill>
                   <a:srgbClr val="F4F8FB"/>
                 </a:solidFill>
@@ -7649,7 +6985,7 @@
               <a:buNone/>
             </a:pPr>
             <a:r>
-              <a:rPr lang="en-US" sz="1300" dirty="0">
+              <a:rPr lang="en-US" sz="1800" dirty="0">
                 <a:solidFill>
                   <a:srgbClr val="F4F8FB"/>
                 </a:solidFill>
@@ -7664,7 +7000,7 @@
               <a:buNone/>
             </a:pPr>
             <a:r>
-              <a:rPr lang="en-US" sz="1300" dirty="0">
+              <a:rPr lang="en-US" sz="1800" dirty="0">
                 <a:solidFill>
                   <a:srgbClr val="F4F8FB"/>
                 </a:solidFill>
@@ -7674,7 +7010,7 @@
               </a:rPr>
               <a:t>• Standard Library: SOX, AS9100, CMMC, ITAR, …</a:t>
             </a:r>
-            <a:endParaRPr lang="en-US" sz="1300" dirty="0"/>
+            <a:endParaRPr lang="en-US" sz="1800" dirty="0"/>
           </a:p>
         </p:txBody>
       </p:sp>
@@ -7889,89 +7225,6 @@
       </p:sp>
       <p:sp>
         <p:nvSpPr>
-          <p:cNvPr id="4" name="Shape 2"/>
-          <p:cNvSpPr/>
-          <p:nvPr/>
-        </p:nvSpPr>
-        <p:spPr>
-          <a:xfrm>
-            <a:off x="8275320" y="137160"/>
-            <a:ext cx="3611880" cy="3611880"/>
-          </a:xfrm>
-          <a:prstGeom prst="arc">
-            <a:avLst/>
-          </a:prstGeom>
-          <a:solidFill>
-            <a:srgbClr val="08131F">
-              <a:alpha val="0"/>
-            </a:srgbClr>
-          </a:solidFill>
-          <a:ln w="13970">
-            <a:solidFill>
-              <a:srgbClr val="123D5A">
-                <a:alpha val="65000"/>
-              </a:srgbClr>
-            </a:solidFill>
-            <a:prstDash val="solid"/>
-          </a:ln>
-        </p:spPr>
-      </p:sp>
-      <p:sp>
-        <p:nvSpPr>
-          <p:cNvPr id="5" name="Shape 3"/>
-          <p:cNvSpPr/>
-          <p:nvPr/>
-        </p:nvSpPr>
-        <p:spPr>
-          <a:xfrm>
-            <a:off x="8641080" y="475488"/>
-            <a:ext cx="2834640" cy="2834640"/>
-          </a:xfrm>
-          <a:prstGeom prst="arc">
-            <a:avLst/>
-          </a:prstGeom>
-          <a:solidFill>
-            <a:srgbClr val="08131F">
-              <a:alpha val="0"/>
-            </a:srgbClr>
-          </a:solidFill>
-          <a:ln w="10160">
-            <a:solidFill>
-              <a:srgbClr val="2DE2D1">
-                <a:alpha val="28000"/>
-              </a:srgbClr>
-            </a:solidFill>
-            <a:prstDash val="solid"/>
-          </a:ln>
-        </p:spPr>
-      </p:sp>
-      <p:sp>
-        <p:nvSpPr>
-          <p:cNvPr id="6" name="Shape 4"/>
-          <p:cNvSpPr/>
-          <p:nvPr/>
-        </p:nvSpPr>
-        <p:spPr>
-          <a:xfrm>
-            <a:off x="8138160" y="731520"/>
-            <a:ext cx="3291840" cy="0"/>
-          </a:xfrm>
-          <a:prstGeom prst="line">
-            <a:avLst/>
-          </a:prstGeom>
-          <a:noFill/>
-          <a:ln w="12700">
-            <a:solidFill>
-              <a:srgbClr val="123D5A">
-                <a:alpha val="55000"/>
-              </a:srgbClr>
-            </a:solidFill>
-            <a:prstDash val="solid"/>
-          </a:ln>
-        </p:spPr>
-      </p:sp>
-      <p:sp>
-        <p:nvSpPr>
           <p:cNvPr id="7" name="Text 5"/>
           <p:cNvSpPr/>
           <p:nvPr/>
@@ -8038,7 +7291,7 @@
               <a:buNone/>
             </a:pPr>
             <a:r>
-              <a:rPr lang="en-US" sz="1250" dirty="0">
+              <a:rPr lang="en-US" sz="1800" dirty="0">
                 <a:solidFill>
                   <a:srgbClr val="A9BED0"/>
                 </a:solidFill>
@@ -8048,7 +7301,7 @@
               </a:rPr>
               <a:t>The new deck centers on Ratatosk as the entry point and Yggdrasil ERP as the governed reference implementation.</a:t>
             </a:r>
-            <a:endParaRPr lang="en-US" sz="1250" dirty="0"/>
+            <a:endParaRPr lang="en-US" sz="1800" dirty="0"/>
           </a:p>
         </p:txBody>
       </p:sp>
@@ -8108,7 +7361,7 @@
               <a:buNone/>
             </a:pPr>
             <a:r>
-              <a:rPr lang="en-US" sz="1300" b="1" dirty="0">
+              <a:rPr lang="en-US" sz="1800" b="1" dirty="0">
                 <a:solidFill>
                   <a:srgbClr val="F6C65B"/>
                 </a:solidFill>
@@ -8118,7 +7371,7 @@
               </a:rPr>
               <a:t>Ratatosk</a:t>
             </a:r>
-            <a:endParaRPr lang="en-US" sz="1300" dirty="0"/>
+            <a:endParaRPr lang="en-US" sz="1800" dirty="0"/>
           </a:p>
         </p:txBody>
       </p:sp>
@@ -8244,7 +7497,7 @@
               <a:buNone/>
             </a:pPr>
             <a:r>
-              <a:rPr lang="en-US" sz="1300" b="1" dirty="0">
+              <a:rPr lang="en-US" sz="1800" b="1" dirty="0">
                 <a:solidFill>
                   <a:srgbClr val="2DE2D1"/>
                 </a:solidFill>
@@ -8254,7 +7507,7 @@
               </a:rPr>
               <a:t>Ragnarok</a:t>
             </a:r>
-            <a:endParaRPr lang="en-US" sz="1300" dirty="0"/>
+            <a:endParaRPr lang="en-US" sz="1800" dirty="0"/>
           </a:p>
         </p:txBody>
       </p:sp>
@@ -8380,7 +7633,7 @@
               <a:buNone/>
             </a:pPr>
             <a:r>
-              <a:rPr lang="en-US" sz="1300" b="1" dirty="0">
+              <a:rPr lang="en-US" sz="1800" b="1" dirty="0">
                 <a:solidFill>
                   <a:srgbClr val="2DE2D1"/>
                 </a:solidFill>
@@ -8390,7 +7643,7 @@
               </a:rPr>
               <a:t>Bifrost</a:t>
             </a:r>
-            <a:endParaRPr lang="en-US" sz="1300" dirty="0"/>
+            <a:endParaRPr lang="en-US" sz="1800" dirty="0"/>
           </a:p>
         </p:txBody>
       </p:sp>
@@ -8516,7 +7769,7 @@
               <a:buNone/>
             </a:pPr>
             <a:r>
-              <a:rPr lang="en-US" sz="1300" b="1" dirty="0">
+              <a:rPr lang="en-US" sz="1800" b="1" dirty="0">
                 <a:solidFill>
                   <a:srgbClr val="2DE2D1"/>
                 </a:solidFill>
@@ -8526,7 +7779,7 @@
               </a:rPr>
               <a:t>Yggdrasil ERP</a:t>
             </a:r>
-            <a:endParaRPr lang="en-US" sz="1300" dirty="0"/>
+            <a:endParaRPr lang="en-US" sz="1800" dirty="0"/>
           </a:p>
         </p:txBody>
       </p:sp>
@@ -8652,7 +7905,7 @@
               <a:buNone/>
             </a:pPr>
             <a:r>
-              <a:rPr lang="en-US" sz="1300" b="1" dirty="0">
+              <a:rPr lang="en-US" sz="1800" b="1" dirty="0">
                 <a:solidFill>
                   <a:srgbClr val="2DE2D1"/>
                 </a:solidFill>
@@ -8662,7 +7915,7 @@
               </a:rPr>
               <a:t>Jormungandr</a:t>
             </a:r>
-            <a:endParaRPr lang="en-US" sz="1300" dirty="0"/>
+            <a:endParaRPr lang="en-US" sz="1800" dirty="0"/>
           </a:p>
         </p:txBody>
       </p:sp>
@@ -8788,7 +8041,7 @@
               <a:buNone/>
             </a:pPr>
             <a:r>
-              <a:rPr lang="en-US" sz="1300" b="1" dirty="0">
+              <a:rPr lang="en-US" sz="1800" b="1" dirty="0">
                 <a:solidFill>
                   <a:srgbClr val="2DE2D1"/>
                 </a:solidFill>
@@ -8798,7 +8051,7 @@
               </a:rPr>
               <a:t>Norn</a:t>
             </a:r>
-            <a:endParaRPr lang="en-US" sz="1300" dirty="0"/>
+            <a:endParaRPr lang="en-US" sz="1800" dirty="0"/>
           </a:p>
         </p:txBody>
       </p:sp>
@@ -9054,89 +8307,6 @@
       </p:sp>
       <p:sp>
         <p:nvSpPr>
-          <p:cNvPr id="4" name="Shape 2"/>
-          <p:cNvSpPr/>
-          <p:nvPr/>
-        </p:nvSpPr>
-        <p:spPr>
-          <a:xfrm>
-            <a:off x="8275320" y="137160"/>
-            <a:ext cx="3611880" cy="3611880"/>
-          </a:xfrm>
-          <a:prstGeom prst="arc">
-            <a:avLst/>
-          </a:prstGeom>
-          <a:solidFill>
-            <a:srgbClr val="08131F">
-              <a:alpha val="0"/>
-            </a:srgbClr>
-          </a:solidFill>
-          <a:ln w="13970">
-            <a:solidFill>
-              <a:srgbClr val="123D5A">
-                <a:alpha val="65000"/>
-              </a:srgbClr>
-            </a:solidFill>
-            <a:prstDash val="solid"/>
-          </a:ln>
-        </p:spPr>
-      </p:sp>
-      <p:sp>
-        <p:nvSpPr>
-          <p:cNvPr id="5" name="Shape 3"/>
-          <p:cNvSpPr/>
-          <p:nvPr/>
-        </p:nvSpPr>
-        <p:spPr>
-          <a:xfrm>
-            <a:off x="8641080" y="475488"/>
-            <a:ext cx="2834640" cy="2834640"/>
-          </a:xfrm>
-          <a:prstGeom prst="arc">
-            <a:avLst/>
-          </a:prstGeom>
-          <a:solidFill>
-            <a:srgbClr val="08131F">
-              <a:alpha val="0"/>
-            </a:srgbClr>
-          </a:solidFill>
-          <a:ln w="10160">
-            <a:solidFill>
-              <a:srgbClr val="2DE2D1">
-                <a:alpha val="28000"/>
-              </a:srgbClr>
-            </a:solidFill>
-            <a:prstDash val="solid"/>
-          </a:ln>
-        </p:spPr>
-      </p:sp>
-      <p:sp>
-        <p:nvSpPr>
-          <p:cNvPr id="6" name="Shape 4"/>
-          <p:cNvSpPr/>
-          <p:nvPr/>
-        </p:nvSpPr>
-        <p:spPr>
-          <a:xfrm>
-            <a:off x="8138160" y="731520"/>
-            <a:ext cx="3291840" cy="0"/>
-          </a:xfrm>
-          <a:prstGeom prst="line">
-            <a:avLst/>
-          </a:prstGeom>
-          <a:noFill/>
-          <a:ln w="12700">
-            <a:solidFill>
-              <a:srgbClr val="123D5A">
-                <a:alpha val="55000"/>
-              </a:srgbClr>
-            </a:solidFill>
-            <a:prstDash val="solid"/>
-          </a:ln>
-        </p:spPr>
-      </p:sp>
-      <p:sp>
-        <p:nvSpPr>
           <p:cNvPr id="7" name="Text 5"/>
           <p:cNvSpPr/>
           <p:nvPr/>
@@ -9203,7 +8373,7 @@
               <a:buNone/>
             </a:pPr>
             <a:r>
-              <a:rPr lang="en-US" sz="1250" dirty="0">
+              <a:rPr lang="en-US" sz="1800" dirty="0">
                 <a:solidFill>
                   <a:srgbClr val="A9BED0"/>
                 </a:solidFill>
@@ -9213,7 +8383,7 @@
               </a:rPr>
               <a:t>Operational Policy Enforcement: signed administrative decisions compile to runtime constraints, roles, approval flows, and workflow templates. Shipped May 2026.</a:t>
             </a:r>
-            <a:endParaRPr lang="en-US" sz="1250" dirty="0"/>
+            <a:endParaRPr lang="en-US" sz="1800" dirty="0"/>
           </a:p>
         </p:txBody>
       </p:sp>
@@ -9314,7 +8484,7 @@
               <a:buNone/>
             </a:pPr>
             <a:r>
-              <a:rPr lang="en-US" sz="1400" dirty="0">
+              <a:rPr lang="en-US" sz="1800" dirty="0">
                 <a:solidFill>
                   <a:srgbClr val="F4F8FB"/>
                 </a:solidFill>
@@ -9329,7 +8499,7 @@
               <a:buNone/>
             </a:pPr>
             <a:r>
-              <a:rPr lang="en-US" sz="1400" dirty="0">
+              <a:rPr lang="en-US" sz="1800" dirty="0">
                 <a:solidFill>
                   <a:srgbClr val="F4F8FB"/>
                 </a:solidFill>
@@ -9344,7 +8514,7 @@
               <a:buNone/>
             </a:pPr>
             <a:r>
-              <a:rPr lang="en-US" sz="1400" dirty="0">
+              <a:rPr lang="en-US" sz="1800" dirty="0">
                 <a:solidFill>
                   <a:srgbClr val="F4F8FB"/>
                 </a:solidFill>
@@ -9359,7 +8529,7 @@
               <a:buNone/>
             </a:pPr>
             <a:r>
-              <a:rPr lang="en-US" sz="1400" dirty="0">
+              <a:rPr lang="en-US" sz="1800" dirty="0">
                 <a:solidFill>
                   <a:srgbClr val="F4F8FB"/>
                 </a:solidFill>
@@ -9374,7 +8544,7 @@
               <a:buNone/>
             </a:pPr>
             <a:r>
-              <a:rPr lang="en-US" sz="1400" dirty="0">
+              <a:rPr lang="en-US" sz="1800" dirty="0">
                 <a:solidFill>
                   <a:srgbClr val="F4F8FB"/>
                 </a:solidFill>
@@ -9384,7 +8554,7 @@
               </a:rPr>
               <a:t>• Tribal memory</a:t>
             </a:r>
-            <a:endParaRPr lang="en-US" sz="1400" dirty="0"/>
+            <a:endParaRPr lang="en-US" sz="1800" dirty="0"/>
           </a:p>
         </p:txBody>
       </p:sp>
@@ -9485,7 +8655,7 @@
               <a:buNone/>
             </a:pPr>
             <a:r>
-              <a:rPr lang="en-US" sz="1400" dirty="0">
+              <a:rPr lang="en-US" sz="1800" dirty="0">
                 <a:solidFill>
                   <a:srgbClr val="F4F8FB"/>
                 </a:solidFill>
@@ -9500,7 +8670,7 @@
               <a:buNone/>
             </a:pPr>
             <a:r>
-              <a:rPr lang="en-US" sz="1400" dirty="0">
+              <a:rPr lang="en-US" sz="1800" dirty="0">
                 <a:solidFill>
                   <a:srgbClr val="F4F8FB"/>
                 </a:solidFill>
@@ -9515,7 +8685,7 @@
               <a:buNone/>
             </a:pPr>
             <a:r>
-              <a:rPr lang="en-US" sz="1400" dirty="0">
+              <a:rPr lang="en-US" sz="1800" dirty="0">
                 <a:solidFill>
                   <a:srgbClr val="F4F8FB"/>
                 </a:solidFill>
@@ -9530,7 +8700,7 @@
               <a:buNone/>
             </a:pPr>
             <a:r>
-              <a:rPr lang="en-US" sz="1400" dirty="0">
+              <a:rPr lang="en-US" sz="1800" dirty="0">
                 <a:solidFill>
                   <a:srgbClr val="F4F8FB"/>
                 </a:solidFill>
@@ -9545,7 +8715,7 @@
               <a:buNone/>
             </a:pPr>
             <a:r>
-              <a:rPr lang="en-US" sz="1400" dirty="0">
+              <a:rPr lang="en-US" sz="1800" dirty="0">
                 <a:solidFill>
                   <a:srgbClr val="F4F8FB"/>
                 </a:solidFill>
@@ -9555,7 +8725,7 @@
               </a:rPr>
               <a:t>• Signed lifecycle: draft → active → superseded</a:t>
             </a:r>
-            <a:endParaRPr lang="en-US" sz="1400" dirty="0"/>
+            <a:endParaRPr lang="en-US" sz="1800" dirty="0"/>
           </a:p>
         </p:txBody>
       </p:sp>
@@ -9656,7 +8826,7 @@
               <a:buNone/>
             </a:pPr>
             <a:r>
-              <a:rPr lang="en-US" sz="1400" dirty="0">
+              <a:rPr lang="en-US" sz="1800" dirty="0">
                 <a:solidFill>
                   <a:srgbClr val="F4F8FB"/>
                 </a:solidFill>
@@ -9671,7 +8841,7 @@
               <a:buNone/>
             </a:pPr>
             <a:r>
-              <a:rPr lang="en-US" sz="1400" dirty="0">
+              <a:rPr lang="en-US" sz="1800" dirty="0">
                 <a:solidFill>
                   <a:srgbClr val="F4F8FB"/>
                 </a:solidFill>
@@ -9686,7 +8856,7 @@
               <a:buNone/>
             </a:pPr>
             <a:r>
-              <a:rPr lang="en-US" sz="1400" dirty="0">
+              <a:rPr lang="en-US" sz="1800" dirty="0">
                 <a:solidFill>
                   <a:srgbClr val="F4F8FB"/>
                 </a:solidFill>
@@ -9701,7 +8871,7 @@
               <a:buNone/>
             </a:pPr>
             <a:r>
-              <a:rPr lang="en-US" sz="1400" dirty="0">
+              <a:rPr lang="en-US" sz="1800" dirty="0">
                 <a:solidFill>
                   <a:srgbClr val="F4F8FB"/>
                 </a:solidFill>
@@ -9716,7 +8886,7 @@
               <a:buNone/>
             </a:pPr>
             <a:r>
-              <a:rPr lang="en-US" sz="1400" dirty="0">
+              <a:rPr lang="en-US" sz="1800" dirty="0">
                 <a:solidFill>
                   <a:srgbClr val="F4F8FB"/>
                 </a:solidFill>
@@ -9726,7 +8896,7 @@
               </a:rPr>
               <a:t>• Audited (per-field)</a:t>
             </a:r>
-            <a:endParaRPr lang="en-US" sz="1400" dirty="0"/>
+            <a:endParaRPr lang="en-US" sz="1800" dirty="0"/>
           </a:p>
         </p:txBody>
       </p:sp>
@@ -9807,7 +8977,7 @@
               <a:buNone/>
             </a:pPr>
             <a:r>
-              <a:rPr lang="en-US" sz="1520" dirty="0">
+              <a:rPr lang="en-US" sz="1800" dirty="0">
                 <a:solidFill>
                   <a:srgbClr val="A9BED0"/>
                 </a:solidFill>
@@ -9817,7 +8987,7 @@
               </a:rPr>
               <a:t>Eight Standard Library templates ship today across SOX, AS9100, AS9102, ISO 9001, CMMC, and OFAC. Mimisbrunnr carries the controls vocabulary.</a:t>
             </a:r>
-            <a:endParaRPr lang="en-US" sz="1520" dirty="0"/>
+            <a:endParaRPr lang="en-US" sz="1800" dirty="0"/>
           </a:p>
         </p:txBody>
       </p:sp>
@@ -9991,89 +9161,6 @@
       </p:sp>
       <p:sp>
         <p:nvSpPr>
-          <p:cNvPr id="4" name="Shape 2"/>
-          <p:cNvSpPr/>
-          <p:nvPr/>
-        </p:nvSpPr>
-        <p:spPr>
-          <a:xfrm>
-            <a:off x="8275320" y="137160"/>
-            <a:ext cx="3611880" cy="3611880"/>
-          </a:xfrm>
-          <a:prstGeom prst="arc">
-            <a:avLst/>
-          </a:prstGeom>
-          <a:solidFill>
-            <a:srgbClr val="08131F">
-              <a:alpha val="0"/>
-            </a:srgbClr>
-          </a:solidFill>
-          <a:ln w="13970">
-            <a:solidFill>
-              <a:srgbClr val="123D5A">
-                <a:alpha val="65000"/>
-              </a:srgbClr>
-            </a:solidFill>
-            <a:prstDash val="solid"/>
-          </a:ln>
-        </p:spPr>
-      </p:sp>
-      <p:sp>
-        <p:nvSpPr>
-          <p:cNvPr id="5" name="Shape 3"/>
-          <p:cNvSpPr/>
-          <p:nvPr/>
-        </p:nvSpPr>
-        <p:spPr>
-          <a:xfrm>
-            <a:off x="8641080" y="475488"/>
-            <a:ext cx="2834640" cy="2834640"/>
-          </a:xfrm>
-          <a:prstGeom prst="arc">
-            <a:avLst/>
-          </a:prstGeom>
-          <a:solidFill>
-            <a:srgbClr val="08131F">
-              <a:alpha val="0"/>
-            </a:srgbClr>
-          </a:solidFill>
-          <a:ln w="10160">
-            <a:solidFill>
-              <a:srgbClr val="2DE2D1">
-                <a:alpha val="28000"/>
-              </a:srgbClr>
-            </a:solidFill>
-            <a:prstDash val="solid"/>
-          </a:ln>
-        </p:spPr>
-      </p:sp>
-      <p:sp>
-        <p:nvSpPr>
-          <p:cNvPr id="6" name="Shape 4"/>
-          <p:cNvSpPr/>
-          <p:nvPr/>
-        </p:nvSpPr>
-        <p:spPr>
-          <a:xfrm>
-            <a:off x="8138160" y="731520"/>
-            <a:ext cx="3291840" cy="0"/>
-          </a:xfrm>
-          <a:prstGeom prst="line">
-            <a:avLst/>
-          </a:prstGeom>
-          <a:noFill/>
-          <a:ln w="12700">
-            <a:solidFill>
-              <a:srgbClr val="123D5A">
-                <a:alpha val="55000"/>
-              </a:srgbClr>
-            </a:solidFill>
-            <a:prstDash val="solid"/>
-          </a:ln>
-        </p:spPr>
-      </p:sp>
-      <p:sp>
-        <p:nvSpPr>
           <p:cNvPr id="7" name="Text 5"/>
           <p:cNvSpPr/>
           <p:nvPr/>
@@ -10140,7 +9227,7 @@
               <a:buNone/>
             </a:pPr>
             <a:r>
-              <a:rPr lang="en-US" sz="1250" dirty="0">
+              <a:rPr lang="en-US" sz="1800" dirty="0">
                 <a:solidFill>
                   <a:srgbClr val="A9BED0"/>
                 </a:solidFill>
@@ -10150,7 +9237,7 @@
               </a:rPr>
               <a:t>Manufacturing ERP is a large, established market where mid-market manufacturers (10–500 employees) are systematically failed by incumbents. We sell into that gap.</a:t>
             </a:r>
-            <a:endParaRPr lang="en-US" sz="1250" dirty="0"/>
+            <a:endParaRPr lang="en-US" sz="1800" dirty="0"/>
           </a:p>
         </p:txBody>
       </p:sp>
@@ -10251,7 +9338,7 @@
               <a:buNone/>
             </a:pPr>
             <a:r>
-              <a:rPr lang="en-US" sz="1300" dirty="0">
+              <a:rPr lang="en-US" sz="1800" dirty="0">
                 <a:solidFill>
                   <a:srgbClr val="F4F8FB"/>
                 </a:solidFill>
@@ -10266,7 +9353,7 @@
               <a:buNone/>
             </a:pPr>
             <a:r>
-              <a:rPr lang="en-US" sz="1300" dirty="0">
+              <a:rPr lang="en-US" sz="1800" dirty="0">
                 <a:solidFill>
                   <a:srgbClr val="F4F8FB"/>
                 </a:solidFill>
@@ -10281,7 +9368,7 @@
               <a:buNone/>
             </a:pPr>
             <a:r>
-              <a:rPr lang="en-US" sz="1300" dirty="0">
+              <a:rPr lang="en-US" sz="1800" dirty="0">
                 <a:solidFill>
                   <a:srgbClr val="F4F8FB"/>
                 </a:solidFill>
@@ -10296,7 +9383,7 @@
               <a:buNone/>
             </a:pPr>
             <a:r>
-              <a:rPr lang="en-US" sz="1300" dirty="0">
+              <a:rPr lang="en-US" sz="1800" dirty="0">
                 <a:solidFill>
                   <a:srgbClr val="F4F8FB"/>
                 </a:solidFill>
@@ -10306,7 +9393,7 @@
               </a:rPr>
               <a:t>• Digital transformation + Industry 4.0 tailwinds</a:t>
             </a:r>
-            <a:endParaRPr lang="en-US" sz="1300" dirty="0"/>
+            <a:endParaRPr lang="en-US" sz="1800" dirty="0"/>
           </a:p>
         </p:txBody>
       </p:sp>
@@ -10407,7 +9494,7 @@
               <a:buNone/>
             </a:pPr>
             <a:r>
-              <a:rPr lang="en-US" sz="1300" dirty="0">
+              <a:rPr lang="en-US" sz="1800" dirty="0">
                 <a:solidFill>
                   <a:srgbClr val="F4F8FB"/>
                 </a:solidFill>
@@ -10422,7 +9509,7 @@
               <a:buNone/>
             </a:pPr>
             <a:r>
-              <a:rPr lang="en-US" sz="1300" dirty="0">
+              <a:rPr lang="en-US" sz="1800" dirty="0">
                 <a:solidFill>
                   <a:srgbClr val="F4F8FB"/>
                 </a:solidFill>
@@ -10437,7 +9524,7 @@
               <a:buNone/>
             </a:pPr>
             <a:r>
-              <a:rPr lang="en-US" sz="1300" dirty="0">
+              <a:rPr lang="en-US" sz="1800" dirty="0">
                 <a:solidFill>
                   <a:srgbClr val="F4F8FB"/>
                 </a:solidFill>
@@ -10452,7 +9539,7 @@
               <a:buNone/>
             </a:pPr>
             <a:r>
-              <a:rPr lang="en-US" sz="1300" dirty="0">
+              <a:rPr lang="en-US" sz="1800" dirty="0">
                 <a:solidFill>
                   <a:srgbClr val="F4F8FB"/>
                 </a:solidFill>
@@ -10462,7 +9549,7 @@
               </a:rPr>
               <a:t>• AS9100, CMMC, ISO, ITAR regulated</a:t>
             </a:r>
-            <a:endParaRPr lang="en-US" sz="1300" dirty="0"/>
+            <a:endParaRPr lang="en-US" sz="1800" dirty="0"/>
           </a:p>
         </p:txBody>
       </p:sp>
@@ -10563,7 +9650,7 @@
               <a:buNone/>
             </a:pPr>
             <a:r>
-              <a:rPr lang="en-US" sz="1300" dirty="0">
+              <a:rPr lang="en-US" sz="1800" dirty="0">
                 <a:solidFill>
                   <a:srgbClr val="F4F8FB"/>
                 </a:solidFill>
@@ -10578,7 +9665,7 @@
               <a:buNone/>
             </a:pPr>
             <a:r>
-              <a:rPr lang="en-US" sz="1300" dirty="0">
+              <a:rPr lang="en-US" sz="1800" dirty="0">
                 <a:solidFill>
                   <a:srgbClr val="F4F8FB"/>
                 </a:solidFill>
@@ -10593,7 +9680,7 @@
               <a:buNone/>
             </a:pPr>
             <a:r>
-              <a:rPr lang="en-US" sz="1300" dirty="0">
+              <a:rPr lang="en-US" sz="1800" dirty="0">
                 <a:solidFill>
                   <a:srgbClr val="F4F8FB"/>
                 </a:solidFill>
@@ -10608,7 +9695,7 @@
               <a:buNone/>
             </a:pPr>
             <a:r>
-              <a:rPr lang="en-US" sz="1300" dirty="0">
+              <a:rPr lang="en-US" sz="1800" dirty="0">
                 <a:solidFill>
                   <a:srgbClr val="F4F8FB"/>
                 </a:solidFill>
@@ -10618,7 +9705,7 @@
               </a:rPr>
               <a:t>• PA-grown, MANTEC-aligned, US-hosted</a:t>
             </a:r>
-            <a:endParaRPr lang="en-US" sz="1300" dirty="0"/>
+            <a:endParaRPr lang="en-US" sz="1800" dirty="0"/>
           </a:p>
         </p:txBody>
       </p:sp>
@@ -10833,89 +9920,6 @@
       </p:sp>
       <p:sp>
         <p:nvSpPr>
-          <p:cNvPr id="4" name="Shape 2"/>
-          <p:cNvSpPr/>
-          <p:nvPr/>
-        </p:nvSpPr>
-        <p:spPr>
-          <a:xfrm>
-            <a:off x="8275320" y="137160"/>
-            <a:ext cx="3611880" cy="3611880"/>
-          </a:xfrm>
-          <a:prstGeom prst="arc">
-            <a:avLst/>
-          </a:prstGeom>
-          <a:solidFill>
-            <a:srgbClr val="08131F">
-              <a:alpha val="0"/>
-            </a:srgbClr>
-          </a:solidFill>
-          <a:ln w="13970">
-            <a:solidFill>
-              <a:srgbClr val="123D5A">
-                <a:alpha val="65000"/>
-              </a:srgbClr>
-            </a:solidFill>
-            <a:prstDash val="solid"/>
-          </a:ln>
-        </p:spPr>
-      </p:sp>
-      <p:sp>
-        <p:nvSpPr>
-          <p:cNvPr id="5" name="Shape 3"/>
-          <p:cNvSpPr/>
-          <p:nvPr/>
-        </p:nvSpPr>
-        <p:spPr>
-          <a:xfrm>
-            <a:off x="8641080" y="475488"/>
-            <a:ext cx="2834640" cy="2834640"/>
-          </a:xfrm>
-          <a:prstGeom prst="arc">
-            <a:avLst/>
-          </a:prstGeom>
-          <a:solidFill>
-            <a:srgbClr val="08131F">
-              <a:alpha val="0"/>
-            </a:srgbClr>
-          </a:solidFill>
-          <a:ln w="10160">
-            <a:solidFill>
-              <a:srgbClr val="2DE2D1">
-                <a:alpha val="28000"/>
-              </a:srgbClr>
-            </a:solidFill>
-            <a:prstDash val="solid"/>
-          </a:ln>
-        </p:spPr>
-      </p:sp>
-      <p:sp>
-        <p:nvSpPr>
-          <p:cNvPr id="6" name="Shape 4"/>
-          <p:cNvSpPr/>
-          <p:nvPr/>
-        </p:nvSpPr>
-        <p:spPr>
-          <a:xfrm>
-            <a:off x="8138160" y="731520"/>
-            <a:ext cx="3291840" cy="0"/>
-          </a:xfrm>
-          <a:prstGeom prst="line">
-            <a:avLst/>
-          </a:prstGeom>
-          <a:noFill/>
-          <a:ln w="12700">
-            <a:solidFill>
-              <a:srgbClr val="123D5A">
-                <a:alpha val="55000"/>
-              </a:srgbClr>
-            </a:solidFill>
-            <a:prstDash val="solid"/>
-          </a:ln>
-        </p:spPr>
-      </p:sp>
-      <p:sp>
-        <p:nvSpPr>
           <p:cNvPr id="7" name="Text 5"/>
           <p:cNvSpPr/>
           <p:nvPr/>
@@ -10982,7 +9986,7 @@
               <a:buNone/>
             </a:pPr>
             <a:r>
-              <a:rPr lang="en-US" sz="1250" dirty="0">
+              <a:rPr lang="en-US" sz="1800" dirty="0">
                 <a:solidFill>
                   <a:srgbClr val="A9BED0"/>
                 </a:solidFill>
@@ -10992,7 +9996,7 @@
               </a:rPr>
               <a:t>Ratatosk creates revenue and proprietary insight before full platform displacement is required.</a:t>
             </a:r>
-            <a:endParaRPr lang="en-US" sz="1250" dirty="0"/>
+            <a:endParaRPr lang="en-US" sz="1800" dirty="0"/>
           </a:p>
         </p:txBody>
       </p:sp>
@@ -11052,7 +10056,7 @@
               <a:buNone/>
             </a:pPr>
             <a:r>
-              <a:rPr lang="en-US" sz="1250" b="1" dirty="0">
+              <a:rPr lang="en-US" sz="1800" b="1" dirty="0">
                 <a:solidFill>
                   <a:srgbClr val="2DE2D1"/>
                 </a:solidFill>
@@ -11062,7 +10066,7 @@
               </a:rPr>
               <a:t>Ratatosk diagnostic</a:t>
             </a:r>
-            <a:endParaRPr lang="en-US" sz="1250" dirty="0"/>
+            <a:endParaRPr lang="en-US" sz="1800" dirty="0"/>
           </a:p>
         </p:txBody>
       </p:sp>
@@ -11093,7 +10097,7 @@
               <a:buNone/>
             </a:pPr>
             <a:r>
-              <a:rPr lang="en-US" sz="1220" dirty="0">
+              <a:rPr lang="en-US" sz="1800" dirty="0">
                 <a:solidFill>
                   <a:srgbClr val="F4F8FB"/>
                 </a:solidFill>
@@ -11103,7 +10107,7 @@
               </a:rPr>
               <a:t>Fixed project fee</a:t>
             </a:r>
-            <a:endParaRPr lang="en-US" sz="1220" dirty="0"/>
+            <a:endParaRPr lang="en-US" sz="1800" dirty="0"/>
           </a:p>
         </p:txBody>
       </p:sp>
@@ -11134,7 +10138,7 @@
               <a:buNone/>
             </a:pPr>
             <a:r>
-              <a:rPr lang="en-US" sz="1180" dirty="0">
+              <a:rPr lang="en-US" sz="1800" dirty="0">
                 <a:solidFill>
                   <a:srgbClr val="A9BED0"/>
                 </a:solidFill>
@@ -11144,7 +10148,7 @@
               </a:rPr>
               <a:t>Fast proof and artifact generation</a:t>
             </a:r>
-            <a:endParaRPr lang="en-US" sz="1180" dirty="0"/>
+            <a:endParaRPr lang="en-US" sz="1800" dirty="0"/>
           </a:p>
         </p:txBody>
       </p:sp>
@@ -11204,7 +10208,7 @@
               <a:buNone/>
             </a:pPr>
             <a:r>
-              <a:rPr lang="en-US" sz="1250" b="1" dirty="0">
+              <a:rPr lang="en-US" sz="1800" b="1" dirty="0">
                 <a:solidFill>
                   <a:srgbClr val="2DE2D1"/>
                 </a:solidFill>
@@ -11214,7 +10218,7 @@
               </a:rPr>
               <a:t>Yggdrasil ERP</a:t>
             </a:r>
-            <a:endParaRPr lang="en-US" sz="1250" dirty="0"/>
+            <a:endParaRPr lang="en-US" sz="1800" dirty="0"/>
           </a:p>
         </p:txBody>
       </p:sp>
@@ -11245,7 +10249,7 @@
               <a:buNone/>
             </a:pPr>
             <a:r>
-              <a:rPr lang="en-US" sz="1220" dirty="0">
+              <a:rPr lang="en-US" sz="1800" dirty="0">
                 <a:solidFill>
                   <a:srgbClr val="F4F8FB"/>
                 </a:solidFill>
@@ -11255,7 +10259,7 @@
               </a:rPr>
               <a:t>$30K + ($10K × Footprint) annual; $35K pilot</a:t>
             </a:r>
-            <a:endParaRPr lang="en-US" sz="1220" dirty="0"/>
+            <a:endParaRPr lang="en-US" sz="1800" dirty="0"/>
           </a:p>
         </p:txBody>
       </p:sp>
@@ -11286,7 +10290,7 @@
               <a:buNone/>
             </a:pPr>
             <a:r>
-              <a:rPr lang="en-US" sz="1180" dirty="0">
+              <a:rPr lang="en-US" sz="1800" dirty="0">
                 <a:solidFill>
                   <a:srgbClr val="A9BED0"/>
                 </a:solidFill>
@@ -11296,7 +10300,7 @@
               </a:rPr>
               <a:t>All 10 modules + OPE included; full audit log</a:t>
             </a:r>
-            <a:endParaRPr lang="en-US" sz="1180" dirty="0"/>
+            <a:endParaRPr lang="en-US" sz="1800" dirty="0"/>
           </a:p>
         </p:txBody>
       </p:sp>
@@ -11356,7 +10360,7 @@
               <a:buNone/>
             </a:pPr>
             <a:r>
-              <a:rPr lang="en-US" sz="1250" b="1" dirty="0">
+              <a:rPr lang="en-US" sz="1800" b="1" dirty="0">
                 <a:solidFill>
                   <a:srgbClr val="2DE2D1"/>
                 </a:solidFill>
@@ -11366,7 +10370,7 @@
               </a:rPr>
               <a:t>Ragnarok migration</a:t>
             </a:r>
-            <a:endParaRPr lang="en-US" sz="1250" dirty="0"/>
+            <a:endParaRPr lang="en-US" sz="1800" dirty="0"/>
           </a:p>
         </p:txBody>
       </p:sp>
@@ -11397,7 +10401,7 @@
               <a:buNone/>
             </a:pPr>
             <a:r>
-              <a:rPr lang="en-US" sz="1220" dirty="0">
+              <a:rPr lang="en-US" sz="1800" dirty="0">
                 <a:solidFill>
                   <a:srgbClr val="F4F8FB"/>
                 </a:solidFill>
@@ -11407,7 +10411,7 @@
               </a:rPr>
               <a:t>Project fee; 1:1 activation credit</a:t>
             </a:r>
-            <a:endParaRPr lang="en-US" sz="1220" dirty="0"/>
+            <a:endParaRPr lang="en-US" sz="1800" dirty="0"/>
           </a:p>
         </p:txBody>
       </p:sp>
@@ -11438,7 +10442,7 @@
               <a:buNone/>
             </a:pPr>
             <a:r>
-              <a:rPr lang="en-US" sz="1180" dirty="0">
+              <a:rPr lang="en-US" sz="1800" dirty="0">
                 <a:solidFill>
                   <a:srgbClr val="A9BED0"/>
                 </a:solidFill>
@@ -11448,7 +10452,7 @@
               </a:rPr>
               <a:t>Governed legacy → canonical schema migration</a:t>
             </a:r>
-            <a:endParaRPr lang="en-US" sz="1180" dirty="0"/>
+            <a:endParaRPr lang="en-US" sz="1800" dirty="0"/>
           </a:p>
         </p:txBody>
       </p:sp>
@@ -11508,7 +10512,7 @@
               <a:buNone/>
             </a:pPr>
             <a:r>
-              <a:rPr lang="en-US" sz="1250" b="1" dirty="0">
+              <a:rPr lang="en-US" sz="1800" b="1" dirty="0">
                 <a:solidFill>
                   <a:srgbClr val="2DE2D1"/>
                 </a:solidFill>
@@ -11518,7 +10522,7 @@
               </a:rPr>
               <a:t>Norn pilot</a:t>
             </a:r>
-            <a:endParaRPr lang="en-US" sz="1250" dirty="0"/>
+            <a:endParaRPr lang="en-US" sz="1800" dirty="0"/>
           </a:p>
         </p:txBody>
       </p:sp>
@@ -11549,7 +10553,7 @@
               <a:buNone/>
             </a:pPr>
             <a:r>
-              <a:rPr lang="en-US" sz="1220" dirty="0">
+              <a:rPr lang="en-US" sz="1800" dirty="0">
                 <a:solidFill>
                   <a:srgbClr val="F4F8FB"/>
                 </a:solidFill>
@@ -11559,7 +10563,7 @@
               </a:rPr>
               <a:t>$299/mo Business tier</a:t>
             </a:r>
-            <a:endParaRPr lang="en-US" sz="1220" dirty="0"/>
+            <a:endParaRPr lang="en-US" sz="1800" dirty="0"/>
           </a:p>
         </p:txBody>
       </p:sp>
@@ -11590,7 +10594,7 @@
               <a:buNone/>
             </a:pPr>
             <a:r>
-              <a:rPr lang="en-US" sz="1180" dirty="0">
+              <a:rPr lang="en-US" sz="1800" dirty="0">
                 <a:solidFill>
                   <a:srgbClr val="A9BED0"/>
                 </a:solidFill>
@@ -11600,7 +10604,7 @@
               </a:rPr>
               <a:t>Contract pilot; 5-org cap</a:t>
             </a:r>
-            <a:endParaRPr lang="en-US" sz="1180" dirty="0"/>
+            <a:endParaRPr lang="en-US" sz="1800" dirty="0"/>
           </a:p>
         </p:txBody>
       </p:sp>
@@ -11660,7 +10664,7 @@
               <a:buNone/>
             </a:pPr>
             <a:r>
-              <a:rPr lang="en-US" sz="1250" b="1" dirty="0">
+              <a:rPr lang="en-US" sz="1800" b="1" dirty="0">
                 <a:solidFill>
                   <a:srgbClr val="2DE2D1"/>
                 </a:solidFill>
@@ -11670,7 +10674,7 @@
               </a:rPr>
               <a:t>Roadmap</a:t>
             </a:r>
-            <a:endParaRPr lang="en-US" sz="1250" dirty="0"/>
+            <a:endParaRPr lang="en-US" sz="1800" dirty="0"/>
           </a:p>
         </p:txBody>
       </p:sp>
@@ -11701,7 +10705,7 @@
               <a:buNone/>
             </a:pPr>
             <a:r>
-              <a:rPr lang="en-US" sz="1220" dirty="0">
+              <a:rPr lang="en-US" sz="1800" dirty="0">
                 <a:solidFill>
                   <a:srgbClr val="F4F8FB"/>
                 </a:solidFill>
@@ -11711,7 +10715,7 @@
               </a:rPr>
               <a:t>Future revenue lines</a:t>
             </a:r>
-            <a:endParaRPr lang="en-US" sz="1220" dirty="0"/>
+            <a:endParaRPr lang="en-US" sz="1800" dirty="0"/>
           </a:p>
         </p:txBody>
       </p:sp>
@@ -11742,7 +10746,7 @@
               <a:buNone/>
             </a:pPr>
             <a:r>
-              <a:rPr lang="en-US" sz="1180" dirty="0">
+              <a:rPr lang="en-US" sz="1800" dirty="0">
                 <a:solidFill>
                   <a:srgbClr val="A9BED0"/>
                 </a:solidFill>
@@ -11752,7 +10756,7 @@
               </a:rPr>
               <a:t>SI channel, OPE-Norn integration, agent SDK</a:t>
             </a:r>
-            <a:endParaRPr lang="en-US" sz="1180" dirty="0"/>
+            <a:endParaRPr lang="en-US" sz="1800" dirty="0"/>
           </a:p>
         </p:txBody>
       </p:sp>
@@ -11783,7 +10787,7 @@
               <a:buNone/>
             </a:pPr>
             <a:r>
-              <a:rPr lang="en-US" sz="1700" b="1" dirty="0">
+              <a:rPr lang="en-US" sz="1800" b="1" dirty="0">
                 <a:solidFill>
                   <a:srgbClr val="F4F8FB"/>
                 </a:solidFill>
@@ -11793,7 +10797,7 @@
               </a:rPr>
               <a:t>GTM motion: founder-led pilots → SI/referrer channel → strategic platform conversations.</a:t>
             </a:r>
-            <a:endParaRPr lang="en-US" sz="1700" dirty="0"/>
+            <a:endParaRPr lang="en-US" sz="1800" dirty="0"/>
           </a:p>
         </p:txBody>
       </p:sp>
@@ -11967,89 +10971,6 @@
       </p:sp>
       <p:sp>
         <p:nvSpPr>
-          <p:cNvPr id="4" name="Shape 2"/>
-          <p:cNvSpPr/>
-          <p:nvPr/>
-        </p:nvSpPr>
-        <p:spPr>
-          <a:xfrm>
-            <a:off x="8275320" y="137160"/>
-            <a:ext cx="3611880" cy="3611880"/>
-          </a:xfrm>
-          <a:prstGeom prst="arc">
-            <a:avLst/>
-          </a:prstGeom>
-          <a:solidFill>
-            <a:srgbClr val="08131F">
-              <a:alpha val="0"/>
-            </a:srgbClr>
-          </a:solidFill>
-          <a:ln w="13970">
-            <a:solidFill>
-              <a:srgbClr val="123D5A">
-                <a:alpha val="65000"/>
-              </a:srgbClr>
-            </a:solidFill>
-            <a:prstDash val="solid"/>
-          </a:ln>
-        </p:spPr>
-      </p:sp>
-      <p:sp>
-        <p:nvSpPr>
-          <p:cNvPr id="5" name="Shape 3"/>
-          <p:cNvSpPr/>
-          <p:nvPr/>
-        </p:nvSpPr>
-        <p:spPr>
-          <a:xfrm>
-            <a:off x="8641080" y="475488"/>
-            <a:ext cx="2834640" cy="2834640"/>
-          </a:xfrm>
-          <a:prstGeom prst="arc">
-            <a:avLst/>
-          </a:prstGeom>
-          <a:solidFill>
-            <a:srgbClr val="08131F">
-              <a:alpha val="0"/>
-            </a:srgbClr>
-          </a:solidFill>
-          <a:ln w="10160">
-            <a:solidFill>
-              <a:srgbClr val="2DE2D1">
-                <a:alpha val="28000"/>
-              </a:srgbClr>
-            </a:solidFill>
-            <a:prstDash val="solid"/>
-          </a:ln>
-        </p:spPr>
-      </p:sp>
-      <p:sp>
-        <p:nvSpPr>
-          <p:cNvPr id="6" name="Shape 4"/>
-          <p:cNvSpPr/>
-          <p:nvPr/>
-        </p:nvSpPr>
-        <p:spPr>
-          <a:xfrm>
-            <a:off x="8138160" y="731520"/>
-            <a:ext cx="3291840" cy="0"/>
-          </a:xfrm>
-          <a:prstGeom prst="line">
-            <a:avLst/>
-          </a:prstGeom>
-          <a:noFill/>
-          <a:ln w="12700">
-            <a:solidFill>
-              <a:srgbClr val="123D5A">
-                <a:alpha val="55000"/>
-              </a:srgbClr>
-            </a:solidFill>
-            <a:prstDash val="solid"/>
-          </a:ln>
-        </p:spPr>
-      </p:sp>
-      <p:sp>
-        <p:nvSpPr>
           <p:cNvPr id="7" name="Text 5"/>
           <p:cNvSpPr/>
           <p:nvPr/>
@@ -12116,7 +11037,7 @@
               <a:buNone/>
             </a:pPr>
             <a:r>
-              <a:rPr lang="en-US" sz="1250" dirty="0">
+              <a:rPr lang="en-US" sz="1800" dirty="0">
                 <a:solidFill>
                   <a:srgbClr val="A9BED0"/>
                 </a:solidFill>
@@ -12126,7 +11047,7 @@
               </a:rPr>
               <a:t>Each phase builds the customer relationship and proof set the next phase needs. We do not need to win an ERP buyer in month one.</a:t>
             </a:r>
-            <a:endParaRPr lang="en-US" sz="1250" dirty="0"/>
+            <a:endParaRPr lang="en-US" sz="1800" dirty="0"/>
           </a:p>
         </p:txBody>
       </p:sp>
@@ -12186,7 +11107,7 @@
               <a:buNone/>
             </a:pPr>
             <a:r>
-              <a:rPr lang="en-US" sz="1550" b="1" dirty="0">
+              <a:rPr lang="en-US" sz="1800" b="1" dirty="0">
                 <a:solidFill>
                   <a:srgbClr val="2DE2D1"/>
                 </a:solidFill>
@@ -12196,7 +11117,7 @@
               </a:rPr>
               <a:t>Phase 1 — Wedge</a:t>
             </a:r>
-            <a:endParaRPr lang="en-US" sz="1550" dirty="0"/>
+            <a:endParaRPr lang="en-US" sz="1800" dirty="0"/>
           </a:p>
         </p:txBody>
       </p:sp>
@@ -12227,7 +11148,7 @@
               <a:buNone/>
             </a:pPr>
             <a:r>
-              <a:rPr lang="en-US" sz="1120" dirty="0">
+              <a:rPr lang="en-US" sz="1800" dirty="0">
                 <a:solidFill>
                   <a:srgbClr val="A9BED0"/>
                 </a:solidFill>
@@ -12237,7 +11158,7 @@
               </a:rPr>
               <a:t>Norn self-serve SaaS (free → $1,499/mo). No IT approval, no sales cycle. Active Q4 2026.</a:t>
             </a:r>
-            <a:endParaRPr lang="en-US" sz="1120" dirty="0"/>
+            <a:endParaRPr lang="en-US" sz="1800" dirty="0"/>
           </a:p>
         </p:txBody>
       </p:sp>
@@ -12297,7 +11218,7 @@
               <a:buNone/>
             </a:pPr>
             <a:r>
-              <a:rPr lang="en-US" sz="1550" b="1" dirty="0">
+              <a:rPr lang="en-US" sz="1800" b="1" dirty="0">
                 <a:solidFill>
                   <a:srgbClr val="2DE2D1"/>
                 </a:solidFill>
@@ -12307,7 +11228,7 @@
               </a:rPr>
               <a:t>Phase 2 — Services</a:t>
             </a:r>
-            <a:endParaRPr lang="en-US" sz="1550" dirty="0"/>
+            <a:endParaRPr lang="en-US" sz="1800" dirty="0"/>
           </a:p>
         </p:txBody>
       </p:sp>
@@ -12338,7 +11259,7 @@
               <a:buNone/>
             </a:pPr>
             <a:r>
-              <a:rPr lang="en-US" sz="1120" dirty="0">
+              <a:rPr lang="en-US" sz="1800" dirty="0">
                 <a:solidFill>
                   <a:srgbClr val="A9BED0"/>
                 </a:solidFill>
@@ -12348,7 +11269,7 @@
               </a:rPr>
               <a:t>Ratatosk governance workshops, $5–12.5K. Reveals migration needs, builds account intelligence. Q3 2026.</a:t>
             </a:r>
-            <a:endParaRPr lang="en-US" sz="1120" dirty="0"/>
+            <a:endParaRPr lang="en-US" sz="1800" dirty="0"/>
           </a:p>
         </p:txBody>
       </p:sp>
@@ -12408,7 +11329,7 @@
               <a:buNone/>
             </a:pPr>
             <a:r>
-              <a:rPr lang="en-US" sz="1550" b="1" dirty="0">
+              <a:rPr lang="en-US" sz="1800" b="1" dirty="0">
                 <a:solidFill>
                   <a:srgbClr val="2DE2D1"/>
                 </a:solidFill>
@@ -12418,7 +11339,7 @@
               </a:rPr>
               <a:t>Phase 3 — Platform</a:t>
             </a:r>
-            <a:endParaRPr lang="en-US" sz="1550" dirty="0"/>
+            <a:endParaRPr lang="en-US" sz="1800" dirty="0"/>
           </a:p>
         </p:txBody>
       </p:sp>
@@ -12449,7 +11370,7 @@
               <a:buNone/>
             </a:pPr>
             <a:r>
-              <a:rPr lang="en-US" sz="1120" dirty="0">
+              <a:rPr lang="en-US" sz="1800" dirty="0">
                 <a:solidFill>
                   <a:srgbClr val="A9BED0"/>
                 </a:solidFill>
@@ -12459,7 +11380,7 @@
               </a:rPr>
               <a:t>Ragnarok migrations + Bifrost integrations. 60% Ratatosk → Ragnarok attach, 25% → Bifrost. Q1 2027.</a:t>
             </a:r>
-            <a:endParaRPr lang="en-US" sz="1120" dirty="0"/>
+            <a:endParaRPr lang="en-US" sz="1800" dirty="0"/>
           </a:p>
         </p:txBody>
       </p:sp>
@@ -12519,7 +11440,7 @@
               <a:buNone/>
             </a:pPr>
             <a:r>
-              <a:rPr lang="en-US" sz="1550" b="1" dirty="0">
+              <a:rPr lang="en-US" sz="1800" b="1" dirty="0">
                 <a:solidFill>
                   <a:srgbClr val="2DE2D1"/>
                 </a:solidFill>
@@ -12529,7 +11450,7 @@
               </a:rPr>
               <a:t>Phase 4 — ERP</a:t>
             </a:r>
-            <a:endParaRPr lang="en-US" sz="1550" dirty="0"/>
+            <a:endParaRPr lang="en-US" sz="1800" dirty="0"/>
           </a:p>
         </p:txBody>
       </p:sp>
@@ -12560,7 +11481,7 @@
               <a:buNone/>
             </a:pPr>
             <a:r>
-              <a:rPr lang="en-US" sz="1120" dirty="0">
+              <a:rPr lang="en-US" sz="1800" dirty="0">
                 <a:solidFill>
                   <a:srgbClr val="A9BED0"/>
                 </a:solidFill>
@@ -12570,7 +11491,7 @@
               </a:rPr>
               <a:t>Yggdrasil ERP pilots ($35K) and full subscriptions. Footprint Score pricing. Q3 2027+.</a:t>
             </a:r>
-            <a:endParaRPr lang="en-US" sz="1120" dirty="0"/>
+            <a:endParaRPr lang="en-US" sz="1800" dirty="0"/>
           </a:p>
         </p:txBody>
       </p:sp>
@@ -12630,7 +11551,7 @@
               <a:buNone/>
             </a:pPr>
             <a:r>
-              <a:rPr lang="en-US" sz="1550" b="1" dirty="0">
+              <a:rPr lang="en-US" sz="1800" b="1" dirty="0">
                 <a:solidFill>
                   <a:srgbClr val="2DE2D1"/>
                 </a:solidFill>
@@ -12640,7 +11561,7 @@
               </a:rPr>
               <a:t>Pre-seed milestones</a:t>
             </a:r>
-            <a:endParaRPr lang="en-US" sz="1550" dirty="0"/>
+            <a:endParaRPr lang="en-US" sz="1800" dirty="0"/>
           </a:p>
         </p:txBody>
       </p:sp>
@@ -12671,7 +11592,7 @@
               <a:buNone/>
             </a:pPr>
             <a:r>
-              <a:rPr lang="en-US" sz="1120" dirty="0">
+              <a:rPr lang="en-US" sz="1800" dirty="0">
                 <a:solidFill>
                   <a:srgbClr val="A9BED0"/>
                 </a:solidFill>
@@ -12681,7 +11602,7 @@
               </a:rPr>
               <a:t>3–5 Ratatosk workshops, 2 Yggdrasil pilots, Wave-1 OPE rollout, SOC 2 Type I, first engineering hire.</a:t>
             </a:r>
-            <a:endParaRPr lang="en-US" sz="1120" dirty="0"/>
+            <a:endParaRPr lang="en-US" sz="1800" dirty="0"/>
           </a:p>
         </p:txBody>
       </p:sp>
@@ -12741,7 +11662,7 @@
               <a:buNone/>
             </a:pPr>
             <a:r>
-              <a:rPr lang="en-US" sz="1550" b="1" dirty="0">
+              <a:rPr lang="en-US" sz="1800" b="1" dirty="0">
                 <a:solidFill>
                   <a:srgbClr val="2DE2D1"/>
                 </a:solidFill>
@@ -12751,7 +11672,7 @@
               </a:rPr>
               <a:t>Series A milestones</a:t>
             </a:r>
-            <a:endParaRPr lang="en-US" sz="1550" dirty="0"/>
+            <a:endParaRPr lang="en-US" sz="1800" dirty="0"/>
           </a:p>
         </p:txBody>
       </p:sp>
@@ -12782,7 +11703,7 @@
               <a:buNone/>
             </a:pPr>
             <a:r>
-              <a:rPr lang="en-US" sz="1120" dirty="0">
+              <a:rPr lang="en-US" sz="1800" dirty="0">
                 <a:solidFill>
                   <a:srgbClr val="A9BED0"/>
                 </a:solidFill>
@@ -12792,7 +11713,7 @@
               </a:rPr>
               <a:t>$500K ARR, 100 Norn paid accounts, 10 services engagements, 3 Yggdrasil tenants, Template Exchange live.</a:t>
             </a:r>
-            <a:endParaRPr lang="en-US" sz="1120" dirty="0"/>
+            <a:endParaRPr lang="en-US" sz="1800" dirty="0"/>
           </a:p>
         </p:txBody>
       </p:sp>
@@ -12823,7 +11744,7 @@
               <a:buNone/>
             </a:pPr>
             <a:r>
-              <a:rPr lang="en-US" sz="1700" b="1" dirty="0">
+              <a:rPr lang="en-US" sz="1800" b="1" dirty="0">
                 <a:solidFill>
                   <a:srgbClr val="F4F8FB"/>
                 </a:solidFill>
@@ -12833,7 +11754,7 @@
               </a:rPr>
               <a:t>GTM motion: founder-led pilots → SI/referrer channel → strategic platform conversations. No partner channel before product is proven.</a:t>
             </a:r>
-            <a:endParaRPr lang="en-US" sz="1700" dirty="0"/>
+            <a:endParaRPr lang="en-US" sz="1800" dirty="0"/>
           </a:p>
         </p:txBody>
       </p:sp>
@@ -13007,89 +11928,6 @@
       </p:sp>
       <p:sp>
         <p:nvSpPr>
-          <p:cNvPr id="4" name="Shape 2"/>
-          <p:cNvSpPr/>
-          <p:nvPr/>
-        </p:nvSpPr>
-        <p:spPr>
-          <a:xfrm>
-            <a:off x="8275320" y="137160"/>
-            <a:ext cx="3611880" cy="3611880"/>
-          </a:xfrm>
-          <a:prstGeom prst="arc">
-            <a:avLst/>
-          </a:prstGeom>
-          <a:solidFill>
-            <a:srgbClr val="08131F">
-              <a:alpha val="0"/>
-            </a:srgbClr>
-          </a:solidFill>
-          <a:ln w="13970">
-            <a:solidFill>
-              <a:srgbClr val="123D5A">
-                <a:alpha val="65000"/>
-              </a:srgbClr>
-            </a:solidFill>
-            <a:prstDash val="solid"/>
-          </a:ln>
-        </p:spPr>
-      </p:sp>
-      <p:sp>
-        <p:nvSpPr>
-          <p:cNvPr id="5" name="Shape 3"/>
-          <p:cNvSpPr/>
-          <p:nvPr/>
-        </p:nvSpPr>
-        <p:spPr>
-          <a:xfrm>
-            <a:off x="8641080" y="475488"/>
-            <a:ext cx="2834640" cy="2834640"/>
-          </a:xfrm>
-          <a:prstGeom prst="arc">
-            <a:avLst/>
-          </a:prstGeom>
-          <a:solidFill>
-            <a:srgbClr val="08131F">
-              <a:alpha val="0"/>
-            </a:srgbClr>
-          </a:solidFill>
-          <a:ln w="10160">
-            <a:solidFill>
-              <a:srgbClr val="2DE2D1">
-                <a:alpha val="28000"/>
-              </a:srgbClr>
-            </a:solidFill>
-            <a:prstDash val="solid"/>
-          </a:ln>
-        </p:spPr>
-      </p:sp>
-      <p:sp>
-        <p:nvSpPr>
-          <p:cNvPr id="6" name="Shape 4"/>
-          <p:cNvSpPr/>
-          <p:nvPr/>
-        </p:nvSpPr>
-        <p:spPr>
-          <a:xfrm>
-            <a:off x="8138160" y="731520"/>
-            <a:ext cx="3291840" cy="0"/>
-          </a:xfrm>
-          <a:prstGeom prst="line">
-            <a:avLst/>
-          </a:prstGeom>
-          <a:noFill/>
-          <a:ln w="12700">
-            <a:solidFill>
-              <a:srgbClr val="123D5A">
-                <a:alpha val="55000"/>
-              </a:srgbClr>
-            </a:solidFill>
-            <a:prstDash val="solid"/>
-          </a:ln>
-        </p:spPr>
-      </p:sp>
-      <p:sp>
-        <p:nvSpPr>
           <p:cNvPr id="7" name="Text 5"/>
           <p:cNvSpPr/>
           <p:nvPr/>
@@ -13156,7 +11994,7 @@
               <a:buNone/>
             </a:pPr>
             <a:r>
-              <a:rPr lang="en-US" sz="1250" dirty="0">
+              <a:rPr lang="en-US" sz="1800" dirty="0">
                 <a:solidFill>
                   <a:srgbClr val="A9BED0"/>
                 </a:solidFill>
@@ -13166,7 +12004,7 @@
               </a:rPr>
               <a:t>Most adjacent tools observe, move, or interpret data. Mimir Labs governs what can become operational truth.</a:t>
             </a:r>
-            <a:endParaRPr lang="en-US" sz="1250" dirty="0"/>
+            <a:endParaRPr lang="en-US" sz="1800" dirty="0"/>
           </a:p>
         </p:txBody>
       </p:sp>
@@ -13197,7 +12035,7 @@
               <a:buNone/>
             </a:pPr>
             <a:r>
-              <a:rPr lang="en-US" sz="1280" b="1" dirty="0">
+              <a:rPr lang="en-US" sz="1800" b="1" dirty="0">
                 <a:solidFill>
                   <a:srgbClr val="2DE2D1"/>
                 </a:solidFill>
@@ -13207,7 +12045,7 @@
               </a:rPr>
               <a:t>MDM / governance</a:t>
             </a:r>
-            <a:endParaRPr lang="en-US" sz="1280" dirty="0"/>
+            <a:endParaRPr lang="en-US" sz="1800" dirty="0"/>
           </a:p>
         </p:txBody>
       </p:sp>
@@ -13238,7 +12076,7 @@
               <a:buNone/>
             </a:pPr>
             <a:r>
-              <a:rPr lang="en-US" sz="1160" dirty="0">
+              <a:rPr lang="en-US" sz="1800" dirty="0">
                 <a:solidFill>
                   <a:srgbClr val="A9BED0"/>
                 </a:solidFill>
@@ -13248,7 +12086,7 @@
               </a:rPr>
               <a:t>Manages definitions and stewardship</a:t>
             </a:r>
-            <a:endParaRPr lang="en-US" sz="1160" dirty="0"/>
+            <a:endParaRPr lang="en-US" sz="1800" dirty="0"/>
           </a:p>
         </p:txBody>
       </p:sp>
@@ -13279,7 +12117,7 @@
               <a:buNone/>
             </a:pPr>
             <a:r>
-              <a:rPr lang="en-US" sz="1160" dirty="0">
+              <a:rPr lang="en-US" sz="1800" dirty="0">
                 <a:solidFill>
                   <a:srgbClr val="F4F8FB"/>
                 </a:solidFill>
@@ -13289,7 +12127,7 @@
               </a:rPr>
               <a:t>Often stops before runtime action authority</a:t>
             </a:r>
-            <a:endParaRPr lang="en-US" sz="1160" dirty="0"/>
+            <a:endParaRPr lang="en-US" sz="1800" dirty="0"/>
           </a:p>
         </p:txBody>
       </p:sp>
@@ -13345,7 +12183,7 @@
               <a:buNone/>
             </a:pPr>
             <a:r>
-              <a:rPr lang="en-US" sz="1280" b="1" dirty="0">
+              <a:rPr lang="en-US" sz="1800" b="1" dirty="0">
                 <a:solidFill>
                   <a:srgbClr val="2DE2D1"/>
                 </a:solidFill>
@@ -13355,7 +12193,7 @@
               </a:rPr>
               <a:t>iPaaS / data fabric</a:t>
             </a:r>
-            <a:endParaRPr lang="en-US" sz="1280" dirty="0"/>
+            <a:endParaRPr lang="en-US" sz="1800" dirty="0"/>
           </a:p>
         </p:txBody>
       </p:sp>
@@ -13386,7 +12224,7 @@
               <a:buNone/>
             </a:pPr>
             <a:r>
-              <a:rPr lang="en-US" sz="1160" dirty="0">
+              <a:rPr lang="en-US" sz="1800" dirty="0">
                 <a:solidFill>
                   <a:srgbClr val="A9BED0"/>
                 </a:solidFill>
@@ -13396,7 +12234,7 @@
               </a:rPr>
               <a:t>Moves and reconciles data</a:t>
             </a:r>
-            <a:endParaRPr lang="en-US" sz="1160" dirty="0"/>
+            <a:endParaRPr lang="en-US" sz="1800" dirty="0"/>
           </a:p>
         </p:txBody>
       </p:sp>
@@ -13427,7 +12265,7 @@
               <a:buNone/>
             </a:pPr>
             <a:r>
-              <a:rPr lang="en-US" sz="1160" dirty="0">
+              <a:rPr lang="en-US" sz="1800" dirty="0">
                 <a:solidFill>
                   <a:srgbClr val="F4F8FB"/>
                 </a:solidFill>
@@ -13437,7 +12275,7 @@
               </a:rPr>
               <a:t>Translation is not agreement</a:t>
             </a:r>
-            <a:endParaRPr lang="en-US" sz="1160" dirty="0"/>
+            <a:endParaRPr lang="en-US" sz="1800" dirty="0"/>
           </a:p>
         </p:txBody>
       </p:sp>
@@ -13493,7 +12331,7 @@
               <a:buNone/>
             </a:pPr>
             <a:r>
-              <a:rPr lang="en-US" sz="1280" b="1" dirty="0">
+              <a:rPr lang="en-US" sz="1800" b="1" dirty="0">
                 <a:solidFill>
                   <a:srgbClr val="2DE2D1"/>
                 </a:solidFill>
@@ -13503,7 +12341,7 @@
               </a:rPr>
               <a:t>Knowledge graphs / semantic layers</a:t>
             </a:r>
-            <a:endParaRPr lang="en-US" sz="1280" dirty="0"/>
+            <a:endParaRPr lang="en-US" sz="1800" dirty="0"/>
           </a:p>
         </p:txBody>
       </p:sp>
@@ -13534,7 +12372,7 @@
               <a:buNone/>
             </a:pPr>
             <a:r>
-              <a:rPr lang="en-US" sz="1160" dirty="0">
+              <a:rPr lang="en-US" sz="1800" dirty="0">
                 <a:solidFill>
                   <a:srgbClr val="A9BED0"/>
                 </a:solidFill>
@@ -13544,7 +12382,7 @@
               </a:rPr>
               <a:t>Models relationships and meaning</a:t>
             </a:r>
-            <a:endParaRPr lang="en-US" sz="1160" dirty="0"/>
+            <a:endParaRPr lang="en-US" sz="1800" dirty="0"/>
           </a:p>
         </p:txBody>
       </p:sp>
@@ -13575,7 +12413,7 @@
               <a:buNone/>
             </a:pPr>
             <a:r>
-              <a:rPr lang="en-US" sz="1160" dirty="0">
+              <a:rPr lang="en-US" sz="1800" dirty="0">
                 <a:solidFill>
                   <a:srgbClr val="F4F8FB"/>
                 </a:solidFill>
@@ -13585,7 +12423,7 @@
               </a:rPr>
               <a:t>Usually downstream of operational ambiguity</a:t>
             </a:r>
-            <a:endParaRPr lang="en-US" sz="1160" dirty="0"/>
+            <a:endParaRPr lang="en-US" sz="1800" dirty="0"/>
           </a:p>
         </p:txBody>
       </p:sp>
@@ -13641,7 +12479,7 @@
               <a:buNone/>
             </a:pPr>
             <a:r>
-              <a:rPr lang="en-US" sz="1280" b="1" dirty="0">
+              <a:rPr lang="en-US" sz="1800" b="1" dirty="0">
                 <a:solidFill>
                   <a:srgbClr val="2DE2D1"/>
                 </a:solidFill>
@@ -13651,7 +12489,7 @@
               </a:rPr>
               <a:t>AI copilots / agents</a:t>
             </a:r>
-            <a:endParaRPr lang="en-US" sz="1280" dirty="0"/>
+            <a:endParaRPr lang="en-US" sz="1800" dirty="0"/>
           </a:p>
         </p:txBody>
       </p:sp>
@@ -13682,7 +12520,7 @@
               <a:buNone/>
             </a:pPr>
             <a:r>
-              <a:rPr lang="en-US" sz="1160" dirty="0">
+              <a:rPr lang="en-US" sz="1800" dirty="0">
                 <a:solidFill>
                   <a:srgbClr val="A9BED0"/>
                 </a:solidFill>
@@ -13692,7 +12530,7 @@
               </a:rPr>
               <a:t>Retrieve and act through tools</a:t>
             </a:r>
-            <a:endParaRPr lang="en-US" sz="1160" dirty="0"/>
+            <a:endParaRPr lang="en-US" sz="1800" dirty="0"/>
           </a:p>
         </p:txBody>
       </p:sp>
@@ -13723,7 +12561,7 @@
               <a:buNone/>
             </a:pPr>
             <a:r>
-              <a:rPr lang="en-US" sz="1160" dirty="0">
+              <a:rPr lang="en-US" sz="1800" dirty="0">
                 <a:solidFill>
                   <a:srgbClr val="F4F8FB"/>
                 </a:solidFill>
@@ -13733,7 +12571,7 @@
               </a:rPr>
               <a:t>Context is not authority</a:t>
             </a:r>
-            <a:endParaRPr lang="en-US" sz="1160" dirty="0"/>
+            <a:endParaRPr lang="en-US" sz="1800" dirty="0"/>
           </a:p>
         </p:txBody>
       </p:sp>
@@ -13789,7 +12627,7 @@
               <a:buNone/>
             </a:pPr>
             <a:r>
-              <a:rPr lang="en-US" sz="1280" b="1" dirty="0">
+              <a:rPr lang="en-US" sz="1800" b="1" dirty="0">
                 <a:solidFill>
                   <a:srgbClr val="2DE2D1"/>
                 </a:solidFill>
@@ -13799,7 +12637,7 @@
               </a:rPr>
               <a:t>Traditional ERP</a:t>
             </a:r>
-            <a:endParaRPr lang="en-US" sz="1280" dirty="0"/>
+            <a:endParaRPr lang="en-US" sz="1800" dirty="0"/>
           </a:p>
         </p:txBody>
       </p:sp>
@@ -13830,7 +12668,7 @@
               <a:buNone/>
             </a:pPr>
             <a:r>
-              <a:rPr lang="en-US" sz="1160" dirty="0">
+              <a:rPr lang="en-US" sz="1800" dirty="0">
                 <a:solidFill>
                   <a:srgbClr val="A9BED0"/>
                 </a:solidFill>
@@ -13840,7 +12678,7 @@
               </a:rPr>
               <a:t>Records transactions and configurations</a:t>
             </a:r>
-            <a:endParaRPr lang="en-US" sz="1160" dirty="0"/>
+            <a:endParaRPr lang="en-US" sz="1800" dirty="0"/>
           </a:p>
         </p:txBody>
       </p:sp>
@@ -13871,7 +12709,7 @@
               <a:buNone/>
             </a:pPr>
             <a:r>
-              <a:rPr lang="en-US" sz="1160" dirty="0">
+              <a:rPr lang="en-US" sz="1800" dirty="0">
                 <a:solidFill>
                   <a:srgbClr val="F4F8FB"/>
                 </a:solidFill>
@@ -13881,7 +12719,7 @@
               </a:rPr>
               <a:t>Business rules often live around the substrate</a:t>
             </a:r>
-            <a:endParaRPr lang="en-US" sz="1160" dirty="0"/>
+            <a:endParaRPr lang="en-US" sz="1800" dirty="0"/>
           </a:p>
         </p:txBody>
       </p:sp>
@@ -13966,7 +12804,7 @@
               <a:buNone/>
             </a:pPr>
             <a:r>
-              <a:rPr lang="en-US" sz="1450" b="1" dirty="0">
+              <a:rPr lang="en-US" sz="1800" b="1" dirty="0">
                 <a:solidFill>
                   <a:srgbClr val="F6C65B"/>
                 </a:solidFill>
@@ -13976,7 +12814,7 @@
               </a:rPr>
               <a:t>Moat: canonical manifests + deterministic enforcement + audit replay + operational state-machine authority.</a:t>
             </a:r>
-            <a:endParaRPr lang="en-US" sz="1450" dirty="0"/>
+            <a:endParaRPr lang="en-US" sz="1800" dirty="0"/>
           </a:p>
         </p:txBody>
       </p:sp>

</xml_diff>

<commit_message>
BFTP deck: slide 6 TAM/SAM/SOM funnel visualization
Replaced the three side-by-side text tiles with a stacked horizontal funnel:
- TAM bar: 11" wide, $10B headline (28pt teal), supporting facts at 18pt
- SAM bar:  7" wide, ~$3.5B headline
- SOM bar:  3.5" wide, ~$160M headline + teal accent stroke (actionable layer)

Removed 9 tile/text shapes (Shape 7-15), added 3 funnel bars (IDs 21-23).
Bottom strip retained: "Mid-market manufacturers pay $45K-$250K/yr..."

Validation: 14 slides, sldIdLst in sync, zip integrity OK.

Co-Authored-By: Claude Opus 4.7 (1M context) <noreply@anthropic.com>
</commit_message>
<xml_diff>
--- a/business/btfp/mimir_labs_investor_deck_rewrite_clean.pptx
+++ b/business/btfp/mimir_labs_investor_deck_rewrite_clean.pptx
@@ -9243,18 +9243,141 @@
       </p:sp>
       <p:sp>
         <p:nvSpPr>
-          <p:cNvPr id="9" name="Shape 7"/>
-          <p:cNvSpPr/>
-          <p:nvPr/>
-        </p:nvSpPr>
-        <p:spPr>
-          <a:xfrm>
-            <a:off x="868680" y="1417320"/>
-            <a:ext cx="3108960" cy="3520440"/>
+          <p:cNvPr id="18" name="Text 16"/>
+          <p:cNvSpPr/>
+          <p:nvPr/>
+        </p:nvSpPr>
+        <p:spPr>
+          <a:xfrm>
+            <a:off x="1115568" y="5532120"/>
+            <a:ext cx="9966960" cy="457200"/>
+          </a:xfrm>
+          <a:prstGeom prst="rect">
+            <a:avLst/>
+          </a:prstGeom>
+          <a:noFill/>
+          <a:ln/>
+        </p:spPr>
+        <p:txBody>
+          <a:bodyPr wrap="square" lIns="254" tIns="254" rIns="254" bIns="254" rtlCol="0" anchor="t">
+            <a:normAutofit/>
+          </a:bodyPr>
+          <a:lstStyle/>
+          <a:p>
+            <a:pPr algn="ctr" indent="0" marL="0">
+              <a:buNone/>
+            </a:pPr>
+            <a:r>
+              <a:rPr lang="en-US" sz="1800" b="1" dirty="0">
+                <a:solidFill>
+                  <a:srgbClr val="F4F8FB"/>
+                </a:solidFill>
+                <a:latin typeface="Aptos" pitchFamily="34" charset="0"/>
+                <a:ea typeface="Aptos" pitchFamily="34" charset="-122"/>
+                <a:cs typeface="Aptos" pitchFamily="34" charset="-120"/>
+              </a:rPr>
+              <a:t>Mid-market manufacturers pay $45K–$250K/yr to incumbents (Epicor, Sage, Infor) for systems they actively distrust. Same budget, better product.</a:t>
+            </a:r>
+            <a:endParaRPr lang="en-US" sz="1800" dirty="0"/>
+          </a:p>
+        </p:txBody>
+      </p:sp>
+      <p:sp>
+        <p:nvSpPr>
+          <p:cNvPr id="19" name="Text 17"/>
+          <p:cNvSpPr/>
+          <p:nvPr/>
+        </p:nvSpPr>
+        <p:spPr>
+          <a:xfrm>
+            <a:off x="594360" y="6473952"/>
+            <a:ext cx="2926080" cy="201168"/>
+          </a:xfrm>
+          <a:prstGeom prst="rect">
+            <a:avLst/>
+          </a:prstGeom>
+          <a:noFill/>
+          <a:ln/>
+        </p:spPr>
+        <p:txBody>
+          <a:bodyPr wrap="square" lIns="254" tIns="254" rIns="254" bIns="254" rtlCol="0" anchor="t">
+            <a:normAutofit/>
+          </a:bodyPr>
+          <a:lstStyle/>
+          <a:p>
+            <a:pPr algn="l" indent="0" marL="0">
+              <a:buNone/>
+            </a:pPr>
+            <a:r>
+              <a:rPr lang="en-US" sz="850" dirty="0">
+                <a:solidFill>
+                  <a:srgbClr val="6F889D"/>
+                </a:solidFill>
+                <a:latin typeface="Aptos" pitchFamily="34" charset="0"/>
+                <a:ea typeface="Aptos" pitchFamily="34" charset="-122"/>
+                <a:cs typeface="Aptos" pitchFamily="34" charset="-120"/>
+              </a:rPr>
+              <a:t>Mimir Labs • Investor Deck</a:t>
+            </a:r>
+            <a:endParaRPr lang="en-US" sz="850" dirty="0"/>
+          </a:p>
+        </p:txBody>
+      </p:sp>
+      <p:sp>
+        <p:nvSpPr>
+          <p:cNvPr id="20" name="Text 18"/>
+          <p:cNvSpPr/>
+          <p:nvPr/>
+        </p:nvSpPr>
+        <p:spPr>
+          <a:xfrm>
+            <a:off x="11292840" y="6473952"/>
+            <a:ext cx="411480" cy="201168"/>
+          </a:xfrm>
+          <a:prstGeom prst="rect">
+            <a:avLst/>
+          </a:prstGeom>
+          <a:noFill/>
+          <a:ln/>
+        </p:spPr>
+        <p:txBody>
+          <a:bodyPr wrap="square" lIns="254" tIns="254" rIns="254" bIns="254" rtlCol="0" anchor="t">
+            <a:normAutofit/>
+          </a:bodyPr>
+          <a:lstStyle/>
+          <a:p>
+            <a:pPr algn="r" indent="0" marL="0">
+              <a:buNone/>
+            </a:pPr>
+            <a:r>
+              <a:rPr lang="en-US" sz="850" dirty="0">
+                <a:solidFill>
+                  <a:srgbClr val="6F889D"/>
+                </a:solidFill>
+                <a:latin typeface="Aptos" pitchFamily="34" charset="0"/>
+                <a:ea typeface="Aptos" pitchFamily="34" charset="-122"/>
+                <a:cs typeface="Aptos" pitchFamily="34" charset="-120"/>
+              </a:rPr>
+              <a:t>06</a:t>
+            </a:r>
+            <a:endParaRPr lang="en-US" sz="850" dirty="0"/>
+          </a:p>
+        </p:txBody>
+      </p:sp>
+      <p:sp>
+        <p:nvSpPr>
+          <p:cNvPr id="21" name="Funnel TAM"/>
+          <p:cNvSpPr/>
+          <p:nvPr/>
+        </p:nvSpPr>
+        <p:spPr>
+          <a:xfrm>
+            <a:off x="1065276" y="1417320"/>
+            <a:ext cx="10058400" cy="1005840"/>
           </a:xfrm>
           <a:prstGeom prst="roundRect">
             <a:avLst>
-              <a:gd name="adj" fmla="val 2353"/>
+              <a:gd name="adj" fmla="val 8000"/>
             </a:avLst>
           </a:prstGeom>
           <a:solidFill>
@@ -9262,79 +9385,34 @@
               <a:alpha val="95000"/>
             </a:srgbClr>
           </a:solidFill>
-          <a:ln w="12700">
+          <a:ln w="19050">
             <a:solidFill>
               <a:srgbClr val="2B5A77"/>
             </a:solidFill>
             <a:prstDash val="solid"/>
           </a:ln>
         </p:spPr>
-      </p:sp>
-      <p:sp>
-        <p:nvSpPr>
-          <p:cNvPr id="10" name="Text 8"/>
-          <p:cNvSpPr/>
-          <p:nvPr/>
-        </p:nvSpPr>
-        <p:spPr>
-          <a:xfrm>
-            <a:off x="1069848" y="1664208"/>
-            <a:ext cx="2697480" cy="320040"/>
-          </a:xfrm>
-          <a:prstGeom prst="rect">
-            <a:avLst/>
-          </a:prstGeom>
-          <a:noFill/>
-          <a:ln/>
-        </p:spPr>
-        <p:txBody>
-          <a:bodyPr wrap="square" lIns="254" tIns="254" rIns="254" bIns="254" rtlCol="0" anchor="t">
-            <a:normAutofit/>
-          </a:bodyPr>
-          <a:lstStyle/>
-          <a:p>
-            <a:pPr algn="l" indent="0" marL="0">
-              <a:buNone/>
-            </a:pPr>
-            <a:r>
-              <a:rPr lang="en-US" sz="1800" b="1" dirty="0">
+        <p:txBody>
+          <a:bodyPr wrap="square" lIns="91440" tIns="91440" rIns="91440" bIns="91440" rtlCol="0" anchor="ctr">
+            <a:normAutofit/>
+          </a:bodyPr>
+          <a:lstStyle/>
+          <a:p>
+            <a:pPr algn="ctr" indent="0" marL="0">
+              <a:buNone/>
+            </a:pPr>
+            <a:r>
+              <a:rPr lang="en-US" sz="2800" b="1" dirty="0">
                 <a:solidFill>
                   <a:srgbClr val="2DE2D1"/>
                 </a:solidFill>
                 <a:latin typeface="Aptos" pitchFamily="34" charset="0"/>
-                <a:ea typeface="Aptos" pitchFamily="34" charset="-122"/>
-                <a:cs typeface="Aptos" pitchFamily="34" charset="-120"/>
-              </a:rPr>
-              <a:t>TAM — Global manufacturing ERP</a:t>
-            </a:r>
-            <a:endParaRPr lang="en-US" sz="1800" dirty="0"/>
-          </a:p>
-        </p:txBody>
-      </p:sp>
-      <p:sp>
-        <p:nvSpPr>
-          <p:cNvPr id="11" name="Text 9"/>
-          <p:cNvSpPr/>
-          <p:nvPr/>
-        </p:nvSpPr>
-        <p:spPr>
-          <a:xfrm>
-            <a:off x="1078992" y="2148840"/>
-            <a:ext cx="2377440" cy="1508760"/>
-          </a:xfrm>
-          <a:prstGeom prst="rect">
-            <a:avLst/>
-          </a:prstGeom>
-          <a:noFill/>
-          <a:ln/>
-        </p:spPr>
-        <p:txBody>
-          <a:bodyPr wrap="square" lIns="381" tIns="381" rIns="381" bIns="381" rtlCol="0" anchor="ctr">
-            <a:normAutofit/>
-          </a:bodyPr>
-          <a:lstStyle/>
-          <a:p>
-            <a:pPr indent="0" marL="0">
+              </a:rPr>
+              <a:t>$10B</a:t>
+            </a:r>
+          </a:p>
+          <a:p>
+            <a:pPr algn="ctr" indent="0" marL="0">
               <a:buNone/>
             </a:pPr>
             <a:r>
@@ -9343,154 +9421,61 @@
                   <a:srgbClr val="F4F8FB"/>
                 </a:solidFill>
                 <a:latin typeface="Aptos" pitchFamily="34" charset="0"/>
-                <a:ea typeface="Aptos" pitchFamily="34" charset="-122"/>
-                <a:cs typeface="Aptos" pitchFamily="34" charset="-120"/>
-              </a:rPr>
-              <a:t>• $10B+ market in 2024
-</a:t>
-            </a:r>
-            <a:pPr indent="0" marL="0">
-              <a:buNone/>
-            </a:pPr>
-            <a:r>
-              <a:rPr lang="en-US" sz="1800" dirty="0">
-                <a:solidFill>
-                  <a:srgbClr val="F4F8FB"/>
-                </a:solidFill>
-                <a:latin typeface="Aptos" pitchFamily="34" charset="0"/>
-                <a:ea typeface="Aptos" pitchFamily="34" charset="-122"/>
-                <a:cs typeface="Aptos" pitchFamily="34" charset="-120"/>
-              </a:rPr>
-              <a:t>• 8–10% CAGR through end of decade
-</a:t>
-            </a:r>
-            <a:pPr indent="0" marL="0">
-              <a:buNone/>
-            </a:pPr>
-            <a:r>
-              <a:rPr lang="en-US" sz="1800" dirty="0">
-                <a:solidFill>
-                  <a:srgbClr val="F4F8FB"/>
-                </a:solidFill>
-                <a:latin typeface="Aptos" pitchFamily="34" charset="0"/>
-                <a:ea typeface="Aptos" pitchFamily="34" charset="-122"/>
-                <a:cs typeface="Aptos" pitchFamily="34" charset="-120"/>
-              </a:rPr>
-              <a:t>• Full ERP market $281B by 2034 (Fortune)
-</a:t>
-            </a:r>
-            <a:pPr indent="0" marL="0">
-              <a:buNone/>
-            </a:pPr>
-            <a:r>
-              <a:rPr lang="en-US" sz="1800" dirty="0">
-                <a:solidFill>
-                  <a:srgbClr val="F4F8FB"/>
-                </a:solidFill>
-                <a:latin typeface="Aptos" pitchFamily="34" charset="0"/>
-                <a:ea typeface="Aptos" pitchFamily="34" charset="-122"/>
-                <a:cs typeface="Aptos" pitchFamily="34" charset="-120"/>
-              </a:rPr>
-              <a:t>• Digital transformation + Industry 4.0 tailwinds</a:t>
-            </a:r>
-            <a:endParaRPr lang="en-US" sz="1800" dirty="0"/>
-          </a:p>
-        </p:txBody>
-      </p:sp>
-      <p:sp>
-        <p:nvSpPr>
-          <p:cNvPr id="12" name="Shape 10"/>
-          <p:cNvSpPr/>
-          <p:nvPr/>
-        </p:nvSpPr>
-        <p:spPr>
-          <a:xfrm>
-            <a:off x="4526280" y="1417320"/>
-            <a:ext cx="3108960" cy="3520440"/>
+              </a:rPr>
+              <a:t>TAM — Global manufacturing ERP • 8–10% CAGR through 2030 • $281B full ERP by 2034</a:t>
+            </a:r>
+          </a:p>
+        </p:txBody>
+      </p:sp>
+      <p:sp>
+        <p:nvSpPr>
+          <p:cNvPr id="22" name="Funnel SAM"/>
+          <p:cNvSpPr/>
+          <p:nvPr/>
+        </p:nvSpPr>
+        <p:spPr>
+          <a:xfrm>
+            <a:off x="2894076" y="2606040"/>
+            <a:ext cx="6400800" cy="1005840"/>
           </a:xfrm>
           <a:prstGeom prst="roundRect">
             <a:avLst>
-              <a:gd name="adj" fmla="val 2353"/>
+              <a:gd name="adj" fmla="val 8000"/>
             </a:avLst>
           </a:prstGeom>
           <a:solidFill>
-            <a:srgbClr val="0F2235">
+            <a:srgbClr val="13344F">
               <a:alpha val="95000"/>
             </a:srgbClr>
           </a:solidFill>
-          <a:ln w="12700">
+          <a:ln w="19050">
             <a:solidFill>
               <a:srgbClr val="2B5A77"/>
             </a:solidFill>
             <a:prstDash val="solid"/>
           </a:ln>
         </p:spPr>
-      </p:sp>
-      <p:sp>
-        <p:nvSpPr>
-          <p:cNvPr id="13" name="Text 11"/>
-          <p:cNvSpPr/>
-          <p:nvPr/>
-        </p:nvSpPr>
-        <p:spPr>
-          <a:xfrm>
-            <a:off x="4727448" y="1664208"/>
-            <a:ext cx="2697480" cy="320040"/>
-          </a:xfrm>
-          <a:prstGeom prst="rect">
-            <a:avLst/>
-          </a:prstGeom>
-          <a:noFill/>
-          <a:ln/>
-        </p:spPr>
-        <p:txBody>
-          <a:bodyPr wrap="square" lIns="254" tIns="254" rIns="254" bIns="254" rtlCol="0" anchor="t">
-            <a:normAutofit/>
-          </a:bodyPr>
-          <a:lstStyle/>
-          <a:p>
-            <a:pPr algn="l" indent="0" marL="0">
-              <a:buNone/>
-            </a:pPr>
-            <a:r>
-              <a:rPr lang="en-US" sz="1800" b="1" dirty="0">
+        <p:txBody>
+          <a:bodyPr wrap="square" lIns="91440" tIns="91440" rIns="91440" bIns="91440" rtlCol="0" anchor="ctr">
+            <a:normAutofit/>
+          </a:bodyPr>
+          <a:lstStyle/>
+          <a:p>
+            <a:pPr algn="ctr" indent="0" marL="0">
+              <a:buNone/>
+            </a:pPr>
+            <a:r>
+              <a:rPr lang="en-US" sz="2800" b="1" dirty="0">
                 <a:solidFill>
                   <a:srgbClr val="2DE2D1"/>
                 </a:solidFill>
                 <a:latin typeface="Aptos" pitchFamily="34" charset="0"/>
-                <a:ea typeface="Aptos" pitchFamily="34" charset="-122"/>
-                <a:cs typeface="Aptos" pitchFamily="34" charset="-120"/>
-              </a:rPr>
-              <a:t>SAM — Mid-market manufacturing</a:t>
-            </a:r>
-            <a:endParaRPr lang="en-US" sz="1800" dirty="0"/>
-          </a:p>
-        </p:txBody>
-      </p:sp>
-      <p:sp>
-        <p:nvSpPr>
-          <p:cNvPr id="14" name="Text 12"/>
-          <p:cNvSpPr/>
-          <p:nvPr/>
-        </p:nvSpPr>
-        <p:spPr>
-          <a:xfrm>
-            <a:off x="4736592" y="2148840"/>
-            <a:ext cx="2377440" cy="1508760"/>
-          </a:xfrm>
-          <a:prstGeom prst="rect">
-            <a:avLst/>
-          </a:prstGeom>
-          <a:noFill/>
-          <a:ln/>
-        </p:spPr>
-        <p:txBody>
-          <a:bodyPr wrap="square" lIns="381" tIns="381" rIns="381" bIns="381" rtlCol="0" anchor="ctr">
-            <a:normAutofit/>
-          </a:bodyPr>
-          <a:lstStyle/>
-          <a:p>
-            <a:pPr indent="0" marL="0">
+              </a:rPr>
+              <a:t>~$3.5B</a:t>
+            </a:r>
+          </a:p>
+          <a:p>
+            <a:pPr algn="ctr" indent="0" marL="0">
               <a:buNone/>
             </a:pPr>
             <a:r>
@@ -9499,154 +9484,61 @@
                   <a:srgbClr val="F4F8FB"/>
                 </a:solidFill>
                 <a:latin typeface="Aptos" pitchFamily="34" charset="0"/>
-                <a:ea typeface="Aptos" pitchFamily="34" charset="-122"/>
-                <a:cs typeface="Aptos" pitchFamily="34" charset="-120"/>
-              </a:rPr>
-              <a:t>• 10–500 employee shops, US + EU
-</a:t>
-            </a:r>
-            <a:pPr indent="0" marL="0">
-              <a:buNone/>
-            </a:pPr>
-            <a:r>
-              <a:rPr lang="en-US" sz="1800" dirty="0">
-                <a:solidFill>
-                  <a:srgbClr val="F4F8FB"/>
-                </a:solidFill>
-                <a:latin typeface="Aptos" pitchFamily="34" charset="0"/>
-                <a:ea typeface="Aptos" pitchFamily="34" charset="-122"/>
-                <a:cs typeface="Aptos" pitchFamily="34" charset="-120"/>
-              </a:rPr>
-              <a:t>• ~30–40% of revenue, ~80% of customers
-</a:t>
-            </a:r>
-            <a:pPr indent="0" marL="0">
-              <a:buNone/>
-            </a:pPr>
-            <a:r>
-              <a:rPr lang="en-US" sz="1800" dirty="0">
-                <a:solidFill>
-                  <a:srgbClr val="F4F8FB"/>
-                </a:solidFill>
-                <a:latin typeface="Aptos" pitchFamily="34" charset="0"/>
-                <a:ea typeface="Aptos" pitchFamily="34" charset="-122"/>
-                <a:cs typeface="Aptos" pitchFamily="34" charset="-120"/>
-              </a:rPr>
-              <a:t>• Concentrated in discrete + mixed-mode
-</a:t>
-            </a:r>
-            <a:pPr indent="0" marL="0">
-              <a:buNone/>
-            </a:pPr>
-            <a:r>
-              <a:rPr lang="en-US" sz="1800" dirty="0">
-                <a:solidFill>
-                  <a:srgbClr val="F4F8FB"/>
-                </a:solidFill>
-                <a:latin typeface="Aptos" pitchFamily="34" charset="0"/>
-                <a:ea typeface="Aptos" pitchFamily="34" charset="-122"/>
-                <a:cs typeface="Aptos" pitchFamily="34" charset="-120"/>
-              </a:rPr>
-              <a:t>• AS9100, CMMC, ISO, ITAR regulated</a:t>
-            </a:r>
-            <a:endParaRPr lang="en-US" sz="1800" dirty="0"/>
-          </a:p>
-        </p:txBody>
-      </p:sp>
-      <p:sp>
-        <p:nvSpPr>
-          <p:cNvPr id="15" name="Shape 13"/>
-          <p:cNvSpPr/>
-          <p:nvPr/>
-        </p:nvSpPr>
-        <p:spPr>
-          <a:xfrm>
-            <a:off x="8183880" y="1417320"/>
-            <a:ext cx="3108960" cy="3520440"/>
+              </a:rPr>
+              <a:t>SAM — Mid-market manufacturing, 10–500 employees, US + EU • AS9100 / CMMC / ISO / ITAR</a:t>
+            </a:r>
+          </a:p>
+        </p:txBody>
+      </p:sp>
+      <p:sp>
+        <p:nvSpPr>
+          <p:cNvPr id="23" name="Funnel SOM"/>
+          <p:cNvSpPr/>
+          <p:nvPr/>
+        </p:nvSpPr>
+        <p:spPr>
+          <a:xfrm>
+            <a:off x="4494276" y="3794760"/>
+            <a:ext cx="3200400" cy="1005840"/>
           </a:xfrm>
           <a:prstGeom prst="roundRect">
             <a:avLst>
-              <a:gd name="adj" fmla="val 2353"/>
+              <a:gd name="adj" fmla="val 8000"/>
             </a:avLst>
           </a:prstGeom>
           <a:solidFill>
-            <a:srgbClr val="0F2235">
+            <a:srgbClr val="1A4F6E">
               <a:alpha val="95000"/>
             </a:srgbClr>
           </a:solidFill>
-          <a:ln w="12700">
+          <a:ln w="19050">
             <a:solidFill>
-              <a:srgbClr val="2B5A77"/>
+              <a:srgbClr val="2DE2D1"/>
             </a:solidFill>
             <a:prstDash val="solid"/>
           </a:ln>
         </p:spPr>
-      </p:sp>
-      <p:sp>
-        <p:nvSpPr>
-          <p:cNvPr id="16" name="Text 14"/>
-          <p:cNvSpPr/>
-          <p:nvPr/>
-        </p:nvSpPr>
-        <p:spPr>
-          <a:xfrm>
-            <a:off x="8385048" y="1664208"/>
-            <a:ext cx="2697480" cy="320040"/>
-          </a:xfrm>
-          <a:prstGeom prst="rect">
-            <a:avLst/>
-          </a:prstGeom>
-          <a:noFill/>
-          <a:ln/>
-        </p:spPr>
-        <p:txBody>
-          <a:bodyPr wrap="square" lIns="254" tIns="254" rIns="254" bIns="254" rtlCol="0" anchor="t">
-            <a:normAutofit/>
-          </a:bodyPr>
-          <a:lstStyle/>
-          <a:p>
-            <a:pPr algn="l" indent="0" marL="0">
-              <a:buNone/>
-            </a:pPr>
-            <a:r>
-              <a:rPr lang="en-US" sz="1800" b="1" dirty="0">
+        <p:txBody>
+          <a:bodyPr wrap="square" lIns="91440" tIns="91440" rIns="91440" bIns="91440" rtlCol="0" anchor="ctr">
+            <a:normAutofit/>
+          </a:bodyPr>
+          <a:lstStyle/>
+          <a:p>
+            <a:pPr algn="ctr" indent="0" marL="0">
+              <a:buNone/>
+            </a:pPr>
+            <a:r>
+              <a:rPr lang="en-US" sz="2800" b="1" dirty="0">
                 <a:solidFill>
                   <a:srgbClr val="2DE2D1"/>
                 </a:solidFill>
                 <a:latin typeface="Aptos" pitchFamily="34" charset="0"/>
-                <a:ea typeface="Aptos" pitchFamily="34" charset="-122"/>
-                <a:cs typeface="Aptos" pitchFamily="34" charset="-120"/>
-              </a:rPr>
-              <a:t>SOM — PA + adjacent reachable in 36 months</a:t>
-            </a:r>
-            <a:endParaRPr lang="en-US" sz="1800" dirty="0"/>
-          </a:p>
-        </p:txBody>
-      </p:sp>
-      <p:sp>
-        <p:nvSpPr>
-          <p:cNvPr id="17" name="Text 15"/>
-          <p:cNvSpPr/>
-          <p:nvPr/>
-        </p:nvSpPr>
-        <p:spPr>
-          <a:xfrm>
-            <a:off x="8394192" y="2148840"/>
-            <a:ext cx="2377440" cy="1508760"/>
-          </a:xfrm>
-          <a:prstGeom prst="rect">
-            <a:avLst/>
-          </a:prstGeom>
-          <a:noFill/>
-          <a:ln/>
-        </p:spPr>
-        <p:txBody>
-          <a:bodyPr wrap="square" lIns="381" tIns="381" rIns="381" bIns="381" rtlCol="0" anchor="ctr">
-            <a:normAutofit/>
-          </a:bodyPr>
-          <a:lstStyle/>
-          <a:p>
-            <a:pPr indent="0" marL="0">
+              </a:rPr>
+              <a:t>~$160M</a:t>
+            </a:r>
+          </a:p>
+          <a:p>
+            <a:pPr algn="ctr" indent="0" marL="0">
               <a:buNone/>
             </a:pPr>
             <a:r>
@@ -9655,180 +9547,9 @@
                   <a:srgbClr val="F4F8FB"/>
                 </a:solidFill>
                 <a:latin typeface="Aptos" pitchFamily="34" charset="0"/>
-                <a:ea typeface="Aptos" pitchFamily="34" charset="-122"/>
-                <a:cs typeface="Aptos" pitchFamily="34" charset="-120"/>
-              </a:rPr>
-              <a:t>• ~3,500 qualifying manufacturers in PA / OH / MD / NJ / NY
-</a:t>
-            </a:r>
-            <a:pPr indent="0" marL="0">
-              <a:buNone/>
-            </a:pPr>
-            <a:r>
-              <a:rPr lang="en-US" sz="1800" dirty="0">
-                <a:solidFill>
-                  <a:srgbClr val="F4F8FB"/>
-                </a:solidFill>
-                <a:latin typeface="Aptos" pitchFamily="34" charset="0"/>
-                <a:ea typeface="Aptos" pitchFamily="34" charset="-122"/>
-                <a:cs typeface="Aptos" pitchFamily="34" charset="-120"/>
-              </a:rPr>
-              <a:t>• Target: 50–150 paying customers by Year 5
-</a:t>
-            </a:r>
-            <a:pPr indent="0" marL="0">
-              <a:buNone/>
-            </a:pPr>
-            <a:r>
-              <a:rPr lang="en-US" sz="1800" dirty="0">
-                <a:solidFill>
-                  <a:srgbClr val="F4F8FB"/>
-                </a:solidFill>
-                <a:latin typeface="Aptos" pitchFamily="34" charset="0"/>
-                <a:ea typeface="Aptos" pitchFamily="34" charset="-122"/>
-                <a:cs typeface="Aptos" pitchFamily="34" charset="-120"/>
-              </a:rPr>
-              <a:t>• Wedge via Ratatosk workshops; convert ~30% to platform
-</a:t>
-            </a:r>
-            <a:pPr indent="0" marL="0">
-              <a:buNone/>
-            </a:pPr>
-            <a:r>
-              <a:rPr lang="en-US" sz="1800" dirty="0">
-                <a:solidFill>
-                  <a:srgbClr val="F4F8FB"/>
-                </a:solidFill>
-                <a:latin typeface="Aptos" pitchFamily="34" charset="0"/>
-                <a:ea typeface="Aptos" pitchFamily="34" charset="-122"/>
-                <a:cs typeface="Aptos" pitchFamily="34" charset="-120"/>
-              </a:rPr>
-              <a:t>• PA-grown, MANTEC-aligned, US-hosted</a:t>
-            </a:r>
-            <a:endParaRPr lang="en-US" sz="1800" dirty="0"/>
-          </a:p>
-        </p:txBody>
-      </p:sp>
-      <p:sp>
-        <p:nvSpPr>
-          <p:cNvPr id="18" name="Text 16"/>
-          <p:cNvSpPr/>
-          <p:nvPr/>
-        </p:nvSpPr>
-        <p:spPr>
-          <a:xfrm>
-            <a:off x="1115568" y="5532120"/>
-            <a:ext cx="9966960" cy="457200"/>
-          </a:xfrm>
-          <a:prstGeom prst="rect">
-            <a:avLst/>
-          </a:prstGeom>
-          <a:noFill/>
-          <a:ln/>
-        </p:spPr>
-        <p:txBody>
-          <a:bodyPr wrap="square" lIns="254" tIns="254" rIns="254" bIns="254" rtlCol="0" anchor="t">
-            <a:normAutofit/>
-          </a:bodyPr>
-          <a:lstStyle/>
-          <a:p>
-            <a:pPr algn="ctr" indent="0" marL="0">
-              <a:buNone/>
-            </a:pPr>
-            <a:r>
-              <a:rPr lang="en-US" sz="1800" b="1" dirty="0">
-                <a:solidFill>
-                  <a:srgbClr val="F4F8FB"/>
-                </a:solidFill>
-                <a:latin typeface="Aptos" pitchFamily="34" charset="0"/>
-                <a:ea typeface="Aptos" pitchFamily="34" charset="-122"/>
-                <a:cs typeface="Aptos" pitchFamily="34" charset="-120"/>
-              </a:rPr>
-              <a:t>Mid-market manufacturers pay $45K–$250K/yr to incumbents (Epicor, Sage, Infor) for systems they actively distrust. Same budget, better product.</a:t>
-            </a:r>
-            <a:endParaRPr lang="en-US" sz="1800" dirty="0"/>
-          </a:p>
-        </p:txBody>
-      </p:sp>
-      <p:sp>
-        <p:nvSpPr>
-          <p:cNvPr id="19" name="Text 17"/>
-          <p:cNvSpPr/>
-          <p:nvPr/>
-        </p:nvSpPr>
-        <p:spPr>
-          <a:xfrm>
-            <a:off x="594360" y="6473952"/>
-            <a:ext cx="2926080" cy="201168"/>
-          </a:xfrm>
-          <a:prstGeom prst="rect">
-            <a:avLst/>
-          </a:prstGeom>
-          <a:noFill/>
-          <a:ln/>
-        </p:spPr>
-        <p:txBody>
-          <a:bodyPr wrap="square" lIns="254" tIns="254" rIns="254" bIns="254" rtlCol="0" anchor="t">
-            <a:normAutofit/>
-          </a:bodyPr>
-          <a:lstStyle/>
-          <a:p>
-            <a:pPr algn="l" indent="0" marL="0">
-              <a:buNone/>
-            </a:pPr>
-            <a:r>
-              <a:rPr lang="en-US" sz="850" dirty="0">
-                <a:solidFill>
-                  <a:srgbClr val="6F889D"/>
-                </a:solidFill>
-                <a:latin typeface="Aptos" pitchFamily="34" charset="0"/>
-                <a:ea typeface="Aptos" pitchFamily="34" charset="-122"/>
-                <a:cs typeface="Aptos" pitchFamily="34" charset="-120"/>
-              </a:rPr>
-              <a:t>Mimir Labs • Investor Deck</a:t>
-            </a:r>
-            <a:endParaRPr lang="en-US" sz="850" dirty="0"/>
-          </a:p>
-        </p:txBody>
-      </p:sp>
-      <p:sp>
-        <p:nvSpPr>
-          <p:cNvPr id="20" name="Text 18"/>
-          <p:cNvSpPr/>
-          <p:nvPr/>
-        </p:nvSpPr>
-        <p:spPr>
-          <a:xfrm>
-            <a:off x="11292840" y="6473952"/>
-            <a:ext cx="411480" cy="201168"/>
-          </a:xfrm>
-          <a:prstGeom prst="rect">
-            <a:avLst/>
-          </a:prstGeom>
-          <a:noFill/>
-          <a:ln/>
-        </p:spPr>
-        <p:txBody>
-          <a:bodyPr wrap="square" lIns="254" tIns="254" rIns="254" bIns="254" rtlCol="0" anchor="t">
-            <a:normAutofit/>
-          </a:bodyPr>
-          <a:lstStyle/>
-          <a:p>
-            <a:pPr algn="r" indent="0" marL="0">
-              <a:buNone/>
-            </a:pPr>
-            <a:r>
-              <a:rPr lang="en-US" sz="850" dirty="0">
-                <a:solidFill>
-                  <a:srgbClr val="6F889D"/>
-                </a:solidFill>
-                <a:latin typeface="Aptos" pitchFamily="34" charset="0"/>
-                <a:ea typeface="Aptos" pitchFamily="34" charset="-122"/>
-                <a:cs typeface="Aptos" pitchFamily="34" charset="-120"/>
-              </a:rPr>
-              <a:t>06</a:t>
-            </a:r>
-            <a:endParaRPr lang="en-US" sz="850" dirty="0"/>
+              </a:rPr>
+              <a:t>SOM — PA + adjacent, 3,500 shops • Target 50–150 by Year 5</a:t>
+            </a:r>
           </a:p>
         </p:txBody>
       </p:sp>

</xml_diff>

<commit_message>
BFTP deck: slide 12 revenue line chart + slide 6 beachhead state strip
Slide 12 (Financials):
- Removed 5 stacked year cards (15 shapes)
- Built native PPTX line chart: revenue trajectory through Y1-Y5
  - Teal line through 5 data point markers, $241K to $17.6M
  - Y-axis: $0/$5M/$10M/$15M with horizontal gridlines
  - Value labels above each point (18pt teal bold)
  - Year labels below x-axis (14pt)
  - ARR strip below chart: Y3 $2.4M / Y4 $6.2M / Y5 $13.4M
  - Chart title: "Revenue trajectory - $241K to $17.6M - ~135% CAGR"

Slide 6 (Market):
- Added 5-state beachhead strip below the SOM funnel bar
- "BEACHHEAD -> [OH] [PA] [NY] [NJ] [MD]" with shop counts
- PA tile gets teal accent stroke (the home base)
- Other states: navy fill, medium-navy stroke
- Sums to ~3,500 shops, matching the SOM bar number

Validation: 14 slides, sldIdLst + app.xml in sync, all XML parses clean.

Co-Authored-By: Claude Opus 4.7 (1M context) <noreply@anthropic.com>
</commit_message>
<xml_diff>
--- a/business/btfp/mimir_labs_investor_deck_rewrite_clean.pptx
+++ b/business/btfp/mimir_labs_investor_deck_rewrite_clean.pptx
@@ -3666,26 +3666,186 @@
       </p:sp>
       <p:sp>
         <p:nvSpPr>
-          <p:cNvPr id="9" name="Shape 7"/>
-          <p:cNvSpPr/>
-          <p:nvPr/>
-        </p:nvSpPr>
-        <p:spPr>
-          <a:xfrm>
-            <a:off x="822960" y="1417320"/>
-            <a:ext cx="10607040" cy="512064"/>
-          </a:xfrm>
-          <a:prstGeom prst="roundRect">
-            <a:avLst>
-              <a:gd name="adj" fmla="val 14286"/>
-            </a:avLst>
-          </a:prstGeom>
-          <a:solidFill>
-            <a:srgbClr val="06111C">
-              <a:alpha val="93000"/>
-            </a:srgbClr>
-          </a:solidFill>
+          <p:cNvPr id="24" name="Text 22"/>
+          <p:cNvSpPr/>
+          <p:nvPr/>
+        </p:nvSpPr>
+        <p:spPr>
+          <a:xfrm>
+            <a:off x="914400" y="5715000"/>
+            <a:ext cx="10241280" cy="393192"/>
+          </a:xfrm>
+          <a:prstGeom prst="rect">
+            <a:avLst/>
+          </a:prstGeom>
+          <a:noFill/>
+          <a:ln/>
+        </p:spPr>
+        <p:txBody>
+          <a:bodyPr wrap="square" lIns="254" tIns="254" rIns="254" bIns="254" rtlCol="0" anchor="t">
+            <a:normAutofit/>
+          </a:bodyPr>
+          <a:lstStyle/>
+          <a:p>
+            <a:pPr algn="ctr" indent="0" marL="0">
+              <a:buNone/>
+            </a:pPr>
+            <a:r>
+              <a:rPr lang="en-US" sz="1800" b="1" dirty="0">
+                <a:solidFill>
+                  <a:srgbClr val="F4F8FB"/>
+                </a:solidFill>
+                <a:latin typeface="Aptos" pitchFamily="34" charset="0"/>
+                <a:ea typeface="Aptos" pitchFamily="34" charset="-122"/>
+                <a:cs typeface="Aptos" pitchFamily="34" charset="-120"/>
+              </a:rPr>
+              <a:t>Implied Year-5 valuation: $50–90M on 5–8x ARR multiple. Series A target: Q4 2027 at $500K ARR + 3 Yggdrasil tenants.</a:t>
+            </a:r>
+            <a:endParaRPr lang="en-US" sz="1800" dirty="0"/>
+          </a:p>
+        </p:txBody>
+      </p:sp>
+      <p:sp>
+        <p:nvSpPr>
+          <p:cNvPr id="25" name="Text 23"/>
+          <p:cNvSpPr/>
+          <p:nvPr/>
+        </p:nvSpPr>
+        <p:spPr>
+          <a:xfrm>
+            <a:off x="594360" y="6473952"/>
+            <a:ext cx="2926080" cy="201168"/>
+          </a:xfrm>
+          <a:prstGeom prst="rect">
+            <a:avLst/>
+          </a:prstGeom>
+          <a:noFill/>
+          <a:ln/>
+        </p:spPr>
+        <p:txBody>
+          <a:bodyPr wrap="square" lIns="254" tIns="254" rIns="254" bIns="254" rtlCol="0" anchor="t">
+            <a:normAutofit/>
+          </a:bodyPr>
+          <a:lstStyle/>
+          <a:p>
+            <a:pPr algn="l" indent="0" marL="0">
+              <a:buNone/>
+            </a:pPr>
+            <a:r>
+              <a:rPr lang="en-US" sz="850" dirty="0">
+                <a:solidFill>
+                  <a:srgbClr val="6F889D"/>
+                </a:solidFill>
+                <a:latin typeface="Aptos" pitchFamily="34" charset="0"/>
+                <a:ea typeface="Aptos" pitchFamily="34" charset="-122"/>
+                <a:cs typeface="Aptos" pitchFamily="34" charset="-120"/>
+              </a:rPr>
+              <a:t>Mimir Labs • Investor Deck</a:t>
+            </a:r>
+            <a:endParaRPr lang="en-US" sz="850" dirty="0"/>
+          </a:p>
+        </p:txBody>
+      </p:sp>
+      <p:sp>
+        <p:nvSpPr>
+          <p:cNvPr id="26" name="Text 24"/>
+          <p:cNvSpPr/>
+          <p:nvPr/>
+        </p:nvSpPr>
+        <p:spPr>
+          <a:xfrm>
+            <a:off x="11292840" y="6473952"/>
+            <a:ext cx="411480" cy="201168"/>
+          </a:xfrm>
+          <a:prstGeom prst="rect">
+            <a:avLst/>
+          </a:prstGeom>
+          <a:noFill/>
+          <a:ln/>
+        </p:spPr>
+        <p:txBody>
+          <a:bodyPr wrap="square" lIns="254" tIns="254" rIns="254" bIns="254" rtlCol="0" anchor="t">
+            <a:normAutofit/>
+          </a:bodyPr>
+          <a:lstStyle/>
+          <a:p>
+            <a:pPr algn="r" indent="0" marL="0">
+              <a:buNone/>
+            </a:pPr>
+            <a:r>
+              <a:rPr lang="en-US" sz="850" dirty="0">
+                <a:solidFill>
+                  <a:srgbClr val="6F889D"/>
+                </a:solidFill>
+                <a:latin typeface="Aptos" pitchFamily="34" charset="0"/>
+                <a:ea typeface="Aptos" pitchFamily="34" charset="-122"/>
+                <a:cs typeface="Aptos" pitchFamily="34" charset="-120"/>
+              </a:rPr>
+              <a:t>12</a:t>
+            </a:r>
+            <a:endParaRPr lang="en-US" sz="850" dirty="0"/>
+          </a:p>
+        </p:txBody>
+      </p:sp>
+      <p:sp>
+        <p:nvSpPr>
+          <p:cNvPr id="100" name="ChartXAxis"/>
+          <p:cNvSpPr/>
+          <p:nvPr/>
+        </p:nvSpPr>
+        <p:spPr>
+          <a:xfrm>
+            <a:off x="1371600" y="4846320"/>
+            <a:ext cx="10058400" cy="0"/>
+          </a:xfrm>
+          <a:prstGeom prst="line">
+            <a:avLst/>
+          </a:prstGeom>
           <a:ln w="12700">
+            <a:solidFill>
+              <a:srgbClr val="6F889D"/>
+            </a:solidFill>
+            <a:prstDash val="solid"/>
+          </a:ln>
+        </p:spPr>
+      </p:sp>
+      <p:sp>
+        <p:nvSpPr>
+          <p:cNvPr id="101" name="ChartYAxis"/>
+          <p:cNvSpPr/>
+          <p:nvPr/>
+        </p:nvSpPr>
+        <p:spPr>
+          <a:xfrm>
+            <a:off x="1371600" y="1874520"/>
+            <a:ext cx="0" cy="2971800"/>
+          </a:xfrm>
+          <a:prstGeom prst="line">
+            <a:avLst/>
+          </a:prstGeom>
+          <a:ln w="12700">
+            <a:solidFill>
+              <a:srgbClr val="6F889D"/>
+            </a:solidFill>
+            <a:prstDash val="solid"/>
+          </a:ln>
+        </p:spPr>
+      </p:sp>
+      <p:sp>
+        <p:nvSpPr>
+          <p:cNvPr id="102" name="Grid5M"/>
+          <p:cNvSpPr/>
+          <p:nvPr/>
+        </p:nvSpPr>
+        <p:spPr>
+          <a:xfrm>
+            <a:off x="1371600" y="4103370"/>
+            <a:ext cx="10058400" cy="0"/>
+          </a:xfrm>
+          <a:prstGeom prst="line">
+            <a:avLst/>
+          </a:prstGeom>
+          <a:ln w="6350">
             <a:solidFill>
               <a:srgbClr val="244A65"/>
             </a:solidFill>
@@ -3695,108 +3855,57 @@
       </p:sp>
       <p:sp>
         <p:nvSpPr>
-          <p:cNvPr id="10" name="Text 8"/>
-          <p:cNvSpPr/>
-          <p:nvPr/>
-        </p:nvSpPr>
-        <p:spPr>
-          <a:xfrm>
-            <a:off x="1051560" y="1563624"/>
-            <a:ext cx="1097280" cy="164592"/>
-          </a:xfrm>
-          <a:prstGeom prst="rect">
-            <a:avLst/>
-          </a:prstGeom>
-          <a:noFill/>
-          <a:ln/>
-        </p:spPr>
-        <p:txBody>
-          <a:bodyPr wrap="square" lIns="254" tIns="254" rIns="254" bIns="254" rtlCol="0" anchor="t">
-            <a:normAutofit/>
-          </a:bodyPr>
-          <a:lstStyle/>
-          <a:p>
-            <a:pPr algn="l" indent="0" marL="0">
-              <a:buNone/>
-            </a:pPr>
-            <a:r>
-              <a:rPr lang="en-US" sz="1800" b="1" dirty="0">
-                <a:solidFill>
-                  <a:srgbClr val="F6C65B"/>
-                </a:solidFill>
-                <a:latin typeface="Aptos" pitchFamily="34" charset="0"/>
-                <a:ea typeface="Aptos" pitchFamily="34" charset="-122"/>
-                <a:cs typeface="Aptos" pitchFamily="34" charset="-120"/>
-              </a:rPr>
-              <a:t>Year 1 — Foundation</a:t>
-            </a:r>
-            <a:endParaRPr lang="en-US" sz="1800" dirty="0"/>
-          </a:p>
-        </p:txBody>
-      </p:sp>
-      <p:sp>
-        <p:nvSpPr>
-          <p:cNvPr id="11" name="Text 9"/>
-          <p:cNvSpPr/>
-          <p:nvPr/>
-        </p:nvSpPr>
-        <p:spPr>
-          <a:xfrm>
-            <a:off x="2286000" y="1554480"/>
-            <a:ext cx="8686800" cy="182880"/>
-          </a:xfrm>
-          <a:prstGeom prst="rect">
-            <a:avLst/>
-          </a:prstGeom>
-          <a:noFill/>
-          <a:ln/>
-        </p:spPr>
-        <p:txBody>
-          <a:bodyPr wrap="square" lIns="254" tIns="254" rIns="254" bIns="254" rtlCol="0" anchor="t">
-            <a:normAutofit/>
-          </a:bodyPr>
-          <a:lstStyle/>
-          <a:p>
-            <a:pPr algn="l" indent="0" marL="0">
-              <a:buNone/>
-            </a:pPr>
-            <a:r>
-              <a:rPr lang="en-US" sz="1800" dirty="0">
-                <a:solidFill>
-                  <a:srgbClr val="F4F8FB"/>
-                </a:solidFill>
-                <a:latin typeface="Aptos" pitchFamily="34" charset="0"/>
-                <a:ea typeface="Aptos" pitchFamily="34" charset="-122"/>
-                <a:cs typeface="Aptos" pitchFamily="34" charset="-120"/>
-              </a:rPr>
-              <a:t>$241K total revenue. Solo founder. 3 Yggdrasil pilots, 4 Ratatosk workshops, 1 Ragnarok migration, Norn launches. Net (-$23K).</a:t>
-            </a:r>
-            <a:endParaRPr lang="en-US" sz="1800" dirty="0"/>
-          </a:p>
-        </p:txBody>
-      </p:sp>
-      <p:sp>
-        <p:nvSpPr>
-          <p:cNvPr id="12" name="Shape 10"/>
-          <p:cNvSpPr/>
-          <p:nvPr/>
-        </p:nvSpPr>
-        <p:spPr>
-          <a:xfrm>
-            <a:off x="822960" y="2148840"/>
-            <a:ext cx="10607040" cy="512064"/>
-          </a:xfrm>
-          <a:prstGeom prst="roundRect">
-            <a:avLst>
-              <a:gd name="adj" fmla="val 14286"/>
-            </a:avLst>
-          </a:prstGeom>
-          <a:solidFill>
-            <a:srgbClr val="06111C">
-              <a:alpha val="93000"/>
-            </a:srgbClr>
-          </a:solidFill>
-          <a:ln w="12700">
+          <p:cNvPr id="103" name="YLabel5"/>
+          <p:cNvSpPr/>
+          <p:nvPr/>
+        </p:nvSpPr>
+        <p:spPr>
+          <a:xfrm>
+            <a:off x="594360" y="3984498"/>
+            <a:ext cx="685800" cy="237744"/>
+          </a:xfrm>
+          <a:prstGeom prst="rect">
+            <a:avLst/>
+          </a:prstGeom>
+          <a:noFill/>
+          <a:ln/>
+        </p:spPr>
+        <p:txBody>
+          <a:bodyPr wrap="square" lIns="36576" tIns="36576" rIns="36576" bIns="36576" rtlCol="0" anchor="ctr">
+            <a:normAutofit/>
+          </a:bodyPr>
+          <a:lstStyle/>
+          <a:p>
+            <a:pPr algn="r" indent="0" marL="0">
+              <a:buNone/>
+            </a:pPr>
+            <a:r>
+              <a:rPr lang="en-US" sz="1100" dirty="0">
+                <a:solidFill>
+                  <a:srgbClr val="6F889D"/>
+                </a:solidFill>
+                <a:latin typeface="Aptos" pitchFamily="34" charset="0"/>
+              </a:rPr>
+              <a:t>$5M</a:t>
+            </a:r>
+          </a:p>
+        </p:txBody>
+      </p:sp>
+      <p:sp>
+        <p:nvSpPr>
+          <p:cNvPr id="104" name="Grid10M"/>
+          <p:cNvSpPr/>
+          <p:nvPr/>
+        </p:nvSpPr>
+        <p:spPr>
+          <a:xfrm>
+            <a:off x="1371600" y="3360420"/>
+            <a:ext cx="10058400" cy="0"/>
+          </a:xfrm>
+          <a:prstGeom prst="line">
+            <a:avLst/>
+          </a:prstGeom>
+          <a:ln w="6350">
             <a:solidFill>
               <a:srgbClr val="244A65"/>
             </a:solidFill>
@@ -3806,108 +3915,57 @@
       </p:sp>
       <p:sp>
         <p:nvSpPr>
-          <p:cNvPr id="13" name="Text 11"/>
-          <p:cNvSpPr/>
-          <p:nvPr/>
-        </p:nvSpPr>
-        <p:spPr>
-          <a:xfrm>
-            <a:off x="1051560" y="2295144"/>
-            <a:ext cx="1097280" cy="164592"/>
-          </a:xfrm>
-          <a:prstGeom prst="rect">
-            <a:avLst/>
-          </a:prstGeom>
-          <a:noFill/>
-          <a:ln/>
-        </p:spPr>
-        <p:txBody>
-          <a:bodyPr wrap="square" lIns="254" tIns="254" rIns="254" bIns="254" rtlCol="0" anchor="t">
-            <a:normAutofit/>
-          </a:bodyPr>
-          <a:lstStyle/>
-          <a:p>
-            <a:pPr algn="l" indent="0" marL="0">
-              <a:buNone/>
-            </a:pPr>
-            <a:r>
-              <a:rPr lang="en-US" sz="1800" b="1" dirty="0">
-                <a:solidFill>
-                  <a:srgbClr val="F6C65B"/>
-                </a:solidFill>
-                <a:latin typeface="Aptos" pitchFamily="34" charset="0"/>
-                <a:ea typeface="Aptos" pitchFamily="34" charset="-122"/>
-                <a:cs typeface="Aptos" pitchFamily="34" charset="-120"/>
-              </a:rPr>
-              <a:t>Year 2 — First hires</a:t>
-            </a:r>
-            <a:endParaRPr lang="en-US" sz="1800" dirty="0"/>
-          </a:p>
-        </p:txBody>
-      </p:sp>
-      <p:sp>
-        <p:nvSpPr>
-          <p:cNvPr id="14" name="Text 12"/>
-          <p:cNvSpPr/>
-          <p:nvPr/>
-        </p:nvSpPr>
-        <p:spPr>
-          <a:xfrm>
-            <a:off x="2286000" y="2286000"/>
-            <a:ext cx="8686800" cy="182880"/>
-          </a:xfrm>
-          <a:prstGeom prst="rect">
-            <a:avLst/>
-          </a:prstGeom>
-          <a:noFill/>
-          <a:ln/>
-        </p:spPr>
-        <p:txBody>
-          <a:bodyPr wrap="square" lIns="254" tIns="254" rIns="254" bIns="254" rtlCol="0" anchor="t">
-            <a:normAutofit/>
-          </a:bodyPr>
-          <a:lstStyle/>
-          <a:p>
-            <a:pPr algn="l" indent="0" marL="0">
-              <a:buNone/>
-            </a:pPr>
-            <a:r>
-              <a:rPr lang="en-US" sz="1800" dirty="0">
-                <a:solidFill>
-                  <a:srgbClr val="F4F8FB"/>
-                </a:solidFill>
-                <a:latin typeface="Aptos" pitchFamily="34" charset="0"/>
-                <a:ea typeface="Aptos" pitchFamily="34" charset="-122"/>
-                <a:cs typeface="Aptos" pitchFamily="34" charset="-120"/>
-              </a:rPr>
-              <a:t>$1.14M revenue. 3 FTE. 12 Ratatosk, 6 Ragnarok, first Bifrost subscribers, 4 Yggdrasil pilots. Cash-flow positive ($168K net).</a:t>
-            </a:r>
-            <a:endParaRPr lang="en-US" sz="1800" dirty="0"/>
-          </a:p>
-        </p:txBody>
-      </p:sp>
-      <p:sp>
-        <p:nvSpPr>
-          <p:cNvPr id="15" name="Shape 13"/>
-          <p:cNvSpPr/>
-          <p:nvPr/>
-        </p:nvSpPr>
-        <p:spPr>
-          <a:xfrm>
-            <a:off x="822960" y="2880360"/>
-            <a:ext cx="10607040" cy="512064"/>
-          </a:xfrm>
-          <a:prstGeom prst="roundRect">
-            <a:avLst>
-              <a:gd name="adj" fmla="val 14286"/>
-            </a:avLst>
-          </a:prstGeom>
-          <a:solidFill>
-            <a:srgbClr val="06111C">
-              <a:alpha val="93000"/>
-            </a:srgbClr>
-          </a:solidFill>
-          <a:ln w="12700">
+          <p:cNvPr id="105" name="YLabel10"/>
+          <p:cNvSpPr/>
+          <p:nvPr/>
+        </p:nvSpPr>
+        <p:spPr>
+          <a:xfrm>
+            <a:off x="594360" y="3241548"/>
+            <a:ext cx="685800" cy="237744"/>
+          </a:xfrm>
+          <a:prstGeom prst="rect">
+            <a:avLst/>
+          </a:prstGeom>
+          <a:noFill/>
+          <a:ln/>
+        </p:spPr>
+        <p:txBody>
+          <a:bodyPr wrap="square" lIns="36576" tIns="36576" rIns="36576" bIns="36576" rtlCol="0" anchor="ctr">
+            <a:normAutofit/>
+          </a:bodyPr>
+          <a:lstStyle/>
+          <a:p>
+            <a:pPr algn="r" indent="0" marL="0">
+              <a:buNone/>
+            </a:pPr>
+            <a:r>
+              <a:rPr lang="en-US" sz="1100" dirty="0">
+                <a:solidFill>
+                  <a:srgbClr val="6F889D"/>
+                </a:solidFill>
+                <a:latin typeface="Aptos" pitchFamily="34" charset="0"/>
+              </a:rPr>
+              <a:t>$10M</a:t>
+            </a:r>
+          </a:p>
+        </p:txBody>
+      </p:sp>
+      <p:sp>
+        <p:nvSpPr>
+          <p:cNvPr id="106" name="Grid15M"/>
+          <p:cNvSpPr/>
+          <p:nvPr/>
+        </p:nvSpPr>
+        <p:spPr>
+          <a:xfrm>
+            <a:off x="1371600" y="2617470"/>
+            <a:ext cx="10058400" cy="0"/>
+          </a:xfrm>
+          <a:prstGeom prst="line">
+            <a:avLst/>
+          </a:prstGeom>
+          <a:ln w="6350">
             <a:solidFill>
               <a:srgbClr val="244A65"/>
             </a:solidFill>
@@ -3917,110 +3975,97 @@
       </p:sp>
       <p:sp>
         <p:nvSpPr>
-          <p:cNvPr id="16" name="Text 14"/>
-          <p:cNvSpPr/>
-          <p:nvPr/>
-        </p:nvSpPr>
-        <p:spPr>
-          <a:xfrm>
-            <a:off x="1051560" y="3026664"/>
-            <a:ext cx="1097280" cy="164592"/>
-          </a:xfrm>
-          <a:prstGeom prst="rect">
-            <a:avLst/>
-          </a:prstGeom>
-          <a:noFill/>
-          <a:ln/>
-        </p:spPr>
-        <p:txBody>
-          <a:bodyPr wrap="square" lIns="254" tIns="254" rIns="254" bIns="254" rtlCol="0" anchor="t">
-            <a:normAutofit/>
-          </a:bodyPr>
-          <a:lstStyle/>
-          <a:p>
-            <a:pPr algn="l" indent="0" marL="0">
-              <a:buNone/>
-            </a:pPr>
-            <a:r>
-              <a:rPr lang="en-US" sz="1800" b="1" dirty="0">
-                <a:solidFill>
-                  <a:srgbClr val="F6C65B"/>
-                </a:solidFill>
-                <a:latin typeface="Aptos" pitchFamily="34" charset="0"/>
-                <a:ea typeface="Aptos" pitchFamily="34" charset="-122"/>
-                <a:cs typeface="Aptos" pitchFamily="34" charset="-120"/>
-              </a:rPr>
-              <a:t>Year 3 — Platform proves out</a:t>
-            </a:r>
-            <a:endParaRPr lang="en-US" sz="1800" dirty="0"/>
-          </a:p>
-        </p:txBody>
-      </p:sp>
-      <p:sp>
-        <p:nvSpPr>
-          <p:cNvPr id="17" name="Text 15"/>
-          <p:cNvSpPr/>
-          <p:nvPr/>
-        </p:nvSpPr>
-        <p:spPr>
-          <a:xfrm>
-            <a:off x="2286000" y="3017520"/>
-            <a:ext cx="8686800" cy="182880"/>
-          </a:xfrm>
-          <a:prstGeom prst="rect">
-            <a:avLst/>
-          </a:prstGeom>
-          <a:noFill/>
-          <a:ln/>
-        </p:spPr>
-        <p:txBody>
-          <a:bodyPr wrap="square" lIns="254" tIns="254" rIns="254" bIns="254" rtlCol="0" anchor="t">
-            <a:normAutofit/>
-          </a:bodyPr>
-          <a:lstStyle/>
-          <a:p>
-            <a:pPr algn="l" indent="0" marL="0">
-              <a:buNone/>
-            </a:pPr>
-            <a:r>
-              <a:rPr lang="en-US" sz="1800" dirty="0">
-                <a:solidFill>
-                  <a:srgbClr val="F4F8FB"/>
-                </a:solidFill>
-                <a:latin typeface="Aptos" pitchFamily="34" charset="0"/>
-                <a:ea typeface="Aptos" pitchFamily="34" charset="-122"/>
-                <a:cs typeface="Aptos" pitchFamily="34" charset="-120"/>
-              </a:rPr>
-              <a:t>$3.62M revenue ($2.36M ARR, 65% recurring). 7 FTE. 28 Ratatosk, 16 Ragnarok, 13 Yggdrasil tenants, Audit Authority attach begins. $1.43M net.</a:t>
-            </a:r>
-            <a:endParaRPr lang="en-US" sz="1800" dirty="0"/>
-          </a:p>
-        </p:txBody>
-      </p:sp>
-      <p:sp>
-        <p:nvSpPr>
-          <p:cNvPr id="18" name="Shape 16"/>
-          <p:cNvSpPr/>
-          <p:nvPr/>
-        </p:nvSpPr>
-        <p:spPr>
-          <a:xfrm>
-            <a:off x="822960" y="3611880"/>
-            <a:ext cx="10607040" cy="512064"/>
-          </a:xfrm>
-          <a:prstGeom prst="roundRect">
-            <a:avLst>
-              <a:gd name="adj" fmla="val 14286"/>
-            </a:avLst>
-          </a:prstGeom>
-          <a:solidFill>
-            <a:srgbClr val="06111C">
-              <a:alpha val="93000"/>
-            </a:srgbClr>
-          </a:solidFill>
-          <a:ln w="12700">
+          <p:cNvPr id="107" name="YLabel15"/>
+          <p:cNvSpPr/>
+          <p:nvPr/>
+        </p:nvSpPr>
+        <p:spPr>
+          <a:xfrm>
+            <a:off x="594360" y="2498598"/>
+            <a:ext cx="685800" cy="237744"/>
+          </a:xfrm>
+          <a:prstGeom prst="rect">
+            <a:avLst/>
+          </a:prstGeom>
+          <a:noFill/>
+          <a:ln/>
+        </p:spPr>
+        <p:txBody>
+          <a:bodyPr wrap="square" lIns="36576" tIns="36576" rIns="36576" bIns="36576" rtlCol="0" anchor="ctr">
+            <a:normAutofit/>
+          </a:bodyPr>
+          <a:lstStyle/>
+          <a:p>
+            <a:pPr algn="r" indent="0" marL="0">
+              <a:buNone/>
+            </a:pPr>
+            <a:r>
+              <a:rPr lang="en-US" sz="1100" dirty="0">
+                <a:solidFill>
+                  <a:srgbClr val="6F889D"/>
+                </a:solidFill>
+                <a:latin typeface="Aptos" pitchFamily="34" charset="0"/>
+              </a:rPr>
+              <a:t>$15M</a:t>
+            </a:r>
+          </a:p>
+        </p:txBody>
+      </p:sp>
+      <p:sp>
+        <p:nvSpPr>
+          <p:cNvPr id="108" name="YLabel0"/>
+          <p:cNvSpPr/>
+          <p:nvPr/>
+        </p:nvSpPr>
+        <p:spPr>
+          <a:xfrm>
+            <a:off x="594360" y="4727448"/>
+            <a:ext cx="685800" cy="237744"/>
+          </a:xfrm>
+          <a:prstGeom prst="rect">
+            <a:avLst/>
+          </a:prstGeom>
+          <a:noFill/>
+          <a:ln/>
+        </p:spPr>
+        <p:txBody>
+          <a:bodyPr wrap="square" lIns="36576" tIns="36576" rIns="36576" bIns="36576" rtlCol="0" anchor="ctr">
+            <a:normAutofit/>
+          </a:bodyPr>
+          <a:lstStyle/>
+          <a:p>
+            <a:pPr algn="r" indent="0" marL="0">
+              <a:buNone/>
+            </a:pPr>
+            <a:r>
+              <a:rPr lang="en-US" sz="1100" dirty="0">
+                <a:solidFill>
+                  <a:srgbClr val="6F889D"/>
+                </a:solidFill>
+                <a:latin typeface="Aptos" pitchFamily="34" charset="0"/>
+              </a:rPr>
+              <a:t>$0</a:t>
+            </a:r>
+          </a:p>
+        </p:txBody>
+      </p:sp>
+      <p:sp>
+        <p:nvSpPr>
+          <p:cNvPr id="109" name="RevSeg1"/>
+          <p:cNvSpPr/>
+          <p:nvPr/>
+        </p:nvSpPr>
+        <p:spPr>
+          <a:xfrm flipV="1">
+            <a:off x="1371600" y="4676927"/>
+            <a:ext cx="2514600" cy="133582"/>
+          </a:xfrm>
+          <a:prstGeom prst="line">
+            <a:avLst/>
+          </a:prstGeom>
+          <a:ln w="38100">
             <a:solidFill>
-              <a:srgbClr val="244A65"/>
+              <a:srgbClr val="2DE2D1"/>
             </a:solidFill>
             <a:prstDash val="solid"/>
           </a:ln>
@@ -4028,110 +4073,21 @@
       </p:sp>
       <p:sp>
         <p:nvSpPr>
-          <p:cNvPr id="19" name="Text 17"/>
-          <p:cNvSpPr/>
-          <p:nvPr/>
-        </p:nvSpPr>
-        <p:spPr>
-          <a:xfrm>
-            <a:off x="1051560" y="3758184"/>
-            <a:ext cx="1097280" cy="164592"/>
-          </a:xfrm>
-          <a:prstGeom prst="rect">
-            <a:avLst/>
-          </a:prstGeom>
-          <a:noFill/>
-          <a:ln/>
-        </p:spPr>
-        <p:txBody>
-          <a:bodyPr wrap="square" lIns="254" tIns="254" rIns="254" bIns="254" rtlCol="0" anchor="t">
-            <a:normAutofit/>
-          </a:bodyPr>
-          <a:lstStyle/>
-          <a:p>
-            <a:pPr algn="l" indent="0" marL="0">
-              <a:buNone/>
-            </a:pPr>
-            <a:r>
-              <a:rPr lang="en-US" sz="1800" b="1" dirty="0">
-                <a:solidFill>
-                  <a:srgbClr val="F6C65B"/>
-                </a:solidFill>
-                <a:latin typeface="Aptos" pitchFamily="34" charset="0"/>
-                <a:ea typeface="Aptos" pitchFamily="34" charset="-122"/>
-                <a:cs typeface="Aptos" pitchFamily="34" charset="-120"/>
-              </a:rPr>
-              <a:t>Year 4 — Scale</a:t>
-            </a:r>
-            <a:endParaRPr lang="en-US" sz="1800" dirty="0"/>
-          </a:p>
-        </p:txBody>
-      </p:sp>
-      <p:sp>
-        <p:nvSpPr>
-          <p:cNvPr id="20" name="Text 18"/>
-          <p:cNvSpPr/>
-          <p:nvPr/>
-        </p:nvSpPr>
-        <p:spPr>
-          <a:xfrm>
-            <a:off x="2286000" y="3749040"/>
-            <a:ext cx="8686800" cy="182880"/>
-          </a:xfrm>
-          <a:prstGeom prst="rect">
-            <a:avLst/>
-          </a:prstGeom>
-          <a:noFill/>
-          <a:ln/>
-        </p:spPr>
-        <p:txBody>
-          <a:bodyPr wrap="square" lIns="254" tIns="254" rIns="254" bIns="254" rtlCol="0" anchor="t">
-            <a:normAutofit/>
-          </a:bodyPr>
-          <a:lstStyle/>
-          <a:p>
-            <a:pPr algn="l" indent="0" marL="0">
-              <a:buNone/>
-            </a:pPr>
-            <a:r>
-              <a:rPr lang="en-US" sz="1800" dirty="0">
-                <a:solidFill>
-                  <a:srgbClr val="F4F8FB"/>
-                </a:solidFill>
-                <a:latin typeface="Aptos" pitchFamily="34" charset="0"/>
-                <a:ea typeface="Aptos" pitchFamily="34" charset="-122"/>
-                <a:cs typeface="Aptos" pitchFamily="34" charset="-120"/>
-              </a:rPr>
-              <a:t>$8.67M revenue ($6.18M ARR, 71% recurring). 14 FTE. Yggdrasil pilots ramp to 25, Bifrost to 31 subscribers, Norn at $2.6M. $4.76M net.</a:t>
-            </a:r>
-            <a:endParaRPr lang="en-US" sz="1800" dirty="0"/>
-          </a:p>
-        </p:txBody>
-      </p:sp>
-      <p:sp>
-        <p:nvSpPr>
-          <p:cNvPr id="21" name="Shape 19"/>
-          <p:cNvSpPr/>
-          <p:nvPr/>
-        </p:nvSpPr>
-        <p:spPr>
-          <a:xfrm>
-            <a:off x="822960" y="4343400"/>
-            <a:ext cx="10607040" cy="512064"/>
-          </a:xfrm>
-          <a:prstGeom prst="roundRect">
-            <a:avLst>
-              <a:gd name="adj" fmla="val 14286"/>
-            </a:avLst>
-          </a:prstGeom>
-          <a:solidFill>
-            <a:srgbClr val="06111C">
-              <a:alpha val="93000"/>
-            </a:srgbClr>
-          </a:solidFill>
-          <a:ln w="12700">
+          <p:cNvPr id="110" name="RevSeg2"/>
+          <p:cNvSpPr/>
+          <p:nvPr/>
+        </p:nvSpPr>
+        <p:spPr>
+          <a:xfrm flipV="1">
+            <a:off x="3886200" y="4308424"/>
+            <a:ext cx="2514600" cy="368503"/>
+          </a:xfrm>
+          <a:prstGeom prst="line">
+            <a:avLst/>
+          </a:prstGeom>
+          <a:ln w="38100">
             <a:solidFill>
-              <a:srgbClr val="244A65"/>
+              <a:srgbClr val="2DE2D1"/>
             </a:solidFill>
             <a:prstDash val="solid"/>
           </a:ln>
@@ -4139,23 +4095,567 @@
       </p:sp>
       <p:sp>
         <p:nvSpPr>
-          <p:cNvPr id="22" name="Text 20"/>
-          <p:cNvSpPr/>
-          <p:nvPr/>
-        </p:nvSpPr>
-        <p:spPr>
-          <a:xfrm>
-            <a:off x="1051560" y="4489704"/>
-            <a:ext cx="1097280" cy="164592"/>
-          </a:xfrm>
-          <a:prstGeom prst="rect">
-            <a:avLst/>
-          </a:prstGeom>
-          <a:noFill/>
-          <a:ln/>
-        </p:spPr>
-        <p:txBody>
-          <a:bodyPr wrap="square" lIns="254" tIns="254" rIns="254" bIns="254" rtlCol="0" anchor="t">
+          <p:cNvPr id="111" name="RevSeg3"/>
+          <p:cNvSpPr/>
+          <p:nvPr/>
+        </p:nvSpPr>
+        <p:spPr>
+          <a:xfrm flipV="1">
+            <a:off x="6400800" y="3558045"/>
+            <a:ext cx="2514600" cy="750380"/>
+          </a:xfrm>
+          <a:prstGeom prst="line">
+            <a:avLst/>
+          </a:prstGeom>
+          <a:ln w="38100">
+            <a:solidFill>
+              <a:srgbClr val="2DE2D1"/>
+            </a:solidFill>
+            <a:prstDash val="solid"/>
+          </a:ln>
+        </p:spPr>
+      </p:sp>
+      <p:sp>
+        <p:nvSpPr>
+          <p:cNvPr id="112" name="RevSeg4"/>
+          <p:cNvSpPr/>
+          <p:nvPr/>
+        </p:nvSpPr>
+        <p:spPr>
+          <a:xfrm flipV="1">
+            <a:off x="8915400" y="2231136"/>
+            <a:ext cx="2514600" cy="1326909"/>
+          </a:xfrm>
+          <a:prstGeom prst="line">
+            <a:avLst/>
+          </a:prstGeom>
+          <a:ln w="38100">
+            <a:solidFill>
+              <a:srgbClr val="2DE2D1"/>
+            </a:solidFill>
+            <a:prstDash val="solid"/>
+          </a:ln>
+        </p:spPr>
+      </p:sp>
+      <p:sp>
+        <p:nvSpPr>
+          <p:cNvPr id="113" name="Marker1"/>
+          <p:cNvSpPr/>
+          <p:nvPr/>
+        </p:nvSpPr>
+        <p:spPr>
+          <a:xfrm>
+            <a:off x="1252728" y="4691638"/>
+            <a:ext cx="237744" cy="237744"/>
+          </a:xfrm>
+          <a:prstGeom prst="ellipse">
+            <a:avLst/>
+          </a:prstGeom>
+          <a:solidFill>
+            <a:srgbClr val="2DE2D1"/>
+          </a:solidFill>
+          <a:ln w="6350">
+            <a:solidFill>
+              <a:srgbClr val="08131F"/>
+            </a:solidFill>
+          </a:ln>
+        </p:spPr>
+      </p:sp>
+      <p:sp>
+        <p:nvSpPr>
+          <p:cNvPr id="114" name="Marker2"/>
+          <p:cNvSpPr/>
+          <p:nvPr/>
+        </p:nvSpPr>
+        <p:spPr>
+          <a:xfrm>
+            <a:off x="3767328" y="4558055"/>
+            <a:ext cx="237744" cy="237744"/>
+          </a:xfrm>
+          <a:prstGeom prst="ellipse">
+            <a:avLst/>
+          </a:prstGeom>
+          <a:solidFill>
+            <a:srgbClr val="2DE2D1"/>
+          </a:solidFill>
+          <a:ln w="6350">
+            <a:solidFill>
+              <a:srgbClr val="08131F"/>
+            </a:solidFill>
+          </a:ln>
+        </p:spPr>
+      </p:sp>
+      <p:sp>
+        <p:nvSpPr>
+          <p:cNvPr id="115" name="Marker3"/>
+          <p:cNvSpPr/>
+          <p:nvPr/>
+        </p:nvSpPr>
+        <p:spPr>
+          <a:xfrm>
+            <a:off x="6281928" y="4189552"/>
+            <a:ext cx="237744" cy="237744"/>
+          </a:xfrm>
+          <a:prstGeom prst="ellipse">
+            <a:avLst/>
+          </a:prstGeom>
+          <a:solidFill>
+            <a:srgbClr val="2DE2D1"/>
+          </a:solidFill>
+          <a:ln w="6350">
+            <a:solidFill>
+              <a:srgbClr val="08131F"/>
+            </a:solidFill>
+          </a:ln>
+        </p:spPr>
+      </p:sp>
+      <p:sp>
+        <p:nvSpPr>
+          <p:cNvPr id="116" name="Marker4"/>
+          <p:cNvSpPr/>
+          <p:nvPr/>
+        </p:nvSpPr>
+        <p:spPr>
+          <a:xfrm>
+            <a:off x="8796528" y="3439173"/>
+            <a:ext cx="237744" cy="237744"/>
+          </a:xfrm>
+          <a:prstGeom prst="ellipse">
+            <a:avLst/>
+          </a:prstGeom>
+          <a:solidFill>
+            <a:srgbClr val="2DE2D1"/>
+          </a:solidFill>
+          <a:ln w="6350">
+            <a:solidFill>
+              <a:srgbClr val="08131F"/>
+            </a:solidFill>
+          </a:ln>
+        </p:spPr>
+      </p:sp>
+      <p:sp>
+        <p:nvSpPr>
+          <p:cNvPr id="117" name="Marker5"/>
+          <p:cNvSpPr/>
+          <p:nvPr/>
+        </p:nvSpPr>
+        <p:spPr>
+          <a:xfrm>
+            <a:off x="11311128" y="2112264"/>
+            <a:ext cx="237744" cy="237744"/>
+          </a:xfrm>
+          <a:prstGeom prst="ellipse">
+            <a:avLst/>
+          </a:prstGeom>
+          <a:solidFill>
+            <a:srgbClr val="2DE2D1"/>
+          </a:solidFill>
+          <a:ln w="6350">
+            <a:solidFill>
+              <a:srgbClr val="08131F"/>
+            </a:solidFill>
+          </a:ln>
+        </p:spPr>
+      </p:sp>
+      <p:sp>
+        <p:nvSpPr>
+          <p:cNvPr id="118" name="Val1"/>
+          <p:cNvSpPr/>
+          <p:nvPr/>
+        </p:nvSpPr>
+        <p:spPr>
+          <a:xfrm>
+            <a:off x="731520" y="4399030"/>
+            <a:ext cx="1280160" cy="274320"/>
+          </a:xfrm>
+          <a:prstGeom prst="rect">
+            <a:avLst/>
+          </a:prstGeom>
+          <a:noFill/>
+          <a:ln/>
+        </p:spPr>
+        <p:txBody>
+          <a:bodyPr wrap="square" lIns="36576" tIns="36576" rIns="36576" bIns="36576" rtlCol="0" anchor="ctr">
+            <a:normAutofit/>
+          </a:bodyPr>
+          <a:lstStyle/>
+          <a:p>
+            <a:pPr algn="ctr" indent="0" marL="0">
+              <a:buNone/>
+            </a:pPr>
+            <a:r>
+              <a:rPr lang="en-US" sz="1800" b="1" dirty="0">
+                <a:solidFill>
+                  <a:srgbClr val="2DE2D1"/>
+                </a:solidFill>
+                <a:latin typeface="Aptos" pitchFamily="34" charset="0"/>
+              </a:rPr>
+              <a:t>$241K</a:t>
+            </a:r>
+          </a:p>
+        </p:txBody>
+      </p:sp>
+      <p:sp>
+        <p:nvSpPr>
+          <p:cNvPr id="119" name="Val2"/>
+          <p:cNvSpPr/>
+          <p:nvPr/>
+        </p:nvSpPr>
+        <p:spPr>
+          <a:xfrm>
+            <a:off x="3246120" y="4265447"/>
+            <a:ext cx="1280160" cy="274320"/>
+          </a:xfrm>
+          <a:prstGeom prst="rect">
+            <a:avLst/>
+          </a:prstGeom>
+          <a:noFill/>
+          <a:ln/>
+        </p:spPr>
+        <p:txBody>
+          <a:bodyPr wrap="square" lIns="36576" tIns="36576" rIns="36576" bIns="36576" rtlCol="0" anchor="ctr">
+            <a:normAutofit/>
+          </a:bodyPr>
+          <a:lstStyle/>
+          <a:p>
+            <a:pPr algn="ctr" indent="0" marL="0">
+              <a:buNone/>
+            </a:pPr>
+            <a:r>
+              <a:rPr lang="en-US" sz="1800" b="1" dirty="0">
+                <a:solidFill>
+                  <a:srgbClr val="2DE2D1"/>
+                </a:solidFill>
+                <a:latin typeface="Aptos" pitchFamily="34" charset="0"/>
+              </a:rPr>
+              <a:t>$1.14M</a:t>
+            </a:r>
+          </a:p>
+        </p:txBody>
+      </p:sp>
+      <p:sp>
+        <p:nvSpPr>
+          <p:cNvPr id="120" name="Val3"/>
+          <p:cNvSpPr/>
+          <p:nvPr/>
+        </p:nvSpPr>
+        <p:spPr>
+          <a:xfrm>
+            <a:off x="5760720" y="3896944"/>
+            <a:ext cx="1280160" cy="274320"/>
+          </a:xfrm>
+          <a:prstGeom prst="rect">
+            <a:avLst/>
+          </a:prstGeom>
+          <a:noFill/>
+          <a:ln/>
+        </p:spPr>
+        <p:txBody>
+          <a:bodyPr wrap="square" lIns="36576" tIns="36576" rIns="36576" bIns="36576" rtlCol="0" anchor="ctr">
+            <a:normAutofit/>
+          </a:bodyPr>
+          <a:lstStyle/>
+          <a:p>
+            <a:pPr algn="ctr" indent="0" marL="0">
+              <a:buNone/>
+            </a:pPr>
+            <a:r>
+              <a:rPr lang="en-US" sz="1800" b="1" dirty="0">
+                <a:solidFill>
+                  <a:srgbClr val="2DE2D1"/>
+                </a:solidFill>
+                <a:latin typeface="Aptos" pitchFamily="34" charset="0"/>
+              </a:rPr>
+              <a:t>$3.62M</a:t>
+            </a:r>
+          </a:p>
+        </p:txBody>
+      </p:sp>
+      <p:sp>
+        <p:nvSpPr>
+          <p:cNvPr id="121" name="Val4"/>
+          <p:cNvSpPr/>
+          <p:nvPr/>
+        </p:nvSpPr>
+        <p:spPr>
+          <a:xfrm>
+            <a:off x="8275320" y="3146565"/>
+            <a:ext cx="1280160" cy="274320"/>
+          </a:xfrm>
+          <a:prstGeom prst="rect">
+            <a:avLst/>
+          </a:prstGeom>
+          <a:noFill/>
+          <a:ln/>
+        </p:spPr>
+        <p:txBody>
+          <a:bodyPr wrap="square" lIns="36576" tIns="36576" rIns="36576" bIns="36576" rtlCol="0" anchor="ctr">
+            <a:normAutofit/>
+          </a:bodyPr>
+          <a:lstStyle/>
+          <a:p>
+            <a:pPr algn="ctr" indent="0" marL="0">
+              <a:buNone/>
+            </a:pPr>
+            <a:r>
+              <a:rPr lang="en-US" sz="1800" b="1" dirty="0">
+                <a:solidFill>
+                  <a:srgbClr val="2DE2D1"/>
+                </a:solidFill>
+                <a:latin typeface="Aptos" pitchFamily="34" charset="0"/>
+              </a:rPr>
+              <a:t>$8.67M</a:t>
+            </a:r>
+          </a:p>
+        </p:txBody>
+      </p:sp>
+      <p:sp>
+        <p:nvSpPr>
+          <p:cNvPr id="122" name="Val5"/>
+          <p:cNvSpPr/>
+          <p:nvPr/>
+        </p:nvSpPr>
+        <p:spPr>
+          <a:xfrm>
+            <a:off x="10789920" y="1819656"/>
+            <a:ext cx="1280160" cy="274320"/>
+          </a:xfrm>
+          <a:prstGeom prst="rect">
+            <a:avLst/>
+          </a:prstGeom>
+          <a:noFill/>
+          <a:ln/>
+        </p:spPr>
+        <p:txBody>
+          <a:bodyPr wrap="square" lIns="36576" tIns="36576" rIns="36576" bIns="36576" rtlCol="0" anchor="ctr">
+            <a:normAutofit/>
+          </a:bodyPr>
+          <a:lstStyle/>
+          <a:p>
+            <a:pPr algn="ctr" indent="0" marL="0">
+              <a:buNone/>
+            </a:pPr>
+            <a:r>
+              <a:rPr lang="en-US" sz="1800" b="1" dirty="0">
+                <a:solidFill>
+                  <a:srgbClr val="2DE2D1"/>
+                </a:solidFill>
+                <a:latin typeface="Aptos" pitchFamily="34" charset="0"/>
+              </a:rPr>
+              <a:t>$17.6M</a:t>
+            </a:r>
+          </a:p>
+        </p:txBody>
+      </p:sp>
+      <p:sp>
+        <p:nvSpPr>
+          <p:cNvPr id="123" name="YearLabel1"/>
+          <p:cNvSpPr/>
+          <p:nvPr/>
+        </p:nvSpPr>
+        <p:spPr>
+          <a:xfrm>
+            <a:off x="731520" y="4937760"/>
+            <a:ext cx="1280160" cy="274320"/>
+          </a:xfrm>
+          <a:prstGeom prst="rect">
+            <a:avLst/>
+          </a:prstGeom>
+          <a:noFill/>
+          <a:ln/>
+        </p:spPr>
+        <p:txBody>
+          <a:bodyPr wrap="square" lIns="36576" tIns="36576" rIns="36576" bIns="36576" rtlCol="0" anchor="ctr">
+            <a:normAutofit/>
+          </a:bodyPr>
+          <a:lstStyle/>
+          <a:p>
+            <a:pPr algn="ctr" indent="0" marL="0">
+              <a:buNone/>
+            </a:pPr>
+            <a:r>
+              <a:rPr lang="en-US" sz="1400" dirty="0">
+                <a:solidFill>
+                  <a:srgbClr val="A9BED0"/>
+                </a:solidFill>
+                <a:latin typeface="Aptos" pitchFamily="34" charset="0"/>
+              </a:rPr>
+              <a:t>Year 1</a:t>
+            </a:r>
+          </a:p>
+        </p:txBody>
+      </p:sp>
+      <p:sp>
+        <p:nvSpPr>
+          <p:cNvPr id="124" name="YearLabel2"/>
+          <p:cNvSpPr/>
+          <p:nvPr/>
+        </p:nvSpPr>
+        <p:spPr>
+          <a:xfrm>
+            <a:off x="3246120" y="4937760"/>
+            <a:ext cx="1280160" cy="274320"/>
+          </a:xfrm>
+          <a:prstGeom prst="rect">
+            <a:avLst/>
+          </a:prstGeom>
+          <a:noFill/>
+          <a:ln/>
+        </p:spPr>
+        <p:txBody>
+          <a:bodyPr wrap="square" lIns="36576" tIns="36576" rIns="36576" bIns="36576" rtlCol="0" anchor="ctr">
+            <a:normAutofit/>
+          </a:bodyPr>
+          <a:lstStyle/>
+          <a:p>
+            <a:pPr algn="ctr" indent="0" marL="0">
+              <a:buNone/>
+            </a:pPr>
+            <a:r>
+              <a:rPr lang="en-US" sz="1400" dirty="0">
+                <a:solidFill>
+                  <a:srgbClr val="A9BED0"/>
+                </a:solidFill>
+                <a:latin typeface="Aptos" pitchFamily="34" charset="0"/>
+              </a:rPr>
+              <a:t>Year 2</a:t>
+            </a:r>
+          </a:p>
+        </p:txBody>
+      </p:sp>
+      <p:sp>
+        <p:nvSpPr>
+          <p:cNvPr id="125" name="YearLabel3"/>
+          <p:cNvSpPr/>
+          <p:nvPr/>
+        </p:nvSpPr>
+        <p:spPr>
+          <a:xfrm>
+            <a:off x="5760720" y="4937760"/>
+            <a:ext cx="1280160" cy="274320"/>
+          </a:xfrm>
+          <a:prstGeom prst="rect">
+            <a:avLst/>
+          </a:prstGeom>
+          <a:noFill/>
+          <a:ln/>
+        </p:spPr>
+        <p:txBody>
+          <a:bodyPr wrap="square" lIns="36576" tIns="36576" rIns="36576" bIns="36576" rtlCol="0" anchor="ctr">
+            <a:normAutofit/>
+          </a:bodyPr>
+          <a:lstStyle/>
+          <a:p>
+            <a:pPr algn="ctr" indent="0" marL="0">
+              <a:buNone/>
+            </a:pPr>
+            <a:r>
+              <a:rPr lang="en-US" sz="1400" dirty="0">
+                <a:solidFill>
+                  <a:srgbClr val="A9BED0"/>
+                </a:solidFill>
+                <a:latin typeface="Aptos" pitchFamily="34" charset="0"/>
+              </a:rPr>
+              <a:t>Year 3</a:t>
+            </a:r>
+          </a:p>
+        </p:txBody>
+      </p:sp>
+      <p:sp>
+        <p:nvSpPr>
+          <p:cNvPr id="126" name="YearLabel4"/>
+          <p:cNvSpPr/>
+          <p:nvPr/>
+        </p:nvSpPr>
+        <p:spPr>
+          <a:xfrm>
+            <a:off x="8275320" y="4937760"/>
+            <a:ext cx="1280160" cy="274320"/>
+          </a:xfrm>
+          <a:prstGeom prst="rect">
+            <a:avLst/>
+          </a:prstGeom>
+          <a:noFill/>
+          <a:ln/>
+        </p:spPr>
+        <p:txBody>
+          <a:bodyPr wrap="square" lIns="36576" tIns="36576" rIns="36576" bIns="36576" rtlCol="0" anchor="ctr">
+            <a:normAutofit/>
+          </a:bodyPr>
+          <a:lstStyle/>
+          <a:p>
+            <a:pPr algn="ctr" indent="0" marL="0">
+              <a:buNone/>
+            </a:pPr>
+            <a:r>
+              <a:rPr lang="en-US" sz="1400" dirty="0">
+                <a:solidFill>
+                  <a:srgbClr val="A9BED0"/>
+                </a:solidFill>
+                <a:latin typeface="Aptos" pitchFamily="34" charset="0"/>
+              </a:rPr>
+              <a:t>Year 4</a:t>
+            </a:r>
+          </a:p>
+        </p:txBody>
+      </p:sp>
+      <p:sp>
+        <p:nvSpPr>
+          <p:cNvPr id="127" name="YearLabel5"/>
+          <p:cNvSpPr/>
+          <p:nvPr/>
+        </p:nvSpPr>
+        <p:spPr>
+          <a:xfrm>
+            <a:off x="10789920" y="4937760"/>
+            <a:ext cx="1280160" cy="274320"/>
+          </a:xfrm>
+          <a:prstGeom prst="rect">
+            <a:avLst/>
+          </a:prstGeom>
+          <a:noFill/>
+          <a:ln/>
+        </p:spPr>
+        <p:txBody>
+          <a:bodyPr wrap="square" lIns="36576" tIns="36576" rIns="36576" bIns="36576" rtlCol="0" anchor="ctr">
+            <a:normAutofit/>
+          </a:bodyPr>
+          <a:lstStyle/>
+          <a:p>
+            <a:pPr algn="ctr" indent="0" marL="0">
+              <a:buNone/>
+            </a:pPr>
+            <a:r>
+              <a:rPr lang="en-US" sz="1400" dirty="0">
+                <a:solidFill>
+                  <a:srgbClr val="A9BED0"/>
+                </a:solidFill>
+                <a:latin typeface="Aptos" pitchFamily="34" charset="0"/>
+              </a:rPr>
+              <a:t>Year 5</a:t>
+            </a:r>
+          </a:p>
+        </p:txBody>
+      </p:sp>
+      <p:sp>
+        <p:nvSpPr>
+          <p:cNvPr id="128" name="ARRLabel"/>
+          <p:cNvSpPr/>
+          <p:nvPr/>
+        </p:nvSpPr>
+        <p:spPr>
+          <a:xfrm>
+            <a:off x="1371600" y="5349240"/>
+            <a:ext cx="1554480" cy="274320"/>
+          </a:xfrm>
+          <a:prstGeom prst="rect">
+            <a:avLst/>
+          </a:prstGeom>
+          <a:noFill/>
+          <a:ln/>
+        </p:spPr>
+        <p:txBody>
+          <a:bodyPr wrap="square" lIns="36576" tIns="36576" rIns="36576" bIns="36576" rtlCol="0" anchor="ctr">
             <a:normAutofit/>
           </a:bodyPr>
           <a:lstStyle/>
@@ -4164,39 +4664,150 @@
               <a:buNone/>
             </a:pPr>
             <a:r>
-              <a:rPr lang="en-US" sz="1800" b="1" dirty="0">
-                <a:solidFill>
-                  <a:srgbClr val="F6C65B"/>
-                </a:solidFill>
-                <a:latin typeface="Aptos" pitchFamily="34" charset="0"/>
-                <a:ea typeface="Aptos" pitchFamily="34" charset="-122"/>
-                <a:cs typeface="Aptos" pitchFamily="34" charset="-120"/>
-              </a:rPr>
-              <a:t>Year 5 — SaaS-dominant</a:t>
-            </a:r>
-            <a:endParaRPr lang="en-US" sz="1800" dirty="0"/>
-          </a:p>
-        </p:txBody>
-      </p:sp>
-      <p:sp>
-        <p:nvSpPr>
-          <p:cNvPr id="23" name="Text 21"/>
-          <p:cNvSpPr/>
-          <p:nvPr/>
-        </p:nvSpPr>
-        <p:spPr>
-          <a:xfrm>
-            <a:off x="2286000" y="4480560"/>
-            <a:ext cx="8686800" cy="182880"/>
-          </a:xfrm>
-          <a:prstGeom prst="rect">
-            <a:avLst/>
-          </a:prstGeom>
-          <a:noFill/>
-          <a:ln/>
-        </p:spPr>
-        <p:txBody>
-          <a:bodyPr wrap="square" lIns="254" tIns="254" rIns="254" bIns="254" rtlCol="0" anchor="t">
+              <a:rPr lang="en-US" sz="1300" b="1" dirty="0">
+                <a:solidFill>
+                  <a:srgbClr val="A9BED0"/>
+                </a:solidFill>
+                <a:latin typeface="Aptos" pitchFamily="34" charset="0"/>
+              </a:rPr>
+              <a:t>ARR (recurring):</a:t>
+            </a:r>
+          </a:p>
+        </p:txBody>
+      </p:sp>
+      <p:sp>
+        <p:nvSpPr>
+          <p:cNvPr id="129" name="ARRVal1"/>
+          <p:cNvSpPr/>
+          <p:nvPr/>
+        </p:nvSpPr>
+        <p:spPr>
+          <a:xfrm>
+            <a:off x="5760720" y="5349240"/>
+            <a:ext cx="1280160" cy="274320"/>
+          </a:xfrm>
+          <a:prstGeom prst="rect">
+            <a:avLst/>
+          </a:prstGeom>
+          <a:noFill/>
+          <a:ln/>
+        </p:spPr>
+        <p:txBody>
+          <a:bodyPr wrap="square" lIns="36576" tIns="36576" rIns="36576" bIns="36576" rtlCol="0" anchor="ctr">
+            <a:normAutofit/>
+          </a:bodyPr>
+          <a:lstStyle/>
+          <a:p>
+            <a:pPr algn="ctr" indent="0" marL="0">
+              <a:buNone/>
+            </a:pPr>
+            <a:r>
+              <a:rPr lang="en-US" sz="1400" dirty="0">
+                <a:solidFill>
+                  <a:srgbClr val="F4F8FB"/>
+                </a:solidFill>
+                <a:latin typeface="Aptos" pitchFamily="34" charset="0"/>
+              </a:rPr>
+              <a:t>$2.4M</a:t>
+            </a:r>
+          </a:p>
+        </p:txBody>
+      </p:sp>
+      <p:sp>
+        <p:nvSpPr>
+          <p:cNvPr id="130" name="ARRVal2"/>
+          <p:cNvSpPr/>
+          <p:nvPr/>
+        </p:nvSpPr>
+        <p:spPr>
+          <a:xfrm>
+            <a:off x="8275320" y="5349240"/>
+            <a:ext cx="1280160" cy="274320"/>
+          </a:xfrm>
+          <a:prstGeom prst="rect">
+            <a:avLst/>
+          </a:prstGeom>
+          <a:noFill/>
+          <a:ln/>
+        </p:spPr>
+        <p:txBody>
+          <a:bodyPr wrap="square" lIns="36576" tIns="36576" rIns="36576" bIns="36576" rtlCol="0" anchor="ctr">
+            <a:normAutofit/>
+          </a:bodyPr>
+          <a:lstStyle/>
+          <a:p>
+            <a:pPr algn="ctr" indent="0" marL="0">
+              <a:buNone/>
+            </a:pPr>
+            <a:r>
+              <a:rPr lang="en-US" sz="1400" dirty="0">
+                <a:solidFill>
+                  <a:srgbClr val="F4F8FB"/>
+                </a:solidFill>
+                <a:latin typeface="Aptos" pitchFamily="34" charset="0"/>
+              </a:rPr>
+              <a:t>$6.2M</a:t>
+            </a:r>
+          </a:p>
+        </p:txBody>
+      </p:sp>
+      <p:sp>
+        <p:nvSpPr>
+          <p:cNvPr id="131" name="ARRVal3"/>
+          <p:cNvSpPr/>
+          <p:nvPr/>
+        </p:nvSpPr>
+        <p:spPr>
+          <a:xfrm>
+            <a:off x="10789920" y="5349240"/>
+            <a:ext cx="1280160" cy="274320"/>
+          </a:xfrm>
+          <a:prstGeom prst="rect">
+            <a:avLst/>
+          </a:prstGeom>
+          <a:noFill/>
+          <a:ln/>
+        </p:spPr>
+        <p:txBody>
+          <a:bodyPr wrap="square" lIns="36576" tIns="36576" rIns="36576" bIns="36576" rtlCol="0" anchor="ctr">
+            <a:normAutofit/>
+          </a:bodyPr>
+          <a:lstStyle/>
+          <a:p>
+            <a:pPr algn="ctr" indent="0" marL="0">
+              <a:buNone/>
+            </a:pPr>
+            <a:r>
+              <a:rPr lang="en-US" sz="1400" dirty="0">
+                <a:solidFill>
+                  <a:srgbClr val="F4F8FB"/>
+                </a:solidFill>
+                <a:latin typeface="Aptos" pitchFamily="34" charset="0"/>
+              </a:rPr>
+              <a:t>$13.4M</a:t>
+            </a:r>
+          </a:p>
+        </p:txBody>
+      </p:sp>
+      <p:sp>
+        <p:nvSpPr>
+          <p:cNvPr id="132" name="ChartTitle"/>
+          <p:cNvSpPr/>
+          <p:nvPr/>
+        </p:nvSpPr>
+        <p:spPr>
+          <a:xfrm>
+            <a:off x="1371600" y="1417320"/>
+            <a:ext cx="10058400" cy="365760"/>
+          </a:xfrm>
+          <a:prstGeom prst="rect">
+            <a:avLst/>
+          </a:prstGeom>
+          <a:noFill/>
+          <a:ln/>
+        </p:spPr>
+        <p:txBody>
+          <a:bodyPr wrap="square" lIns="36576" tIns="36576" rIns="36576" bIns="36576" rtlCol="0" anchor="ctr">
             <a:normAutofit/>
           </a:bodyPr>
           <a:lstStyle/>
@@ -4205,140 +4816,14 @@
               <a:buNone/>
             </a:pPr>
             <a:r>
-              <a:rPr lang="en-US" sz="1800" dirty="0">
+              <a:rPr lang="en-US" sz="1600" dirty="0">
                 <a:solidFill>
                   <a:srgbClr val="F4F8FB"/>
                 </a:solidFill>
                 <a:latin typeface="Aptos" pitchFamily="34" charset="0"/>
-                <a:ea typeface="Aptos" pitchFamily="34" charset="-122"/>
-                <a:cs typeface="Aptos" pitchFamily="34" charset="-120"/>
-              </a:rPr>
-              <a:t>$17.6M revenue ($13.4M ARR, 76% recurring). 22 FTE. 53 Yggdrasil tenants, 2,000 Norn paid accounts, $700K revenue/employee. $11.4M net.</a:t>
-            </a:r>
-            <a:endParaRPr lang="en-US" sz="1800" dirty="0"/>
-          </a:p>
-        </p:txBody>
-      </p:sp>
-      <p:sp>
-        <p:nvSpPr>
-          <p:cNvPr id="24" name="Text 22"/>
-          <p:cNvSpPr/>
-          <p:nvPr/>
-        </p:nvSpPr>
-        <p:spPr>
-          <a:xfrm>
-            <a:off x="914400" y="5715000"/>
-            <a:ext cx="10241280" cy="393192"/>
-          </a:xfrm>
-          <a:prstGeom prst="rect">
-            <a:avLst/>
-          </a:prstGeom>
-          <a:noFill/>
-          <a:ln/>
-        </p:spPr>
-        <p:txBody>
-          <a:bodyPr wrap="square" lIns="254" tIns="254" rIns="254" bIns="254" rtlCol="0" anchor="t">
-            <a:normAutofit/>
-          </a:bodyPr>
-          <a:lstStyle/>
-          <a:p>
-            <a:pPr algn="ctr" indent="0" marL="0">
-              <a:buNone/>
-            </a:pPr>
-            <a:r>
-              <a:rPr lang="en-US" sz="1800" b="1" dirty="0">
-                <a:solidFill>
-                  <a:srgbClr val="F4F8FB"/>
-                </a:solidFill>
-                <a:latin typeface="Aptos" pitchFamily="34" charset="0"/>
-                <a:ea typeface="Aptos" pitchFamily="34" charset="-122"/>
-                <a:cs typeface="Aptos" pitchFamily="34" charset="-120"/>
-              </a:rPr>
-              <a:t>Implied Year-5 valuation: $50–90M on 5–8x ARR multiple. Series A target: Q4 2027 at $500K ARR + 3 Yggdrasil tenants.</a:t>
-            </a:r>
-            <a:endParaRPr lang="en-US" sz="1800" dirty="0"/>
-          </a:p>
-        </p:txBody>
-      </p:sp>
-      <p:sp>
-        <p:nvSpPr>
-          <p:cNvPr id="25" name="Text 23"/>
-          <p:cNvSpPr/>
-          <p:nvPr/>
-        </p:nvSpPr>
-        <p:spPr>
-          <a:xfrm>
-            <a:off x="594360" y="6473952"/>
-            <a:ext cx="2926080" cy="201168"/>
-          </a:xfrm>
-          <a:prstGeom prst="rect">
-            <a:avLst/>
-          </a:prstGeom>
-          <a:noFill/>
-          <a:ln/>
-        </p:spPr>
-        <p:txBody>
-          <a:bodyPr wrap="square" lIns="254" tIns="254" rIns="254" bIns="254" rtlCol="0" anchor="t">
-            <a:normAutofit/>
-          </a:bodyPr>
-          <a:lstStyle/>
-          <a:p>
-            <a:pPr algn="l" indent="0" marL="0">
-              <a:buNone/>
-            </a:pPr>
-            <a:r>
-              <a:rPr lang="en-US" sz="850" dirty="0">
-                <a:solidFill>
-                  <a:srgbClr val="6F889D"/>
-                </a:solidFill>
-                <a:latin typeface="Aptos" pitchFamily="34" charset="0"/>
-                <a:ea typeface="Aptos" pitchFamily="34" charset="-122"/>
-                <a:cs typeface="Aptos" pitchFamily="34" charset="-120"/>
-              </a:rPr>
-              <a:t>Mimir Labs • Investor Deck</a:t>
-            </a:r>
-            <a:endParaRPr lang="en-US" sz="850" dirty="0"/>
-          </a:p>
-        </p:txBody>
-      </p:sp>
-      <p:sp>
-        <p:nvSpPr>
-          <p:cNvPr id="26" name="Text 24"/>
-          <p:cNvSpPr/>
-          <p:nvPr/>
-        </p:nvSpPr>
-        <p:spPr>
-          <a:xfrm>
-            <a:off x="11292840" y="6473952"/>
-            <a:ext cx="411480" cy="201168"/>
-          </a:xfrm>
-          <a:prstGeom prst="rect">
-            <a:avLst/>
-          </a:prstGeom>
-          <a:noFill/>
-          <a:ln/>
-        </p:spPr>
-        <p:txBody>
-          <a:bodyPr wrap="square" lIns="254" tIns="254" rIns="254" bIns="254" rtlCol="0" anchor="t">
-            <a:normAutofit/>
-          </a:bodyPr>
-          <a:lstStyle/>
-          <a:p>
-            <a:pPr algn="r" indent="0" marL="0">
-              <a:buNone/>
-            </a:pPr>
-            <a:r>
-              <a:rPr lang="en-US" sz="850" dirty="0">
-                <a:solidFill>
-                  <a:srgbClr val="6F889D"/>
-                </a:solidFill>
-                <a:latin typeface="Aptos" pitchFamily="34" charset="0"/>
-                <a:ea typeface="Aptos" pitchFamily="34" charset="-122"/>
-                <a:cs typeface="Aptos" pitchFamily="34" charset="-120"/>
-              </a:rPr>
-              <a:t>12</a:t>
-            </a:r>
-            <a:endParaRPr lang="en-US" sz="850" dirty="0"/>
+              </a:rPr>
+              <a:t>Revenue trajectory  -  $241K to $17.6M  -  ~135% CAGR</a:t>
+            </a:r>
           </a:p>
         </p:txBody>
       </p:sp>
@@ -9549,6 +10034,343 @@
                 <a:latin typeface="Aptos" pitchFamily="34" charset="0"/>
               </a:rPr>
               <a:t>SOM — PA + adjacent, 3,500 shops • Target 50–150 by Year 5</a:t>
+            </a:r>
+          </a:p>
+        </p:txBody>
+      </p:sp>
+      <p:sp>
+        <p:nvSpPr>
+          <p:cNvPr id="200" name="Beachhead Label"/>
+          <p:cNvSpPr/>
+          <p:nvPr/>
+        </p:nvSpPr>
+        <p:spPr>
+          <a:xfrm>
+            <a:off x="996696" y="4983480"/>
+            <a:ext cx="2194560" cy="502920"/>
+          </a:xfrm>
+          <a:prstGeom prst="rect">
+            <a:avLst/>
+          </a:prstGeom>
+          <a:noFill/>
+          <a:ln/>
+        </p:spPr>
+        <p:txBody>
+          <a:bodyPr wrap="square" lIns="36576" tIns="36576" rIns="36576" bIns="36576" rtlCol="0" anchor="ctr">
+            <a:normAutofit/>
+          </a:bodyPr>
+          <a:lstStyle/>
+          <a:p>
+            <a:pPr algn="r" indent="0" marL="0">
+              <a:buNone/>
+            </a:pPr>
+            <a:r>
+              <a:rPr lang="en-US" sz="1800" b="1" dirty="0">
+                <a:solidFill>
+                  <a:srgbClr val="A9BED0"/>
+                </a:solidFill>
+                <a:latin typeface="Aptos" pitchFamily="34" charset="0"/>
+              </a:rPr>
+              <a:t>BEACHHEAD  </a:t>
+            </a:r>
+            <a:r>
+              <a:rPr lang="en-US" sz="2000" b="1" dirty="0">
+                <a:solidFill>
+                  <a:srgbClr val="2DE2D1"/>
+                </a:solidFill>
+                <a:latin typeface="Aptos" pitchFamily="34" charset="0"/>
+              </a:rPr>
+              <a:t>→</a:t>
+            </a:r>
+          </a:p>
+        </p:txBody>
+      </p:sp>
+      <p:sp>
+        <p:nvSpPr>
+          <p:cNvPr id="201" name="State_OH"/>
+          <p:cNvSpPr/>
+          <p:nvPr/>
+        </p:nvSpPr>
+        <p:spPr>
+          <a:xfrm>
+            <a:off x="3282696" y="4983480"/>
+            <a:ext cx="1508760" cy="502920"/>
+          </a:xfrm>
+          <a:prstGeom prst="roundRect">
+            <a:avLst>
+              <a:gd name="adj" fmla="val 12000"/>
+            </a:avLst>
+          </a:prstGeom>
+          <a:solidFill>
+            <a:srgbClr val="13344F">
+              <a:alpha val="95000"/>
+            </a:srgbClr>
+          </a:solidFill>
+          <a:ln w="12700">
+            <a:solidFill>
+              <a:srgbClr val="2B5A77"/>
+            </a:solidFill>
+            <a:prstDash val="solid"/>
+          </a:ln>
+        </p:spPr>
+        <p:txBody>
+          <a:bodyPr wrap="square" lIns="36576" tIns="36576" rIns="36576" bIns="36576" rtlCol="0" anchor="ctr">
+            <a:normAutofit/>
+          </a:bodyPr>
+          <a:lstStyle/>
+          <a:p>
+            <a:pPr algn="ctr" indent="0" marL="0">
+              <a:buNone/>
+            </a:pPr>
+            <a:r>
+              <a:rPr lang="en-US" sz="1800" b="1" dirty="0">
+                <a:solidFill>
+                  <a:srgbClr val="2DE2D1"/>
+                </a:solidFill>
+                <a:latin typeface="Aptos" pitchFamily="34" charset="0"/>
+              </a:rPr>
+              <a:t>OH</a:t>
+            </a:r>
+            <a:r>
+              <a:rPr lang="en-US" sz="1300" dirty="0">
+                <a:solidFill>
+                  <a:srgbClr val="F4F8FB"/>
+                </a:solidFill>
+                <a:latin typeface="Aptos" pitchFamily="34" charset="0"/>
+              </a:rPr>
+              <a:t>  ~600</a:t>
+            </a:r>
+          </a:p>
+        </p:txBody>
+      </p:sp>
+      <p:sp>
+        <p:nvSpPr>
+          <p:cNvPr id="202" name="State_PA"/>
+          <p:cNvSpPr/>
+          <p:nvPr/>
+        </p:nvSpPr>
+        <p:spPr>
+          <a:xfrm>
+            <a:off x="4882896" y="4983480"/>
+            <a:ext cx="1508760" cy="502920"/>
+          </a:xfrm>
+          <a:prstGeom prst="roundRect">
+            <a:avLst>
+              <a:gd name="adj" fmla="val 12000"/>
+            </a:avLst>
+          </a:prstGeom>
+          <a:solidFill>
+            <a:srgbClr val="1A4F6E">
+              <a:alpha val="95000"/>
+            </a:srgbClr>
+          </a:solidFill>
+          <a:ln w="12700">
+            <a:solidFill>
+              <a:srgbClr val="2DE2D1"/>
+            </a:solidFill>
+            <a:prstDash val="solid"/>
+          </a:ln>
+        </p:spPr>
+        <p:txBody>
+          <a:bodyPr wrap="square" lIns="36576" tIns="36576" rIns="36576" bIns="36576" rtlCol="0" anchor="ctr">
+            <a:normAutofit/>
+          </a:bodyPr>
+          <a:lstStyle/>
+          <a:p>
+            <a:pPr algn="ctr" indent="0" marL="0">
+              <a:buNone/>
+            </a:pPr>
+            <a:r>
+              <a:rPr lang="en-US" sz="1800" b="1" dirty="0">
+                <a:solidFill>
+                  <a:srgbClr val="2DE2D1"/>
+                </a:solidFill>
+                <a:latin typeface="Aptos" pitchFamily="34" charset="0"/>
+              </a:rPr>
+              <a:t>PA</a:t>
+            </a:r>
+            <a:r>
+              <a:rPr lang="en-US" sz="1300" dirty="0">
+                <a:solidFill>
+                  <a:srgbClr val="F4F8FB"/>
+                </a:solidFill>
+                <a:latin typeface="Aptos" pitchFamily="34" charset="0"/>
+              </a:rPr>
+              <a:t>  ~1,400</a:t>
+            </a:r>
+          </a:p>
+        </p:txBody>
+      </p:sp>
+      <p:sp>
+        <p:nvSpPr>
+          <p:cNvPr id="203" name="State_NY"/>
+          <p:cNvSpPr/>
+          <p:nvPr/>
+        </p:nvSpPr>
+        <p:spPr>
+          <a:xfrm>
+            <a:off x="6483096" y="4983480"/>
+            <a:ext cx="1508760" cy="502920"/>
+          </a:xfrm>
+          <a:prstGeom prst="roundRect">
+            <a:avLst>
+              <a:gd name="adj" fmla="val 12000"/>
+            </a:avLst>
+          </a:prstGeom>
+          <a:solidFill>
+            <a:srgbClr val="13344F">
+              <a:alpha val="95000"/>
+            </a:srgbClr>
+          </a:solidFill>
+          <a:ln w="12700">
+            <a:solidFill>
+              <a:srgbClr val="2B5A77"/>
+            </a:solidFill>
+            <a:prstDash val="solid"/>
+          </a:ln>
+        </p:spPr>
+        <p:txBody>
+          <a:bodyPr wrap="square" lIns="36576" tIns="36576" rIns="36576" bIns="36576" rtlCol="0" anchor="ctr">
+            <a:normAutofit/>
+          </a:bodyPr>
+          <a:lstStyle/>
+          <a:p>
+            <a:pPr algn="ctr" indent="0" marL="0">
+              <a:buNone/>
+            </a:pPr>
+            <a:r>
+              <a:rPr lang="en-US" sz="1800" b="1" dirty="0">
+                <a:solidFill>
+                  <a:srgbClr val="2DE2D1"/>
+                </a:solidFill>
+                <a:latin typeface="Aptos" pitchFamily="34" charset="0"/>
+              </a:rPr>
+              <a:t>NY</a:t>
+            </a:r>
+            <a:r>
+              <a:rPr lang="en-US" sz="1300" dirty="0">
+                <a:solidFill>
+                  <a:srgbClr val="F4F8FB"/>
+                </a:solidFill>
+                <a:latin typeface="Aptos" pitchFamily="34" charset="0"/>
+              </a:rPr>
+              <a:t>  ~500</a:t>
+            </a:r>
+          </a:p>
+        </p:txBody>
+      </p:sp>
+      <p:sp>
+        <p:nvSpPr>
+          <p:cNvPr id="204" name="State_NJ"/>
+          <p:cNvSpPr/>
+          <p:nvPr/>
+        </p:nvSpPr>
+        <p:spPr>
+          <a:xfrm>
+            <a:off x="8083296" y="4983480"/>
+            <a:ext cx="1508760" cy="502920"/>
+          </a:xfrm>
+          <a:prstGeom prst="roundRect">
+            <a:avLst>
+              <a:gd name="adj" fmla="val 12000"/>
+            </a:avLst>
+          </a:prstGeom>
+          <a:solidFill>
+            <a:srgbClr val="13344F">
+              <a:alpha val="95000"/>
+            </a:srgbClr>
+          </a:solidFill>
+          <a:ln w="12700">
+            <a:solidFill>
+              <a:srgbClr val="2B5A77"/>
+            </a:solidFill>
+            <a:prstDash val="solid"/>
+          </a:ln>
+        </p:spPr>
+        <p:txBody>
+          <a:bodyPr wrap="square" lIns="36576" tIns="36576" rIns="36576" bIns="36576" rtlCol="0" anchor="ctr">
+            <a:normAutofit/>
+          </a:bodyPr>
+          <a:lstStyle/>
+          <a:p>
+            <a:pPr algn="ctr" indent="0" marL="0">
+              <a:buNone/>
+            </a:pPr>
+            <a:r>
+              <a:rPr lang="en-US" sz="1800" b="1" dirty="0">
+                <a:solidFill>
+                  <a:srgbClr val="2DE2D1"/>
+                </a:solidFill>
+                <a:latin typeface="Aptos" pitchFamily="34" charset="0"/>
+              </a:rPr>
+              <a:t>NJ</a:t>
+            </a:r>
+            <a:r>
+              <a:rPr lang="en-US" sz="1300" dirty="0">
+                <a:solidFill>
+                  <a:srgbClr val="F4F8FB"/>
+                </a:solidFill>
+                <a:latin typeface="Aptos" pitchFamily="34" charset="0"/>
+              </a:rPr>
+              <a:t>  ~600</a:t>
+            </a:r>
+          </a:p>
+        </p:txBody>
+      </p:sp>
+      <p:sp>
+        <p:nvSpPr>
+          <p:cNvPr id="205" name="State_MD"/>
+          <p:cNvSpPr/>
+          <p:nvPr/>
+        </p:nvSpPr>
+        <p:spPr>
+          <a:xfrm>
+            <a:off x="9683496" y="4983480"/>
+            <a:ext cx="1508760" cy="502920"/>
+          </a:xfrm>
+          <a:prstGeom prst="roundRect">
+            <a:avLst>
+              <a:gd name="adj" fmla="val 12000"/>
+            </a:avLst>
+          </a:prstGeom>
+          <a:solidFill>
+            <a:srgbClr val="13344F">
+              <a:alpha val="95000"/>
+            </a:srgbClr>
+          </a:solidFill>
+          <a:ln w="12700">
+            <a:solidFill>
+              <a:srgbClr val="2B5A77"/>
+            </a:solidFill>
+            <a:prstDash val="solid"/>
+          </a:ln>
+        </p:spPr>
+        <p:txBody>
+          <a:bodyPr wrap="square" lIns="36576" tIns="36576" rIns="36576" bIns="36576" rtlCol="0" anchor="ctr">
+            <a:normAutofit/>
+          </a:bodyPr>
+          <a:lstStyle/>
+          <a:p>
+            <a:pPr algn="ctr" indent="0" marL="0">
+              <a:buNone/>
+            </a:pPr>
+            <a:r>
+              <a:rPr lang="en-US" sz="1800" b="1" dirty="0">
+                <a:solidFill>
+                  <a:srgbClr val="2DE2D1"/>
+                </a:solidFill>
+                <a:latin typeface="Aptos" pitchFamily="34" charset="0"/>
+              </a:rPr>
+              <a:t>MD</a:t>
+            </a:r>
+            <a:r>
+              <a:rPr lang="en-US" sz="1300" dirty="0">
+                <a:solidFill>
+                  <a:srgbClr val="F4F8FB"/>
+                </a:solidFill>
+                <a:latin typeface="Aptos" pitchFamily="34" charset="0"/>
+              </a:rPr>
+              <a:t>  ~400</a:t>
             </a:r>
           </a:p>
         </p:txBody>

</xml_diff>

<commit_message>
Add accumulated strategy, essays, business, legal, and research artifacts
Essays (substrate, glass-machines, bookkeeper's-inheritance, greater-fool,
no-AI-will-fix, mimisbrunnr/builders updates), COPYPASTA log, CEO runbook,
acquirer strategic-fit analysis, SBA 7(a)/E2G application materials, legal
formation + Clarity Driven partnership docs, NVIDIA/IBSP/Mimisbrunnr
research, design-partner program, demo runbook, DNA-of-enterprise-data
whitepaper, investor outreach assets.

Co-Authored-By: Claude Opus 4.7 (1M context) <noreply@anthropic.com>
</commit_message>
<xml_diff>
--- a/business/btfp/mimir_labs_investor_deck_rewrite_clean.pptx
+++ b/business/btfp/mimir_labs_investor_deck_rewrite_clean.pptx
@@ -1827,7 +1827,7 @@
               <a:buNone/>
             </a:pPr>
             <a:r>
-              <a:rPr lang="en-US" sz="1800" dirty="0">
+              <a:rPr lang="en-US" sz="1600" dirty="0">
                 <a:solidFill>
                   <a:srgbClr val="A9BED0"/>
                 </a:solidFill>
@@ -1936,7 +1936,7 @@
               <a:buNone/>
             </a:pPr>
             <a:r>
-              <a:rPr lang="en-US" sz="1800" dirty="0">
+              <a:rPr lang="en-US" sz="1150" dirty="0">
                 <a:solidFill>
                   <a:srgbClr val="A9BED0"/>
                 </a:solidFill>
@@ -2186,7 +2186,7 @@
               <a:buNone/>
             </a:pPr>
             <a:r>
-              <a:rPr lang="en-US" sz="1800" dirty="0">
+              <a:rPr lang="en-US" sz="1250" dirty="0">
                 <a:solidFill>
                   <a:srgbClr val="A9BED0"/>
                 </a:solidFill>
@@ -2256,7 +2256,7 @@
               <a:buNone/>
             </a:pPr>
             <a:r>
-              <a:rPr lang="en-US" sz="1800" b="1" dirty="0">
+              <a:rPr lang="en-US" sz="1180" b="1" dirty="0">
                 <a:solidFill>
                   <a:srgbClr val="F6C65B"/>
                 </a:solidFill>
@@ -2297,7 +2297,7 @@
               <a:buNone/>
             </a:pPr>
             <a:r>
-              <a:rPr lang="en-US" sz="1800" dirty="0">
+              <a:rPr lang="en-US" sz="1220" dirty="0">
                 <a:solidFill>
                   <a:srgbClr val="F4F8FB"/>
                 </a:solidFill>
@@ -2367,7 +2367,7 @@
               <a:buNone/>
             </a:pPr>
             <a:r>
-              <a:rPr lang="en-US" sz="1800" b="1" dirty="0">
+              <a:rPr lang="en-US" sz="1180" b="1" dirty="0">
                 <a:solidFill>
                   <a:srgbClr val="F6C65B"/>
                 </a:solidFill>
@@ -2408,7 +2408,7 @@
               <a:buNone/>
             </a:pPr>
             <a:r>
-              <a:rPr lang="en-US" sz="1800" dirty="0">
+              <a:rPr lang="en-US" sz="1220" dirty="0">
                 <a:solidFill>
                   <a:srgbClr val="F4F8FB"/>
                 </a:solidFill>
@@ -2478,7 +2478,7 @@
               <a:buNone/>
             </a:pPr>
             <a:r>
-              <a:rPr lang="en-US" sz="1800" b="1" dirty="0">
+              <a:rPr lang="en-US" sz="1180" b="1" dirty="0">
                 <a:solidFill>
                   <a:srgbClr val="F6C65B"/>
                 </a:solidFill>
@@ -2519,7 +2519,7 @@
               <a:buNone/>
             </a:pPr>
             <a:r>
-              <a:rPr lang="en-US" sz="1800" dirty="0">
+              <a:rPr lang="en-US" sz="1220" dirty="0">
                 <a:solidFill>
                   <a:srgbClr val="F4F8FB"/>
                 </a:solidFill>
@@ -2589,7 +2589,7 @@
               <a:buNone/>
             </a:pPr>
             <a:r>
-              <a:rPr lang="en-US" sz="1800" b="1" dirty="0">
+              <a:rPr lang="en-US" sz="1180" b="1" dirty="0">
                 <a:solidFill>
                   <a:srgbClr val="F6C65B"/>
                 </a:solidFill>
@@ -2630,7 +2630,7 @@
               <a:buNone/>
             </a:pPr>
             <a:r>
-              <a:rPr lang="en-US" sz="1800" dirty="0">
+              <a:rPr lang="en-US" sz="1220" dirty="0">
                 <a:solidFill>
                   <a:srgbClr val="F4F8FB"/>
                 </a:solidFill>
@@ -2700,7 +2700,7 @@
               <a:buNone/>
             </a:pPr>
             <a:r>
-              <a:rPr lang="en-US" sz="1800" b="1" dirty="0">
+              <a:rPr lang="en-US" sz="1180" b="1" dirty="0">
                 <a:solidFill>
                   <a:srgbClr val="F6C65B"/>
                 </a:solidFill>
@@ -2741,7 +2741,7 @@
               <a:buNone/>
             </a:pPr>
             <a:r>
-              <a:rPr lang="en-US" sz="1800" dirty="0">
+              <a:rPr lang="en-US" sz="1220" dirty="0">
                 <a:solidFill>
                   <a:srgbClr val="F4F8FB"/>
                 </a:solidFill>
@@ -3032,7 +3032,7 @@
               <a:buNone/>
             </a:pPr>
             <a:r>
-              <a:rPr lang="en-US" sz="1800" dirty="0">
+              <a:rPr lang="en-US" sz="1250" dirty="0">
                 <a:solidFill>
                   <a:srgbClr val="A9BED0"/>
                 </a:solidFill>
@@ -3143,7 +3143,7 @@
               <a:buNone/>
             </a:pPr>
             <a:r>
-              <a:rPr lang="en-US" sz="1800" dirty="0">
+              <a:rPr lang="en-US" sz="1400" dirty="0">
                 <a:solidFill>
                   <a:srgbClr val="F4F8FB"/>
                 </a:solidFill>
@@ -3158,7 +3158,7 @@
               <a:buNone/>
             </a:pPr>
             <a:r>
-              <a:rPr lang="en-US" sz="1800" dirty="0">
+              <a:rPr lang="en-US" sz="1400" dirty="0">
                 <a:solidFill>
                   <a:srgbClr val="F4F8FB"/>
                 </a:solidFill>
@@ -3173,7 +3173,7 @@
               <a:buNone/>
             </a:pPr>
             <a:r>
-              <a:rPr lang="en-US" sz="1800" dirty="0">
+              <a:rPr lang="en-US" sz="1400" dirty="0">
                 <a:solidFill>
                   <a:srgbClr val="F4F8FB"/>
                 </a:solidFill>
@@ -3188,7 +3188,7 @@
               <a:buNone/>
             </a:pPr>
             <a:r>
-              <a:rPr lang="en-US" sz="1800" dirty="0">
+              <a:rPr lang="en-US" sz="1400" dirty="0">
                 <a:solidFill>
                   <a:srgbClr val="F4F8FB"/>
                 </a:solidFill>
@@ -3203,7 +3203,7 @@
               <a:buNone/>
             </a:pPr>
             <a:r>
-              <a:rPr lang="en-US" sz="1800" dirty="0">
+              <a:rPr lang="en-US" sz="1400" dirty="0">
                 <a:solidFill>
                   <a:srgbClr val="F4F8FB"/>
                 </a:solidFill>
@@ -3314,7 +3314,7 @@
               <a:buNone/>
             </a:pPr>
             <a:r>
-              <a:rPr lang="en-US" sz="1800" dirty="0">
+              <a:rPr lang="en-US" sz="1400" dirty="0">
                 <a:solidFill>
                   <a:srgbClr val="F4F8FB"/>
                 </a:solidFill>
@@ -3329,7 +3329,7 @@
               <a:buNone/>
             </a:pPr>
             <a:r>
-              <a:rPr lang="en-US" sz="1800" dirty="0">
+              <a:rPr lang="en-US" sz="1400" dirty="0">
                 <a:solidFill>
                   <a:srgbClr val="F4F8FB"/>
                 </a:solidFill>
@@ -3344,7 +3344,7 @@
               <a:buNone/>
             </a:pPr>
             <a:r>
-              <a:rPr lang="en-US" sz="1800" dirty="0">
+              <a:rPr lang="en-US" sz="1400" dirty="0">
                 <a:solidFill>
                   <a:srgbClr val="F4F8FB"/>
                 </a:solidFill>
@@ -3359,7 +3359,7 @@
               <a:buNone/>
             </a:pPr>
             <a:r>
-              <a:rPr lang="en-US" sz="1800" dirty="0">
+              <a:rPr lang="en-US" sz="1400" dirty="0">
                 <a:solidFill>
                   <a:srgbClr val="F4F8FB"/>
                 </a:solidFill>
@@ -3400,7 +3400,7 @@
               <a:buNone/>
             </a:pPr>
             <a:r>
-              <a:rPr lang="en-US" sz="1800" dirty="0">
+              <a:rPr lang="en-US" sz="1550" dirty="0">
                 <a:solidFill>
                   <a:srgbClr val="A9BED0"/>
                 </a:solidFill>
@@ -3650,7 +3650,7 @@
               <a:buNone/>
             </a:pPr>
             <a:r>
-              <a:rPr lang="en-US" sz="1800" dirty="0">
+              <a:rPr lang="en-US" sz="1250" dirty="0">
                 <a:solidFill>
                   <a:srgbClr val="A9BED0"/>
                 </a:solidFill>
@@ -4981,7 +4981,7 @@
               <a:buNone/>
             </a:pPr>
             <a:r>
-              <a:rPr lang="en-US" sz="1800" dirty="0">
+              <a:rPr lang="en-US" sz="1250" dirty="0">
                 <a:solidFill>
                   <a:srgbClr val="A9BED0"/>
                 </a:solidFill>
@@ -5133,7 +5133,7 @@
               <a:buNone/>
             </a:pPr>
             <a:r>
-              <a:rPr lang="en-US" sz="1800" dirty="0">
+              <a:rPr lang="en-US" sz="1220" dirty="0">
                 <a:solidFill>
                   <a:srgbClr val="A9BED0"/>
                 </a:solidFill>
@@ -5244,7 +5244,7 @@
               <a:buNone/>
             </a:pPr>
             <a:r>
-              <a:rPr lang="en-US" sz="1800" dirty="0">
+              <a:rPr lang="en-US" sz="1300" dirty="0">
                 <a:solidFill>
                   <a:srgbClr val="F4F8FB"/>
                 </a:solidFill>
@@ -5259,7 +5259,7 @@
               <a:buNone/>
             </a:pPr>
             <a:r>
-              <a:rPr lang="en-US" sz="1800" dirty="0">
+              <a:rPr lang="en-US" sz="1300" dirty="0">
                 <a:solidFill>
                   <a:srgbClr val="F4F8FB"/>
                 </a:solidFill>
@@ -5274,7 +5274,7 @@
               <a:buNone/>
             </a:pPr>
             <a:r>
-              <a:rPr lang="en-US" sz="1800" dirty="0">
+              <a:rPr lang="en-US" sz="1300" dirty="0">
                 <a:solidFill>
                   <a:srgbClr val="F4F8FB"/>
                 </a:solidFill>
@@ -5289,7 +5289,7 @@
               <a:buNone/>
             </a:pPr>
             <a:r>
-              <a:rPr lang="en-US" sz="1800" dirty="0">
+              <a:rPr lang="en-US" sz="1300" dirty="0">
                 <a:solidFill>
                   <a:srgbClr val="F4F8FB"/>
                 </a:solidFill>
@@ -5400,7 +5400,7 @@
               <a:buNone/>
             </a:pPr>
             <a:r>
-              <a:rPr lang="en-US" sz="1800" dirty="0">
+              <a:rPr lang="en-US" sz="1300" dirty="0">
                 <a:solidFill>
                   <a:srgbClr val="F4F8FB"/>
                 </a:solidFill>
@@ -5415,7 +5415,7 @@
               <a:buNone/>
             </a:pPr>
             <a:r>
-              <a:rPr lang="en-US" sz="1800" dirty="0">
+              <a:rPr lang="en-US" sz="1300" dirty="0">
                 <a:solidFill>
                   <a:srgbClr val="F4F8FB"/>
                 </a:solidFill>
@@ -5430,7 +5430,7 @@
               <a:buNone/>
             </a:pPr>
             <a:r>
-              <a:rPr lang="en-US" sz="1800" dirty="0">
+              <a:rPr lang="en-US" sz="1300" dirty="0">
                 <a:solidFill>
                   <a:srgbClr val="F4F8FB"/>
                 </a:solidFill>
@@ -5445,7 +5445,7 @@
               <a:buNone/>
             </a:pPr>
             <a:r>
-              <a:rPr lang="en-US" sz="1800" dirty="0">
+              <a:rPr lang="en-US" sz="1300" dirty="0">
                 <a:solidFill>
                   <a:srgbClr val="F4F8FB"/>
                 </a:solidFill>
@@ -5486,7 +5486,7 @@
               <a:buNone/>
             </a:pPr>
             <a:r>
-              <a:rPr lang="en-US" sz="1800" b="1" dirty="0">
+              <a:rPr lang="en-US" sz="1730" b="1" dirty="0">
                 <a:solidFill>
                   <a:srgbClr val="F4F8FB"/>
                 </a:solidFill>
@@ -5849,7 +5849,7 @@
               <a:buNone/>
             </a:pPr>
             <a:r>
-              <a:rPr lang="en-US" sz="1800" dirty="0">
+              <a:rPr lang="en-US" sz="1600" dirty="0">
                 <a:solidFill>
                   <a:srgbClr val="A9BED0"/>
                 </a:solidFill>
@@ -5958,7 +5958,7 @@
               <a:buNone/>
             </a:pPr>
             <a:r>
-              <a:rPr lang="en-US" sz="1800" dirty="0">
+              <a:rPr lang="en-US" sz="1150" dirty="0">
                 <a:solidFill>
                   <a:srgbClr val="A9BED0"/>
                 </a:solidFill>
@@ -6208,7 +6208,7 @@
               <a:buNone/>
             </a:pPr>
             <a:r>
-              <a:rPr lang="en-US" sz="1800" dirty="0">
+              <a:rPr lang="en-US" sz="1250" dirty="0">
                 <a:solidFill>
                   <a:srgbClr val="A9BED0"/>
                 </a:solidFill>
@@ -6278,7 +6278,7 @@
               <a:buNone/>
             </a:pPr>
             <a:r>
-              <a:rPr lang="en-US" sz="1800" b="1" dirty="0">
+              <a:rPr lang="en-US" sz="1700" b="1" dirty="0">
                 <a:solidFill>
                   <a:srgbClr val="F4F8FB"/>
                 </a:solidFill>
@@ -6319,7 +6319,7 @@
               <a:buNone/>
             </a:pPr>
             <a:r>
-              <a:rPr lang="en-US" sz="1800" dirty="0">
+              <a:rPr lang="en-US" sz="1350" dirty="0">
                 <a:solidFill>
                   <a:srgbClr val="A9BED0"/>
                 </a:solidFill>
@@ -6334,7 +6334,7 @@
               <a:buNone/>
             </a:pPr>
             <a:r>
-              <a:rPr lang="en-US" sz="1800" dirty="0">
+              <a:rPr lang="en-US" sz="1350" dirty="0">
                 <a:solidFill>
                   <a:srgbClr val="A9BED0"/>
                 </a:solidFill>
@@ -6349,7 +6349,7 @@
               <a:buNone/>
             </a:pPr>
             <a:r>
-              <a:rPr lang="en-US" sz="1800" dirty="0">
+              <a:rPr lang="en-US" sz="1350" dirty="0">
                 <a:solidFill>
                   <a:srgbClr val="A9BED0"/>
                 </a:solidFill>
@@ -6364,7 +6364,7 @@
               <a:buNone/>
             </a:pPr>
             <a:r>
-              <a:rPr lang="en-US" sz="1800" dirty="0">
+              <a:rPr lang="en-US" sz="1350" dirty="0">
                 <a:solidFill>
                   <a:srgbClr val="A9BED0"/>
                 </a:solidFill>
@@ -6434,7 +6434,7 @@
               <a:buNone/>
             </a:pPr>
             <a:r>
-              <a:rPr lang="en-US" sz="1800" b="1" dirty="0">
+              <a:rPr lang="en-US" sz="1700" b="1" dirty="0">
                 <a:solidFill>
                   <a:srgbClr val="F4F8FB"/>
                 </a:solidFill>
@@ -6475,7 +6475,7 @@
               <a:buNone/>
             </a:pPr>
             <a:r>
-              <a:rPr lang="en-US" sz="1800" dirty="0">
+              <a:rPr lang="en-US" sz="1350" dirty="0">
                 <a:solidFill>
                   <a:srgbClr val="A9BED0"/>
                 </a:solidFill>
@@ -6490,7 +6490,7 @@
               <a:buNone/>
             </a:pPr>
             <a:r>
-              <a:rPr lang="en-US" sz="1800" dirty="0">
+              <a:rPr lang="en-US" sz="1350" dirty="0">
                 <a:solidFill>
                   <a:srgbClr val="A9BED0"/>
                 </a:solidFill>
@@ -6505,7 +6505,7 @@
               <a:buNone/>
             </a:pPr>
             <a:r>
-              <a:rPr lang="en-US" sz="1800" dirty="0">
+              <a:rPr lang="en-US" sz="1350" dirty="0">
                 <a:solidFill>
                   <a:srgbClr val="A9BED0"/>
                 </a:solidFill>
@@ -6520,7 +6520,7 @@
               <a:buNone/>
             </a:pPr>
             <a:r>
-              <a:rPr lang="en-US" sz="1800" dirty="0">
+              <a:rPr lang="en-US" sz="1350" dirty="0">
                 <a:solidFill>
                   <a:srgbClr val="A9BED0"/>
                 </a:solidFill>
@@ -6590,7 +6590,7 @@
               <a:buNone/>
             </a:pPr>
             <a:r>
-              <a:rPr lang="en-US" sz="1800" b="1" dirty="0">
+              <a:rPr lang="en-US" sz="1700" b="1" dirty="0">
                 <a:solidFill>
                   <a:srgbClr val="F4F8FB"/>
                 </a:solidFill>
@@ -6631,7 +6631,7 @@
               <a:buNone/>
             </a:pPr>
             <a:r>
-              <a:rPr lang="en-US" sz="1800" dirty="0">
+              <a:rPr lang="en-US" sz="1350" dirty="0">
                 <a:solidFill>
                   <a:srgbClr val="A9BED0"/>
                 </a:solidFill>
@@ -6646,7 +6646,7 @@
               <a:buNone/>
             </a:pPr>
             <a:r>
-              <a:rPr lang="en-US" sz="1800" dirty="0">
+              <a:rPr lang="en-US" sz="1350" dirty="0">
                 <a:solidFill>
                   <a:srgbClr val="A9BED0"/>
                 </a:solidFill>
@@ -6661,7 +6661,7 @@
               <a:buNone/>
             </a:pPr>
             <a:r>
-              <a:rPr lang="en-US" sz="1800" dirty="0">
+              <a:rPr lang="en-US" sz="1350" dirty="0">
                 <a:solidFill>
                   <a:srgbClr val="A9BED0"/>
                 </a:solidFill>
@@ -6676,7 +6676,7 @@
               <a:buNone/>
             </a:pPr>
             <a:r>
-              <a:rPr lang="en-US" sz="1800" dirty="0">
+              <a:rPr lang="en-US" sz="1350" dirty="0">
                 <a:solidFill>
                   <a:srgbClr val="A9BED0"/>
                 </a:solidFill>
@@ -7017,7 +7017,7 @@
               <a:buNone/>
             </a:pPr>
             <a:r>
-              <a:rPr lang="en-US" sz="1800" dirty="0">
+              <a:rPr lang="en-US" sz="1250" dirty="0">
                 <a:solidFill>
                   <a:srgbClr val="A9BED0"/>
                 </a:solidFill>
@@ -7128,7 +7128,7 @@
               <a:buNone/>
             </a:pPr>
             <a:r>
-              <a:rPr lang="en-US" sz="1800" dirty="0">
+              <a:rPr lang="en-US" sz="1300" dirty="0">
                 <a:solidFill>
                   <a:srgbClr val="F4F8FB"/>
                 </a:solidFill>
@@ -7143,7 +7143,7 @@
               <a:buNone/>
             </a:pPr>
             <a:r>
-              <a:rPr lang="en-US" sz="1800" dirty="0">
+              <a:rPr lang="en-US" sz="1300" dirty="0">
                 <a:solidFill>
                   <a:srgbClr val="F4F8FB"/>
                 </a:solidFill>
@@ -7158,7 +7158,7 @@
               <a:buNone/>
             </a:pPr>
             <a:r>
-              <a:rPr lang="en-US" sz="1800" dirty="0">
+              <a:rPr lang="en-US" sz="1300" dirty="0">
                 <a:solidFill>
                   <a:srgbClr val="F4F8FB"/>
                 </a:solidFill>
@@ -7173,7 +7173,7 @@
               <a:buNone/>
             </a:pPr>
             <a:r>
-              <a:rPr lang="en-US" sz="1800" dirty="0">
+              <a:rPr lang="en-US" sz="1300" dirty="0">
                 <a:solidFill>
                   <a:srgbClr val="F4F8FB"/>
                 </a:solidFill>
@@ -7284,7 +7284,7 @@
               <a:buNone/>
             </a:pPr>
             <a:r>
-              <a:rPr lang="en-US" sz="1800" dirty="0">
+              <a:rPr lang="en-US" sz="1300" dirty="0">
                 <a:solidFill>
                   <a:srgbClr val="F4F8FB"/>
                 </a:solidFill>
@@ -7299,7 +7299,7 @@
               <a:buNone/>
             </a:pPr>
             <a:r>
-              <a:rPr lang="en-US" sz="1800" dirty="0">
+              <a:rPr lang="en-US" sz="1300" dirty="0">
                 <a:solidFill>
                   <a:srgbClr val="F4F8FB"/>
                 </a:solidFill>
@@ -7314,7 +7314,7 @@
               <a:buNone/>
             </a:pPr>
             <a:r>
-              <a:rPr lang="en-US" sz="1800" dirty="0">
+              <a:rPr lang="en-US" sz="1300" dirty="0">
                 <a:solidFill>
                   <a:srgbClr val="F4F8FB"/>
                 </a:solidFill>
@@ -7329,7 +7329,7 @@
               <a:buNone/>
             </a:pPr>
             <a:r>
-              <a:rPr lang="en-US" sz="1800" dirty="0">
+              <a:rPr lang="en-US" sz="1300" dirty="0">
                 <a:solidFill>
                   <a:srgbClr val="F4F8FB"/>
                 </a:solidFill>
@@ -7440,7 +7440,7 @@
               <a:buNone/>
             </a:pPr>
             <a:r>
-              <a:rPr lang="en-US" sz="1800" dirty="0">
+              <a:rPr lang="en-US" sz="1300" dirty="0">
                 <a:solidFill>
                   <a:srgbClr val="F4F8FB"/>
                 </a:solidFill>
@@ -7455,7 +7455,7 @@
               <a:buNone/>
             </a:pPr>
             <a:r>
-              <a:rPr lang="en-US" sz="1800" dirty="0">
+              <a:rPr lang="en-US" sz="1300" dirty="0">
                 <a:solidFill>
                   <a:srgbClr val="F4F8FB"/>
                 </a:solidFill>
@@ -7470,7 +7470,7 @@
               <a:buNone/>
             </a:pPr>
             <a:r>
-              <a:rPr lang="en-US" sz="1800" dirty="0">
+              <a:rPr lang="en-US" sz="1300" dirty="0">
                 <a:solidFill>
                   <a:srgbClr val="F4F8FB"/>
                 </a:solidFill>
@@ -7485,7 +7485,7 @@
               <a:buNone/>
             </a:pPr>
             <a:r>
-              <a:rPr lang="en-US" sz="1800" dirty="0">
+              <a:rPr lang="en-US" sz="1300" dirty="0">
                 <a:solidFill>
                   <a:srgbClr val="F4F8FB"/>
                 </a:solidFill>
@@ -7776,7 +7776,7 @@
               <a:buNone/>
             </a:pPr>
             <a:r>
-              <a:rPr lang="en-US" sz="1800" dirty="0">
+              <a:rPr lang="en-US" sz="1250" dirty="0">
                 <a:solidFill>
                   <a:srgbClr val="A9BED0"/>
                 </a:solidFill>
@@ -7846,7 +7846,7 @@
               <a:buNone/>
             </a:pPr>
             <a:r>
-              <a:rPr lang="en-US" sz="1800" b="1" dirty="0">
+              <a:rPr lang="en-US" sz="1300" b="1" dirty="0">
                 <a:solidFill>
                   <a:srgbClr val="F6C65B"/>
                 </a:solidFill>
@@ -7982,7 +7982,7 @@
               <a:buNone/>
             </a:pPr>
             <a:r>
-              <a:rPr lang="en-US" sz="1800" b="1" dirty="0">
+              <a:rPr lang="en-US" sz="1300" b="1" dirty="0">
                 <a:solidFill>
                   <a:srgbClr val="2DE2D1"/>
                 </a:solidFill>
@@ -8118,7 +8118,7 @@
               <a:buNone/>
             </a:pPr>
             <a:r>
-              <a:rPr lang="en-US" sz="1800" b="1" dirty="0">
+              <a:rPr lang="en-US" sz="1300" b="1" dirty="0">
                 <a:solidFill>
                   <a:srgbClr val="2DE2D1"/>
                 </a:solidFill>
@@ -8254,7 +8254,7 @@
               <a:buNone/>
             </a:pPr>
             <a:r>
-              <a:rPr lang="en-US" sz="1800" b="1" dirty="0">
+              <a:rPr lang="en-US" sz="1300" b="1" dirty="0">
                 <a:solidFill>
                   <a:srgbClr val="2DE2D1"/>
                 </a:solidFill>
@@ -8390,7 +8390,7 @@
               <a:buNone/>
             </a:pPr>
             <a:r>
-              <a:rPr lang="en-US" sz="1800" b="1" dirty="0">
+              <a:rPr lang="en-US" sz="1300" b="1" dirty="0">
                 <a:solidFill>
                   <a:srgbClr val="2DE2D1"/>
                 </a:solidFill>
@@ -8526,7 +8526,7 @@
               <a:buNone/>
             </a:pPr>
             <a:r>
-              <a:rPr lang="en-US" sz="1800" b="1" dirty="0">
+              <a:rPr lang="en-US" sz="1300" b="1" dirty="0">
                 <a:solidFill>
                   <a:srgbClr val="2DE2D1"/>
                 </a:solidFill>
@@ -8858,7 +8858,7 @@
               <a:buNone/>
             </a:pPr>
             <a:r>
-              <a:rPr lang="en-US" sz="1800" dirty="0">
+              <a:rPr lang="en-US" sz="1250" dirty="0">
                 <a:solidFill>
                   <a:srgbClr val="A9BED0"/>
                 </a:solidFill>
@@ -8969,7 +8969,7 @@
               <a:buNone/>
             </a:pPr>
             <a:r>
-              <a:rPr lang="en-US" sz="1800" dirty="0">
+              <a:rPr lang="en-US" sz="1400" dirty="0">
                 <a:solidFill>
                   <a:srgbClr val="F4F8FB"/>
                 </a:solidFill>
@@ -8984,7 +8984,7 @@
               <a:buNone/>
             </a:pPr>
             <a:r>
-              <a:rPr lang="en-US" sz="1800" dirty="0">
+              <a:rPr lang="en-US" sz="1400" dirty="0">
                 <a:solidFill>
                   <a:srgbClr val="F4F8FB"/>
                 </a:solidFill>
@@ -8999,7 +8999,7 @@
               <a:buNone/>
             </a:pPr>
             <a:r>
-              <a:rPr lang="en-US" sz="1800" dirty="0">
+              <a:rPr lang="en-US" sz="1400" dirty="0">
                 <a:solidFill>
                   <a:srgbClr val="F4F8FB"/>
                 </a:solidFill>
@@ -9014,7 +9014,7 @@
               <a:buNone/>
             </a:pPr>
             <a:r>
-              <a:rPr lang="en-US" sz="1800" dirty="0">
+              <a:rPr lang="en-US" sz="1400" dirty="0">
                 <a:solidFill>
                   <a:srgbClr val="F4F8FB"/>
                 </a:solidFill>
@@ -9029,7 +9029,7 @@
               <a:buNone/>
             </a:pPr>
             <a:r>
-              <a:rPr lang="en-US" sz="1800" dirty="0">
+              <a:rPr lang="en-US" sz="1400" dirty="0">
                 <a:solidFill>
                   <a:srgbClr val="F4F8FB"/>
                 </a:solidFill>
@@ -9140,7 +9140,7 @@
               <a:buNone/>
             </a:pPr>
             <a:r>
-              <a:rPr lang="en-US" sz="1800" dirty="0">
+              <a:rPr lang="en-US" sz="1400" dirty="0">
                 <a:solidFill>
                   <a:srgbClr val="F4F8FB"/>
                 </a:solidFill>
@@ -9155,7 +9155,7 @@
               <a:buNone/>
             </a:pPr>
             <a:r>
-              <a:rPr lang="en-US" sz="1800" dirty="0">
+              <a:rPr lang="en-US" sz="1400" dirty="0">
                 <a:solidFill>
                   <a:srgbClr val="F4F8FB"/>
                 </a:solidFill>
@@ -9170,7 +9170,7 @@
               <a:buNone/>
             </a:pPr>
             <a:r>
-              <a:rPr lang="en-US" sz="1800" dirty="0">
+              <a:rPr lang="en-US" sz="1400" dirty="0">
                 <a:solidFill>
                   <a:srgbClr val="F4F8FB"/>
                 </a:solidFill>
@@ -9185,7 +9185,7 @@
               <a:buNone/>
             </a:pPr>
             <a:r>
-              <a:rPr lang="en-US" sz="1800" dirty="0">
+              <a:rPr lang="en-US" sz="1400" dirty="0">
                 <a:solidFill>
                   <a:srgbClr val="F4F8FB"/>
                 </a:solidFill>
@@ -9200,7 +9200,7 @@
               <a:buNone/>
             </a:pPr>
             <a:r>
-              <a:rPr lang="en-US" sz="1800" dirty="0">
+              <a:rPr lang="en-US" sz="1400" dirty="0">
                 <a:solidFill>
                   <a:srgbClr val="F4F8FB"/>
                 </a:solidFill>
@@ -9311,7 +9311,7 @@
               <a:buNone/>
             </a:pPr>
             <a:r>
-              <a:rPr lang="en-US" sz="1800" dirty="0">
+              <a:rPr lang="en-US" sz="1400" dirty="0">
                 <a:solidFill>
                   <a:srgbClr val="F4F8FB"/>
                 </a:solidFill>
@@ -9326,7 +9326,7 @@
               <a:buNone/>
             </a:pPr>
             <a:r>
-              <a:rPr lang="en-US" sz="1800" dirty="0">
+              <a:rPr lang="en-US" sz="1400" dirty="0">
                 <a:solidFill>
                   <a:srgbClr val="F4F8FB"/>
                 </a:solidFill>
@@ -9341,7 +9341,7 @@
               <a:buNone/>
             </a:pPr>
             <a:r>
-              <a:rPr lang="en-US" sz="1800" dirty="0">
+              <a:rPr lang="en-US" sz="1400" dirty="0">
                 <a:solidFill>
                   <a:srgbClr val="F4F8FB"/>
                 </a:solidFill>
@@ -9356,7 +9356,7 @@
               <a:buNone/>
             </a:pPr>
             <a:r>
-              <a:rPr lang="en-US" sz="1800" dirty="0">
+              <a:rPr lang="en-US" sz="1400" dirty="0">
                 <a:solidFill>
                   <a:srgbClr val="F4F8FB"/>
                 </a:solidFill>
@@ -9371,7 +9371,7 @@
               <a:buNone/>
             </a:pPr>
             <a:r>
-              <a:rPr lang="en-US" sz="1800" dirty="0">
+              <a:rPr lang="en-US" sz="1400" dirty="0">
                 <a:solidFill>
                   <a:srgbClr val="F4F8FB"/>
                 </a:solidFill>
@@ -9462,7 +9462,7 @@
               <a:buNone/>
             </a:pPr>
             <a:r>
-              <a:rPr lang="en-US" sz="1800" dirty="0">
+              <a:rPr lang="en-US" sz="1520" dirty="0">
                 <a:solidFill>
                   <a:srgbClr val="A9BED0"/>
                 </a:solidFill>
@@ -9712,7 +9712,7 @@
               <a:buNone/>
             </a:pPr>
             <a:r>
-              <a:rPr lang="en-US" sz="1800" dirty="0">
+              <a:rPr lang="en-US" sz="1250" dirty="0">
                 <a:solidFill>
                   <a:srgbClr val="A9BED0"/>
                 </a:solidFill>
@@ -10529,7 +10529,7 @@
               <a:buNone/>
             </a:pPr>
             <a:r>
-              <a:rPr lang="en-US" sz="1800" dirty="0">
+              <a:rPr lang="en-US" sz="1250" dirty="0">
                 <a:solidFill>
                   <a:srgbClr val="A9BED0"/>
                 </a:solidFill>
@@ -10599,7 +10599,7 @@
               <a:buNone/>
             </a:pPr>
             <a:r>
-              <a:rPr lang="en-US" sz="1800" b="1" dirty="0">
+              <a:rPr lang="en-US" sz="1250" b="1" dirty="0">
                 <a:solidFill>
                   <a:srgbClr val="2DE2D1"/>
                 </a:solidFill>
@@ -10640,7 +10640,7 @@
               <a:buNone/>
             </a:pPr>
             <a:r>
-              <a:rPr lang="en-US" sz="1800" dirty="0">
+              <a:rPr lang="en-US" sz="1220" dirty="0">
                 <a:solidFill>
                   <a:srgbClr val="F4F8FB"/>
                 </a:solidFill>
@@ -10681,7 +10681,7 @@
               <a:buNone/>
             </a:pPr>
             <a:r>
-              <a:rPr lang="en-US" sz="1800" dirty="0">
+              <a:rPr lang="en-US" sz="1180" dirty="0">
                 <a:solidFill>
                   <a:srgbClr val="A9BED0"/>
                 </a:solidFill>
@@ -10751,7 +10751,7 @@
               <a:buNone/>
             </a:pPr>
             <a:r>
-              <a:rPr lang="en-US" sz="1800" b="1" dirty="0">
+              <a:rPr lang="en-US" sz="1250" b="1" dirty="0">
                 <a:solidFill>
                   <a:srgbClr val="2DE2D1"/>
                 </a:solidFill>
@@ -10792,7 +10792,7 @@
               <a:buNone/>
             </a:pPr>
             <a:r>
-              <a:rPr lang="en-US" sz="1800" dirty="0">
+              <a:rPr lang="en-US" sz="1220" dirty="0">
                 <a:solidFill>
                   <a:srgbClr val="F4F8FB"/>
                 </a:solidFill>
@@ -10833,7 +10833,7 @@
               <a:buNone/>
             </a:pPr>
             <a:r>
-              <a:rPr lang="en-US" sz="1800" dirty="0">
+              <a:rPr lang="en-US" sz="1180" dirty="0">
                 <a:solidFill>
                   <a:srgbClr val="A9BED0"/>
                 </a:solidFill>
@@ -10903,7 +10903,7 @@
               <a:buNone/>
             </a:pPr>
             <a:r>
-              <a:rPr lang="en-US" sz="1800" b="1" dirty="0">
+              <a:rPr lang="en-US" sz="1250" b="1" dirty="0">
                 <a:solidFill>
                   <a:srgbClr val="2DE2D1"/>
                 </a:solidFill>
@@ -10944,7 +10944,7 @@
               <a:buNone/>
             </a:pPr>
             <a:r>
-              <a:rPr lang="en-US" sz="1800" dirty="0">
+              <a:rPr lang="en-US" sz="1220" dirty="0">
                 <a:solidFill>
                   <a:srgbClr val="F4F8FB"/>
                 </a:solidFill>
@@ -10985,7 +10985,7 @@
               <a:buNone/>
             </a:pPr>
             <a:r>
-              <a:rPr lang="en-US" sz="1800" dirty="0">
+              <a:rPr lang="en-US" sz="1180" dirty="0">
                 <a:solidFill>
                   <a:srgbClr val="A9BED0"/>
                 </a:solidFill>
@@ -11055,7 +11055,7 @@
               <a:buNone/>
             </a:pPr>
             <a:r>
-              <a:rPr lang="en-US" sz="1800" b="1" dirty="0">
+              <a:rPr lang="en-US" sz="1250" b="1" dirty="0">
                 <a:solidFill>
                   <a:srgbClr val="2DE2D1"/>
                 </a:solidFill>
@@ -11096,7 +11096,7 @@
               <a:buNone/>
             </a:pPr>
             <a:r>
-              <a:rPr lang="en-US" sz="1800" dirty="0">
+              <a:rPr lang="en-US" sz="1220" dirty="0">
                 <a:solidFill>
                   <a:srgbClr val="F4F8FB"/>
                 </a:solidFill>
@@ -11137,7 +11137,7 @@
               <a:buNone/>
             </a:pPr>
             <a:r>
-              <a:rPr lang="en-US" sz="1800" dirty="0">
+              <a:rPr lang="en-US" sz="1180" dirty="0">
                 <a:solidFill>
                   <a:srgbClr val="A9BED0"/>
                 </a:solidFill>
@@ -11207,7 +11207,7 @@
               <a:buNone/>
             </a:pPr>
             <a:r>
-              <a:rPr lang="en-US" sz="1800" b="1" dirty="0">
+              <a:rPr lang="en-US" sz="1250" b="1" dirty="0">
                 <a:solidFill>
                   <a:srgbClr val="2DE2D1"/>
                 </a:solidFill>
@@ -11248,7 +11248,7 @@
               <a:buNone/>
             </a:pPr>
             <a:r>
-              <a:rPr lang="en-US" sz="1800" dirty="0">
+              <a:rPr lang="en-US" sz="1220" dirty="0">
                 <a:solidFill>
                   <a:srgbClr val="F4F8FB"/>
                 </a:solidFill>
@@ -11289,7 +11289,7 @@
               <a:buNone/>
             </a:pPr>
             <a:r>
-              <a:rPr lang="en-US" sz="1800" dirty="0">
+              <a:rPr lang="en-US" sz="1180" dirty="0">
                 <a:solidFill>
                   <a:srgbClr val="A9BED0"/>
                 </a:solidFill>
@@ -11330,7 +11330,7 @@
               <a:buNone/>
             </a:pPr>
             <a:r>
-              <a:rPr lang="en-US" sz="1800" b="1" dirty="0">
+              <a:rPr lang="en-US" sz="1700" b="1" dirty="0">
                 <a:solidFill>
                   <a:srgbClr val="F4F8FB"/>
                 </a:solidFill>
@@ -11580,7 +11580,7 @@
               <a:buNone/>
             </a:pPr>
             <a:r>
-              <a:rPr lang="en-US" sz="1800" dirty="0">
+              <a:rPr lang="en-US" sz="1250" dirty="0">
                 <a:solidFill>
                   <a:srgbClr val="A9BED0"/>
                 </a:solidFill>
@@ -11650,7 +11650,7 @@
               <a:buNone/>
             </a:pPr>
             <a:r>
-              <a:rPr lang="en-US" sz="1800" b="1" dirty="0">
+              <a:rPr lang="en-US" sz="1550" b="1" dirty="0">
                 <a:solidFill>
                   <a:srgbClr val="2DE2D1"/>
                 </a:solidFill>
@@ -11691,7 +11691,7 @@
               <a:buNone/>
             </a:pPr>
             <a:r>
-              <a:rPr lang="en-US" sz="1800" dirty="0">
+              <a:rPr lang="en-US" sz="1120" dirty="0">
                 <a:solidFill>
                   <a:srgbClr val="A9BED0"/>
                 </a:solidFill>
@@ -11761,7 +11761,7 @@
               <a:buNone/>
             </a:pPr>
             <a:r>
-              <a:rPr lang="en-US" sz="1800" b="1" dirty="0">
+              <a:rPr lang="en-US" sz="1550" b="1" dirty="0">
                 <a:solidFill>
                   <a:srgbClr val="2DE2D1"/>
                 </a:solidFill>
@@ -11802,7 +11802,7 @@
               <a:buNone/>
             </a:pPr>
             <a:r>
-              <a:rPr lang="en-US" sz="1800" dirty="0">
+              <a:rPr lang="en-US" sz="1120" dirty="0">
                 <a:solidFill>
                   <a:srgbClr val="A9BED0"/>
                 </a:solidFill>
@@ -11872,7 +11872,7 @@
               <a:buNone/>
             </a:pPr>
             <a:r>
-              <a:rPr lang="en-US" sz="1800" b="1" dirty="0">
+              <a:rPr lang="en-US" sz="1550" b="1" dirty="0">
                 <a:solidFill>
                   <a:srgbClr val="2DE2D1"/>
                 </a:solidFill>
@@ -11913,7 +11913,7 @@
               <a:buNone/>
             </a:pPr>
             <a:r>
-              <a:rPr lang="en-US" sz="1800" dirty="0">
+              <a:rPr lang="en-US" sz="1120" dirty="0">
                 <a:solidFill>
                   <a:srgbClr val="A9BED0"/>
                 </a:solidFill>
@@ -11983,7 +11983,7 @@
               <a:buNone/>
             </a:pPr>
             <a:r>
-              <a:rPr lang="en-US" sz="1800" b="1" dirty="0">
+              <a:rPr lang="en-US" sz="1550" b="1" dirty="0">
                 <a:solidFill>
                   <a:srgbClr val="2DE2D1"/>
                 </a:solidFill>
@@ -12024,7 +12024,7 @@
               <a:buNone/>
             </a:pPr>
             <a:r>
-              <a:rPr lang="en-US" sz="1800" dirty="0">
+              <a:rPr lang="en-US" sz="1120" dirty="0">
                 <a:solidFill>
                   <a:srgbClr val="A9BED0"/>
                 </a:solidFill>
@@ -12094,7 +12094,7 @@
               <a:buNone/>
             </a:pPr>
             <a:r>
-              <a:rPr lang="en-US" sz="1800" b="1" dirty="0">
+              <a:rPr lang="en-US" sz="1550" b="1" dirty="0">
                 <a:solidFill>
                   <a:srgbClr val="2DE2D1"/>
                 </a:solidFill>
@@ -12135,7 +12135,7 @@
               <a:buNone/>
             </a:pPr>
             <a:r>
-              <a:rPr lang="en-US" sz="1800" dirty="0">
+              <a:rPr lang="en-US" sz="1120" dirty="0">
                 <a:solidFill>
                   <a:srgbClr val="A9BED0"/>
                 </a:solidFill>
@@ -12205,7 +12205,7 @@
               <a:buNone/>
             </a:pPr>
             <a:r>
-              <a:rPr lang="en-US" sz="1800" b="1" dirty="0">
+              <a:rPr lang="en-US" sz="1550" b="1" dirty="0">
                 <a:solidFill>
                   <a:srgbClr val="2DE2D1"/>
                 </a:solidFill>
@@ -12246,7 +12246,7 @@
               <a:buNone/>
             </a:pPr>
             <a:r>
-              <a:rPr lang="en-US" sz="1800" dirty="0">
+              <a:rPr lang="en-US" sz="1120" dirty="0">
                 <a:solidFill>
                   <a:srgbClr val="A9BED0"/>
                 </a:solidFill>
@@ -12287,7 +12287,7 @@
               <a:buNone/>
             </a:pPr>
             <a:r>
-              <a:rPr lang="en-US" sz="1800" b="1" dirty="0">
+              <a:rPr lang="en-US" sz="1700" b="1" dirty="0">
                 <a:solidFill>
                   <a:srgbClr val="F4F8FB"/>
                 </a:solidFill>
@@ -12537,7 +12537,7 @@
               <a:buNone/>
             </a:pPr>
             <a:r>
-              <a:rPr lang="en-US" sz="1800" dirty="0">
+              <a:rPr lang="en-US" sz="1250" dirty="0">
                 <a:solidFill>
                   <a:srgbClr val="A9BED0"/>
                 </a:solidFill>
@@ -12578,7 +12578,7 @@
               <a:buNone/>
             </a:pPr>
             <a:r>
-              <a:rPr lang="en-US" sz="1800" b="1" dirty="0">
+              <a:rPr lang="en-US" sz="1280" b="1" dirty="0">
                 <a:solidFill>
                   <a:srgbClr val="2DE2D1"/>
                 </a:solidFill>
@@ -12619,7 +12619,7 @@
               <a:buNone/>
             </a:pPr>
             <a:r>
-              <a:rPr lang="en-US" sz="1800" dirty="0">
+              <a:rPr lang="en-US" sz="1160" dirty="0">
                 <a:solidFill>
                   <a:srgbClr val="A9BED0"/>
                 </a:solidFill>
@@ -12660,7 +12660,7 @@
               <a:buNone/>
             </a:pPr>
             <a:r>
-              <a:rPr lang="en-US" sz="1800" dirty="0">
+              <a:rPr lang="en-US" sz="1160" dirty="0">
                 <a:solidFill>
                   <a:srgbClr val="F4F8FB"/>
                 </a:solidFill>
@@ -12726,7 +12726,7 @@
               <a:buNone/>
             </a:pPr>
             <a:r>
-              <a:rPr lang="en-US" sz="1800" b="1" dirty="0">
+              <a:rPr lang="en-US" sz="1280" b="1" dirty="0">
                 <a:solidFill>
                   <a:srgbClr val="2DE2D1"/>
                 </a:solidFill>
@@ -12767,7 +12767,7 @@
               <a:buNone/>
             </a:pPr>
             <a:r>
-              <a:rPr lang="en-US" sz="1800" dirty="0">
+              <a:rPr lang="en-US" sz="1160" dirty="0">
                 <a:solidFill>
                   <a:srgbClr val="A9BED0"/>
                 </a:solidFill>
@@ -12808,7 +12808,7 @@
               <a:buNone/>
             </a:pPr>
             <a:r>
-              <a:rPr lang="en-US" sz="1800" dirty="0">
+              <a:rPr lang="en-US" sz="1160" dirty="0">
                 <a:solidFill>
                   <a:srgbClr val="F4F8FB"/>
                 </a:solidFill>
@@ -12874,7 +12874,7 @@
               <a:buNone/>
             </a:pPr>
             <a:r>
-              <a:rPr lang="en-US" sz="1800" b="1" dirty="0">
+              <a:rPr lang="en-US" sz="1280" b="1" dirty="0">
                 <a:solidFill>
                   <a:srgbClr val="2DE2D1"/>
                 </a:solidFill>
@@ -12915,7 +12915,7 @@
               <a:buNone/>
             </a:pPr>
             <a:r>
-              <a:rPr lang="en-US" sz="1800" dirty="0">
+              <a:rPr lang="en-US" sz="1160" dirty="0">
                 <a:solidFill>
                   <a:srgbClr val="A9BED0"/>
                 </a:solidFill>
@@ -12956,7 +12956,7 @@
               <a:buNone/>
             </a:pPr>
             <a:r>
-              <a:rPr lang="en-US" sz="1800" dirty="0">
+              <a:rPr lang="en-US" sz="1160" dirty="0">
                 <a:solidFill>
                   <a:srgbClr val="F4F8FB"/>
                 </a:solidFill>
@@ -13022,7 +13022,7 @@
               <a:buNone/>
             </a:pPr>
             <a:r>
-              <a:rPr lang="en-US" sz="1800" b="1" dirty="0">
+              <a:rPr lang="en-US" sz="1280" b="1" dirty="0">
                 <a:solidFill>
                   <a:srgbClr val="2DE2D1"/>
                 </a:solidFill>
@@ -13063,7 +13063,7 @@
               <a:buNone/>
             </a:pPr>
             <a:r>
-              <a:rPr lang="en-US" sz="1800" dirty="0">
+              <a:rPr lang="en-US" sz="1160" dirty="0">
                 <a:solidFill>
                   <a:srgbClr val="A9BED0"/>
                 </a:solidFill>
@@ -13104,7 +13104,7 @@
               <a:buNone/>
             </a:pPr>
             <a:r>
-              <a:rPr lang="en-US" sz="1800" dirty="0">
+              <a:rPr lang="en-US" sz="1160" dirty="0">
                 <a:solidFill>
                   <a:srgbClr val="F4F8FB"/>
                 </a:solidFill>
@@ -13170,7 +13170,7 @@
               <a:buNone/>
             </a:pPr>
             <a:r>
-              <a:rPr lang="en-US" sz="1800" b="1" dirty="0">
+              <a:rPr lang="en-US" sz="1280" b="1" dirty="0">
                 <a:solidFill>
                   <a:srgbClr val="2DE2D1"/>
                 </a:solidFill>
@@ -13211,7 +13211,7 @@
               <a:buNone/>
             </a:pPr>
             <a:r>
-              <a:rPr lang="en-US" sz="1800" dirty="0">
+              <a:rPr lang="en-US" sz="1160" dirty="0">
                 <a:solidFill>
                   <a:srgbClr val="A9BED0"/>
                 </a:solidFill>
@@ -13252,7 +13252,7 @@
               <a:buNone/>
             </a:pPr>
             <a:r>
-              <a:rPr lang="en-US" sz="1800" dirty="0">
+              <a:rPr lang="en-US" sz="1160" dirty="0">
                 <a:solidFill>
                   <a:srgbClr val="F4F8FB"/>
                 </a:solidFill>
@@ -13347,7 +13347,7 @@
               <a:buNone/>
             </a:pPr>
             <a:r>
-              <a:rPr lang="en-US" sz="1800" b="1" dirty="0">
+              <a:rPr lang="en-US" sz="1450" b="1" dirty="0">
                 <a:solidFill>
                   <a:srgbClr val="F6C65B"/>
                 </a:solidFill>

</xml_diff>